<commit_message>
docs: distinguish live demo storage and simulated payments
</commit_message>
<xml_diff>
--- a/public/pitch/trustify-pitch.pptx
+++ b/public/pitch/trustify-pitch.pptx
@@ -2,24 +2,24 @@
 <file path=ppt/presentation.xml><?xml version="1.0" encoding="utf-8"?>
 <p:presentation xmlns:p="http://schemas.openxmlformats.org/presentationml/2006/main">
   <p:sldMasterIdLst>
-    <p:sldMasterId xmlns:r="http://schemas.openxmlformats.org/officeDocument/2006/relationships" id="2147483648" r:id="R39af2560490b4058"/>
+    <p:sldMasterId xmlns:r="http://schemas.openxmlformats.org/officeDocument/2006/relationships" id="2147483648" r:id="R0e79cf8b55ad4b21"/>
   </p:sldMasterIdLst>
   <p:notesMasterIdLst>
-    <p:notesMasterId xmlns:r="http://schemas.openxmlformats.org/officeDocument/2006/relationships" r:id="Rc8ed3fd9fcb84635"/>
+    <p:notesMasterId xmlns:r="http://schemas.openxmlformats.org/officeDocument/2006/relationships" r:id="R27dec79570b8423f"/>
   </p:notesMasterIdLst>
   <p:sldIdLst>
-    <p:sldId xmlns:r="http://schemas.openxmlformats.org/officeDocument/2006/relationships" id="256" r:id="R4b19b3317dc84582"/>
-    <p:sldId xmlns:r="http://schemas.openxmlformats.org/officeDocument/2006/relationships" id="257" r:id="R8be21a1d322a4873"/>
-    <p:sldId xmlns:r="http://schemas.openxmlformats.org/officeDocument/2006/relationships" id="258" r:id="R18c5c8506d674669"/>
-    <p:sldId xmlns:r="http://schemas.openxmlformats.org/officeDocument/2006/relationships" id="259" r:id="R95efd26c8d8f4c35"/>
-    <p:sldId xmlns:r="http://schemas.openxmlformats.org/officeDocument/2006/relationships" id="260" r:id="Re803a442977d40b4"/>
-    <p:sldId xmlns:r="http://schemas.openxmlformats.org/officeDocument/2006/relationships" id="261" r:id="R74cb22cd7af34fbb"/>
-    <p:sldId xmlns:r="http://schemas.openxmlformats.org/officeDocument/2006/relationships" id="262" r:id="R7a2ac16e0330459d"/>
-    <p:sldId xmlns:r="http://schemas.openxmlformats.org/officeDocument/2006/relationships" id="263" r:id="R45a7c0238055495f"/>
-    <p:sldId xmlns:r="http://schemas.openxmlformats.org/officeDocument/2006/relationships" id="264" r:id="R322810c0a92b4560"/>
-    <p:sldId xmlns:r="http://schemas.openxmlformats.org/officeDocument/2006/relationships" id="265" r:id="Rc0b9371f4a2f4e46"/>
-    <p:sldId xmlns:r="http://schemas.openxmlformats.org/officeDocument/2006/relationships" id="266" r:id="R869d12a324cc4523"/>
-    <p:sldId xmlns:r="http://schemas.openxmlformats.org/officeDocument/2006/relationships" id="267" r:id="R2d1efdabad394031"/>
+    <p:sldId xmlns:r="http://schemas.openxmlformats.org/officeDocument/2006/relationships" id="256" r:id="Rb6f8f37c25a04df3"/>
+    <p:sldId xmlns:r="http://schemas.openxmlformats.org/officeDocument/2006/relationships" id="257" r:id="R33d3e646551f4f15"/>
+    <p:sldId xmlns:r="http://schemas.openxmlformats.org/officeDocument/2006/relationships" id="258" r:id="R26894316ff7146c3"/>
+    <p:sldId xmlns:r="http://schemas.openxmlformats.org/officeDocument/2006/relationships" id="259" r:id="Rfe609679e0ac4043"/>
+    <p:sldId xmlns:r="http://schemas.openxmlformats.org/officeDocument/2006/relationships" id="260" r:id="R6d61e8fcf0d6486e"/>
+    <p:sldId xmlns:r="http://schemas.openxmlformats.org/officeDocument/2006/relationships" id="261" r:id="R91ebb2f3f73c4403"/>
+    <p:sldId xmlns:r="http://schemas.openxmlformats.org/officeDocument/2006/relationships" id="262" r:id="Re1de6e1c6d754dcc"/>
+    <p:sldId xmlns:r="http://schemas.openxmlformats.org/officeDocument/2006/relationships" id="263" r:id="Rdd05f281ff854ff8"/>
+    <p:sldId xmlns:r="http://schemas.openxmlformats.org/officeDocument/2006/relationships" id="264" r:id="R1922a7aa28f14ec2"/>
+    <p:sldId xmlns:r="http://schemas.openxmlformats.org/officeDocument/2006/relationships" id="265" r:id="R06f4a867542f40eb"/>
+    <p:sldId xmlns:r="http://schemas.openxmlformats.org/officeDocument/2006/relationships" id="266" r:id="R16398b599f1841f8"/>
+    <p:sldId xmlns:r="http://schemas.openxmlformats.org/officeDocument/2006/relationships" id="267" r:id="R77f30fc79c0146e7"/>
   </p:sldIdLst>
   <p:sldSz cx="12192000" cy="6858000"/>
   <p:notesSz cx="6858000" cy="9144000"/>
@@ -663,7 +663,7 @@
           <a:lstStyle xmlns:a="http://schemas.openxmlformats.org/drawingml/2006/main"/>
           <a:p xmlns:a="http://schemas.openxmlformats.org/drawingml/2006/main">
             <a:r>
-              <a:t>Call to action proposes discussions with licensed notary offices and product/security reviewers. No existing partnerships or endorsements implied. Demo: https://trustify-notary.vercel.app. Contact: https://www.linkedin.com/in/sloweyne/. Source: https://github.com/sloweyyy/Trustify-Frontend and https://github.com/sloweyyy/Trustify-Backend. Deck updated25October2026.</a:t>
+              <a:t>Call to action proposes discussions with licensed notary offices and product/security reviewers. No existing partnerships or endorsements implied. Demo: https://trustify-notary.vercel.app. Contact: https://www.linkedin.com/in/sloweyne/. Source: https://github.com/sloweyyy/Trustify-Frontend and https://github.com/sloweyyy/Trustify-Backend. The current public demo simulates payments and uses Supabase Storage. Maintainer configuration check: https://github.com/sloweyyy/Trustify-Frontend/pull/50. Deck updated25October2026.</a:t>
             </a:r>
           </a:p>
         </p:txBody>
@@ -1083,7 +1083,7 @@
           <a:lstStyle xmlns:a="http://schemas.openxmlformats.org/drawingml/2006/main"/>
           <a:p xmlns:a="http://schemas.openxmlformats.org/drawingml/2006/main">
             <a:r>
-              <a:t>Blockchain implementation: https://github.com/sloweyyy/Trustify-Backend/blob/main/src/config/blockchain.js and src/services/notarization.service.js. Verification UI: https://github.com/sloweyyy/Trustify-Frontend/blob/main/docs/design/screenshots/final/states/public-verify-record-desktop.png. Files are uploaded off-chain to IPFS/Pinata and metadata references are minted on Solana devnet. NFT possession/metadata is not proof of legal validity or complete confidentiality.</a:t>
+              <a:t>Blockchain implementation: https://github.com/sloweyyy/Trustify-Backend/blob/main/src/config/blockchain.js and src/services/notarization.service.js. Verification UI: https://github.com/sloweyyy/Trustify-Frontend/blob/main/docs/design/screenshots/final/states/public-verify-record-desktop.png. The public demo stores files and metadata in Supabase Storage. IPFS/Pinata pinning is supported in code. Metadata references are minted on Solana devnet. Live-demo configuration verified by the maintainer in https://github.com/sloweyyy/Trustify-Frontend/pull/50. NFT possession/metadata is not proof of legal validity or complete confidentiality.</a:t>
             </a:r>
           </a:p>
         </p:txBody>
@@ -1153,7 +1153,7 @@
           <a:lstStyle xmlns:a="http://schemas.openxmlformats.org/drawingml/2006/main"/>
           <a:p xmlns:a="http://schemas.openxmlformats.org/drawingml/2006/main">
             <a:r>
-              <a:t>Verified against frontend package.json/README and backend package.json, src/config/blockchain.js, src/services/chatbot.service.js and src/services/payment.service.js. Source: https://github.com/sloweyyy/Trustify-Frontend and https://github.com/sloweyyy/Trustify-Backend. Gemini supplies procedural guidance, not implemented document generation. PayOS is the implemented payment gateway, not crypto checkout.</a:t>
+              <a:t>Verified against frontend package.json/README and backend package.json, src/config/blockchain.js, src/services/chatbot.service.js and src/services/payment.service.js. Source: https://github.com/sloweyyy/Trustify-Frontend and https://github.com/sloweyyy/Trustify-Backend. Gemini supplies procedural guidance, not implemented document generation. PayOS is the supported payment integration. The current public demo simulates payments, as verified by the maintainer in https://github.com/sloweyyy/Trustify-Frontend/pull/50. The demo uses Supabase Storage for files/metadata, with IPFS/Pinata support in code.</a:t>
             </a:r>
           </a:p>
         </p:txBody>
@@ -1270,7 +1270,7 @@
           <p:cNvPr id="3" name="Title">
             <a:extLst xmlns:a="http://schemas.openxmlformats.org/drawingml/2006/main">
               <a:ext uri="{FF2B5EF4-FFF2-40B4-BE49-F238E27FC236}">
-                <a16:creationId xmlns:a16="http://schemas.microsoft.com/office/drawing/2014/main" id="{BD9CCF2A-A17E-4EF6-9126-B10885B0C3EF}"/>
+                <a16:creationId xmlns:a16="http://schemas.microsoft.com/office/drawing/2014/main" id="{699EA64F-7F90-4C51-8314-9FFC025A3963}"/>
               </a:ext>
             </a:extLst>
           </p:cNvPr>
@@ -1499,7 +1499,7 @@
           <p:cNvPr id="2" name="Subtitle">
             <a:extLst xmlns:a="http://schemas.openxmlformats.org/drawingml/2006/main">
               <a:ext uri="{FF2B5EF4-FFF2-40B4-BE49-F238E27FC236}">
-                <a16:creationId xmlns:a16="http://schemas.microsoft.com/office/drawing/2014/main" id="{BAF274FB-EBEC-4C34-A2AF-79BDAACD79B5}"/>
+                <a16:creationId xmlns:a16="http://schemas.microsoft.com/office/drawing/2014/main" id="{D121FBFF-B982-44BC-B4F8-7AFCC4D4660B}"/>
               </a:ext>
             </a:extLst>
           </p:cNvPr>
@@ -1745,7 +1745,7 @@
           <p:cNvPr id="2" name="Section title">
             <a:extLst xmlns:a="http://schemas.openxmlformats.org/drawingml/2006/main">
               <a:ext uri="{FF2B5EF4-FFF2-40B4-BE49-F238E27FC236}">
-                <a16:creationId xmlns:a16="http://schemas.microsoft.com/office/drawing/2014/main" id="{0256BF64-1018-4549-87CD-48652E3C07F4}"/>
+                <a16:creationId xmlns:a16="http://schemas.microsoft.com/office/drawing/2014/main" id="{44FDA90C-F65D-4425-A52A-CEE5E71209DE}"/>
               </a:ext>
             </a:extLst>
           </p:cNvPr>
@@ -1991,7 +1991,7 @@
           <p:cNvPr id="3" name="Title">
             <a:extLst xmlns:a="http://schemas.openxmlformats.org/drawingml/2006/main">
               <a:ext uri="{FF2B5EF4-FFF2-40B4-BE49-F238E27FC236}">
-                <a16:creationId xmlns:a16="http://schemas.microsoft.com/office/drawing/2014/main" id="{45EDD006-9D1D-4AF0-92D4-564D972FE535}"/>
+                <a16:creationId xmlns:a16="http://schemas.microsoft.com/office/drawing/2014/main" id="{BFFCD74B-F0BE-4A36-850B-11435E45B045}"/>
               </a:ext>
             </a:extLst>
           </p:cNvPr>
@@ -2220,7 +2220,7 @@
           <p:cNvPr id="2" name="Body">
             <a:extLst xmlns:a="http://schemas.openxmlformats.org/drawingml/2006/main">
               <a:ext uri="{FF2B5EF4-FFF2-40B4-BE49-F238E27FC236}">
-                <a16:creationId xmlns:a16="http://schemas.microsoft.com/office/drawing/2014/main" id="{6B8AFE06-9671-4C4B-931F-AAE6B52B9AF5}"/>
+                <a16:creationId xmlns:a16="http://schemas.microsoft.com/office/drawing/2014/main" id="{B901BCE0-D499-4B99-A599-3F7E0A8DCB02}"/>
               </a:ext>
             </a:extLst>
           </p:cNvPr>
@@ -2466,7 +2466,7 @@
           <p:cNvPr id="4" name="Title">
             <a:extLst xmlns:a="http://schemas.openxmlformats.org/drawingml/2006/main">
               <a:ext uri="{FF2B5EF4-FFF2-40B4-BE49-F238E27FC236}">
-                <a16:creationId xmlns:a16="http://schemas.microsoft.com/office/drawing/2014/main" id="{686F02F1-D15E-42D8-8AF3-0CBB50213CB0}"/>
+                <a16:creationId xmlns:a16="http://schemas.microsoft.com/office/drawing/2014/main" id="{50882001-4222-4386-9AC7-194317571D75}"/>
               </a:ext>
             </a:extLst>
           </p:cNvPr>
@@ -2695,7 +2695,7 @@
           <p:cNvPr id="2" name="Left column">
             <a:extLst xmlns:a="http://schemas.openxmlformats.org/drawingml/2006/main">
               <a:ext uri="{FF2B5EF4-FFF2-40B4-BE49-F238E27FC236}">
-                <a16:creationId xmlns:a16="http://schemas.microsoft.com/office/drawing/2014/main" id="{F7B14FB0-48BF-42F4-92C5-9BDCF5DCBAEB}"/>
+                <a16:creationId xmlns:a16="http://schemas.microsoft.com/office/drawing/2014/main" id="{8AA9071A-B1BE-4EF7-8034-AB256E62CA9E}"/>
               </a:ext>
             </a:extLst>
           </p:cNvPr>
@@ -2924,7 +2924,7 @@
           <p:cNvPr id="3" name="Right column">
             <a:extLst xmlns:a="http://schemas.openxmlformats.org/drawingml/2006/main">
               <a:ext uri="{FF2B5EF4-FFF2-40B4-BE49-F238E27FC236}">
-                <a16:creationId xmlns:a16="http://schemas.microsoft.com/office/drawing/2014/main" id="{544070C1-D437-4867-A4A2-FE71A19914CA}"/>
+                <a16:creationId xmlns:a16="http://schemas.microsoft.com/office/drawing/2014/main" id="{EEAA6425-1B2C-4053-BD05-45F0C65705AB}"/>
               </a:ext>
             </a:extLst>
           </p:cNvPr>
@@ -3170,7 +3170,7 @@
           <p:cNvPr id="3" name="Title">
             <a:extLst xmlns:a="http://schemas.openxmlformats.org/drawingml/2006/main">
               <a:ext uri="{FF2B5EF4-FFF2-40B4-BE49-F238E27FC236}">
-                <a16:creationId xmlns:a16="http://schemas.microsoft.com/office/drawing/2014/main" id="{6376FEE4-7C36-4419-AE75-774AF6F886E3}"/>
+                <a16:creationId xmlns:a16="http://schemas.microsoft.com/office/drawing/2014/main" id="{83A0F751-A0DA-4D22-AD6D-9CD316AE09BD}"/>
               </a:ext>
             </a:extLst>
           </p:cNvPr>
@@ -3399,7 +3399,7 @@
           <p:cNvPr id="2" name="Left column">
             <a:extLst xmlns:a="http://schemas.openxmlformats.org/drawingml/2006/main">
               <a:ext uri="{FF2B5EF4-FFF2-40B4-BE49-F238E27FC236}">
-                <a16:creationId xmlns:a16="http://schemas.microsoft.com/office/drawing/2014/main" id="{D6766D27-6CE1-4145-9681-9346D1E58B1C}"/>
+                <a16:creationId xmlns:a16="http://schemas.microsoft.com/office/drawing/2014/main" id="{5AE9946E-0B09-4713-BCC2-91C4D8EDBB2D}"/>
               </a:ext>
             </a:extLst>
           </p:cNvPr>
@@ -3666,12 +3666,12 @@
   </p:cSld>
   <p:clrMap bg1="lt1" tx1="dk1" bg2="lt2" tx2="dk2" accent1="accent1" accent2="accent2" accent3="accent3" accent4="accent4" accent5="accent5" accent6="accent6" hlink="hlink" folHlink="folHlink"/>
   <p:sldLayoutIdLst>
-    <p:sldLayoutId xmlns:r="http://schemas.openxmlformats.org/officeDocument/2006/relationships" id="2147483649" r:id="Rdf1c2a7d3b6c4cdb"/>
-    <p:sldLayoutId xmlns:r="http://schemas.openxmlformats.org/officeDocument/2006/relationships" id="2147483650" r:id="R076f7a793bbf41f9"/>
-    <p:sldLayoutId xmlns:r="http://schemas.openxmlformats.org/officeDocument/2006/relationships" id="2147483651" r:id="R33f0eb1b5b4e4090"/>
-    <p:sldLayoutId xmlns:r="http://schemas.openxmlformats.org/officeDocument/2006/relationships" id="2147483652" r:id="R3e559156601f4c70"/>
-    <p:sldLayoutId xmlns:r="http://schemas.openxmlformats.org/officeDocument/2006/relationships" id="2147483653" r:id="Rf381511bb5e642f8"/>
-    <p:sldLayoutId xmlns:r="http://schemas.openxmlformats.org/officeDocument/2006/relationships" id="2147483654" r:id="R636e4d5300ce419c"/>
+    <p:sldLayoutId xmlns:r="http://schemas.openxmlformats.org/officeDocument/2006/relationships" id="2147483649" r:id="Rb002474a746c4769"/>
+    <p:sldLayoutId xmlns:r="http://schemas.openxmlformats.org/officeDocument/2006/relationships" id="2147483650" r:id="Reafe9b5bf9c84716"/>
+    <p:sldLayoutId xmlns:r="http://schemas.openxmlformats.org/officeDocument/2006/relationships" id="2147483651" r:id="Rb19bc67969594272"/>
+    <p:sldLayoutId xmlns:r="http://schemas.openxmlformats.org/officeDocument/2006/relationships" id="2147483652" r:id="R68fb8bd9e4974a95"/>
+    <p:sldLayoutId xmlns:r="http://schemas.openxmlformats.org/officeDocument/2006/relationships" id="2147483653" r:id="Rd33438a829ab436c"/>
+    <p:sldLayoutId xmlns:r="http://schemas.openxmlformats.org/officeDocument/2006/relationships" id="2147483654" r:id="Rcdac3e41dc2f4357"/>
   </p:sldLayoutIdLst>
   <p:txStyles>
     <p:titleStyle>
@@ -4222,7 +4222,7 @@
           <p:cNvPr id="7" name="">
             <a:extLst xmlns:a="http://schemas.openxmlformats.org/drawingml/2006/main">
               <a:ext uri="{FF2B5EF4-FFF2-40B4-BE49-F238E27FC236}">
-                <a16:creationId xmlns:a16="http://schemas.microsoft.com/office/drawing/2014/main" id="{24C6276B-5493-41D2-883A-EA031F2021DD}"/>
+                <a16:creationId xmlns:a16="http://schemas.microsoft.com/office/drawing/2014/main" id="{9FBE619B-5DD1-48EA-8A18-ECEBD65A9BFA}"/>
               </a:ext>
             </a:extLst>
           </p:cNvPr>
@@ -4232,10 +4232,10 @@
           <p:nvPr/>
         </p:nvPicPr>
         <p:blipFill>
-          <a:blip xmlns:r="http://schemas.openxmlformats.org/officeDocument/2006/relationships" xmlns:a="http://schemas.openxmlformats.org/drawingml/2006/main" r:embed="R6dd0fd3a8acf4980">
+          <a:blip xmlns:r="http://schemas.openxmlformats.org/officeDocument/2006/relationships" xmlns:a="http://schemas.openxmlformats.org/drawingml/2006/main" r:embed="R11b7c8cf56b54d0a">
             <a:extLst>
               <a:ext uri="{96DAC541-7B7A-43D3-8B79-37D633B846F1}">
-                <asvg:svgBlip xmlns:asvg="http://schemas.microsoft.com/office/drawing/2016/SVG/main" r:embed="Rd6e650ec409241f2"/>
+                <asvg:svgBlip xmlns:asvg="http://schemas.microsoft.com/office/drawing/2016/SVG/main" r:embed="Rfda0b987cd9a4311"/>
               </a:ext>
             </a:extLst>
           </a:blip>
@@ -4256,7 +4256,7 @@
           <p:cNvPr id="2" name="page">
             <a:extLst xmlns:a="http://schemas.openxmlformats.org/drawingml/2006/main">
               <a:ext uri="{FF2B5EF4-FFF2-40B4-BE49-F238E27FC236}">
-                <a16:creationId xmlns:a16="http://schemas.microsoft.com/office/drawing/2014/main" id="{B129955E-698D-49E6-9315-672846C1B73A}"/>
+                <a16:creationId xmlns:a16="http://schemas.microsoft.com/office/drawing/2014/main" id="{401AD806-996B-41A0-9067-40DB6CFA6F46}"/>
               </a:ext>
             </a:extLst>
           </p:cNvPr>
@@ -4412,7 +4412,7 @@
           <p:cNvPr id="3" name="title">
             <a:extLst xmlns:a="http://schemas.openxmlformats.org/drawingml/2006/main">
               <a:ext uri="{FF2B5EF4-FFF2-40B4-BE49-F238E27FC236}">
-                <a16:creationId xmlns:a16="http://schemas.microsoft.com/office/drawing/2014/main" id="{9120E431-7563-4183-80FC-AB63D147CEE6}"/>
+                <a16:creationId xmlns:a16="http://schemas.microsoft.com/office/drawing/2014/main" id="{DC53EAAF-FC4D-4697-8F86-21B3EAE37595}"/>
               </a:ext>
             </a:extLst>
           </p:cNvPr>
@@ -4628,7 +4628,7 @@
           <p:cNvPr id="4" name="body">
             <a:extLst xmlns:a="http://schemas.openxmlformats.org/drawingml/2006/main">
               <a:ext uri="{FF2B5EF4-FFF2-40B4-BE49-F238E27FC236}">
-                <a16:creationId xmlns:a16="http://schemas.microsoft.com/office/drawing/2014/main" id="{51BEFC86-4B8F-4E65-89F5-C3D9C1B55F1C}"/>
+                <a16:creationId xmlns:a16="http://schemas.microsoft.com/office/drawing/2014/main" id="{5BC1DC0E-F9C5-4EA3-94A2-1B2EBF9861BA}"/>
               </a:ext>
             </a:extLst>
           </p:cNvPr>
@@ -4817,7 +4817,7 @@
           <p:cNvPr id="5" name="body">
             <a:extLst xmlns:a="http://schemas.openxmlformats.org/drawingml/2006/main">
               <a:ext uri="{FF2B5EF4-FFF2-40B4-BE49-F238E27FC236}">
-                <a16:creationId xmlns:a16="http://schemas.microsoft.com/office/drawing/2014/main" id="{8CC44245-3DBB-4611-AA6E-907691CD4A26}"/>
+                <a16:creationId xmlns:a16="http://schemas.microsoft.com/office/drawing/2014/main" id="{65DBCED9-A3C3-4D2C-AFE7-3648B105A966}"/>
               </a:ext>
             </a:extLst>
           </p:cNvPr>
@@ -5006,7 +5006,7 @@
           <p:cNvPr id="6" name="">
             <a:extLst xmlns:a="http://schemas.openxmlformats.org/drawingml/2006/main">
               <a:ext uri="{FF2B5EF4-FFF2-40B4-BE49-F238E27FC236}">
-                <a16:creationId xmlns:a16="http://schemas.microsoft.com/office/drawing/2014/main" id="{DE7FFC7B-69E1-42FC-B37D-6EE6982010E6}"/>
+                <a16:creationId xmlns:a16="http://schemas.microsoft.com/office/drawing/2014/main" id="{2E1AC8A9-8795-45F6-9522-77B44B35F271}"/>
               </a:ext>
             </a:extLst>
           </p:cNvPr>
@@ -5016,7 +5016,7 @@
           <p:nvPr/>
         </p:nvPicPr>
         <p:blipFill>
-          <a:blip xmlns:r="http://schemas.openxmlformats.org/officeDocument/2006/relationships" xmlns:a="http://schemas.openxmlformats.org/drawingml/2006/main" r:embed="R278a38571523445d"/>
+          <a:blip xmlns:r="http://schemas.openxmlformats.org/officeDocument/2006/relationships" xmlns:a="http://schemas.openxmlformats.org/drawingml/2006/main" r:embed="Rffde4868e8a049fe"/>
           <a:stretch xmlns:a="http://schemas.openxmlformats.org/drawingml/2006/main"/>
         </p:blipFill>
         <p:spPr>
@@ -5032,7 +5032,7 @@
     </p:spTree>
     <p:extLst>
       <p:ext uri="{BB962C8B-B14F-4D97-AF65-F5344CB8AC3E}">
-        <p14:creationId xmlns:p14="http://schemas.microsoft.com/office/powerpoint/2010/main" val="1496176949"/>
+        <p14:creationId xmlns:p14="http://schemas.microsoft.com/office/powerpoint/2010/main" val="552849572"/>
       </p:ext>
     </p:extLst>
   </p:cSld>
@@ -5063,7 +5063,7 @@
           <p:cNvPr id="10" name="">
             <a:extLst xmlns:a="http://schemas.openxmlformats.org/drawingml/2006/main">
               <a:ext uri="{FF2B5EF4-FFF2-40B4-BE49-F238E27FC236}">
-                <a16:creationId xmlns:a16="http://schemas.microsoft.com/office/drawing/2014/main" id="{14D436DE-C111-4BEA-B57C-4E6364FB4DD9}"/>
+                <a16:creationId xmlns:a16="http://schemas.microsoft.com/office/drawing/2014/main" id="{64F8859B-E830-46CB-A7F3-0970DD7A472C}"/>
               </a:ext>
             </a:extLst>
           </p:cNvPr>
@@ -5073,10 +5073,10 @@
           <p:nvPr/>
         </p:nvPicPr>
         <p:blipFill>
-          <a:blip xmlns:r="http://schemas.openxmlformats.org/officeDocument/2006/relationships" xmlns:a="http://schemas.openxmlformats.org/drawingml/2006/main" r:embed="R02270c1a0e9d473d">
+          <a:blip xmlns:r="http://schemas.openxmlformats.org/officeDocument/2006/relationships" xmlns:a="http://schemas.openxmlformats.org/drawingml/2006/main" r:embed="R4de3adb746eb4e8d">
             <a:extLst>
               <a:ext uri="{96DAC541-7B7A-43D3-8B79-37D633B846F1}">
-                <asvg:svgBlip xmlns:asvg="http://schemas.microsoft.com/office/drawing/2016/SVG/main" r:embed="Rb8fcf3860eb943e3"/>
+                <asvg:svgBlip xmlns:asvg="http://schemas.microsoft.com/office/drawing/2016/SVG/main" r:embed="Rd0c5423e34c54705"/>
               </a:ext>
             </a:extLst>
           </a:blip>
@@ -5097,7 +5097,7 @@
           <p:cNvPr id="2" name="title">
             <a:extLst xmlns:a="http://schemas.openxmlformats.org/drawingml/2006/main">
               <a:ext uri="{FF2B5EF4-FFF2-40B4-BE49-F238E27FC236}">
-                <a16:creationId xmlns:a16="http://schemas.microsoft.com/office/drawing/2014/main" id="{EE9E3590-9F4F-478B-A15E-0E63FD5CE630}"/>
+                <a16:creationId xmlns:a16="http://schemas.microsoft.com/office/drawing/2014/main" id="{BBA63D27-A774-486D-B5BC-517C3630AC6C}"/>
               </a:ext>
             </a:extLst>
           </p:cNvPr>
@@ -5259,7 +5259,7 @@
           <p:cNvPr id="3" name="body">
             <a:extLst xmlns:a="http://schemas.openxmlformats.org/drawingml/2006/main">
               <a:ext uri="{FF2B5EF4-FFF2-40B4-BE49-F238E27FC236}">
-                <a16:creationId xmlns:a16="http://schemas.microsoft.com/office/drawing/2014/main" id="{0AA2F9B3-4FF9-40D1-BD85-390A97B7D49C}"/>
+                <a16:creationId xmlns:a16="http://schemas.microsoft.com/office/drawing/2014/main" id="{66706AA4-7DD1-4036-8E03-E1A53546155E}"/>
               </a:ext>
             </a:extLst>
           </p:cNvPr>
@@ -5421,7 +5421,7 @@
           <p:cNvPr id="4" name="page">
             <a:extLst xmlns:a="http://schemas.openxmlformats.org/drawingml/2006/main">
               <a:ext uri="{FF2B5EF4-FFF2-40B4-BE49-F238E27FC236}">
-                <a16:creationId xmlns:a16="http://schemas.microsoft.com/office/drawing/2014/main" id="{2CD9596F-FDD6-497B-990C-5A01C21C5EC3}"/>
+                <a16:creationId xmlns:a16="http://schemas.microsoft.com/office/drawing/2014/main" id="{1771EA89-5982-4B62-9878-CDACD97B8AF4}"/>
               </a:ext>
             </a:extLst>
           </p:cNvPr>
@@ -5577,7 +5577,7 @@
           <p:cNvPr id="5" name="body">
             <a:extLst xmlns:a="http://schemas.openxmlformats.org/drawingml/2006/main">
               <a:ext uri="{FF2B5EF4-FFF2-40B4-BE49-F238E27FC236}">
-                <a16:creationId xmlns:a16="http://schemas.microsoft.com/office/drawing/2014/main" id="{BD3D4E04-37EA-4A24-B86D-3E89A6932E9A}"/>
+                <a16:creationId xmlns:a16="http://schemas.microsoft.com/office/drawing/2014/main" id="{A72FF149-5292-4C55-8E73-B85484515640}"/>
               </a:ext>
             </a:extLst>
           </p:cNvPr>
@@ -5739,7 +5739,7 @@
           <p:cNvPr id="6" name="body">
             <a:extLst xmlns:a="http://schemas.openxmlformats.org/drawingml/2006/main">
               <a:ext uri="{FF2B5EF4-FFF2-40B4-BE49-F238E27FC236}">
-                <a16:creationId xmlns:a16="http://schemas.microsoft.com/office/drawing/2014/main" id="{335DC8AA-7B52-4C38-81FB-6205053C0E1C}"/>
+                <a16:creationId xmlns:a16="http://schemas.microsoft.com/office/drawing/2014/main" id="{A3CF780B-9E9E-476C-BDE0-CE8874328A93}"/>
               </a:ext>
             </a:extLst>
           </p:cNvPr>
@@ -5901,7 +5901,7 @@
           <p:cNvPr id="7" name="body">
             <a:extLst xmlns:a="http://schemas.openxmlformats.org/drawingml/2006/main">
               <a:ext uri="{FF2B5EF4-FFF2-40B4-BE49-F238E27FC236}">
-                <a16:creationId xmlns:a16="http://schemas.microsoft.com/office/drawing/2014/main" id="{B6EA92C7-C98E-4689-8E46-3CB9D759A6F2}"/>
+                <a16:creationId xmlns:a16="http://schemas.microsoft.com/office/drawing/2014/main" id="{3B091675-8D79-42A6-BF39-D85EAA27F36E}"/>
               </a:ext>
             </a:extLst>
           </p:cNvPr>
@@ -6063,7 +6063,7 @@
           <p:cNvPr id="8" name="body">
             <a:extLst xmlns:a="http://schemas.openxmlformats.org/drawingml/2006/main">
               <a:ext uri="{FF2B5EF4-FFF2-40B4-BE49-F238E27FC236}">
-                <a16:creationId xmlns:a16="http://schemas.microsoft.com/office/drawing/2014/main" id="{C56C781E-102D-471D-BD20-198CD21E4177}"/>
+                <a16:creationId xmlns:a16="http://schemas.microsoft.com/office/drawing/2014/main" id="{C1D29B11-094E-4583-BA05-EEAA131D5D6C}"/>
               </a:ext>
             </a:extLst>
           </p:cNvPr>
@@ -6225,7 +6225,7 @@
           <p:cNvPr id="9" name="source-note">
             <a:extLst xmlns:a="http://schemas.openxmlformats.org/drawingml/2006/main">
               <a:ext uri="{FF2B5EF4-FFF2-40B4-BE49-F238E27FC236}">
-                <a16:creationId xmlns:a16="http://schemas.microsoft.com/office/drawing/2014/main" id="{8B08E316-68EC-4A0F-8A28-CECB8032E942}"/>
+                <a16:creationId xmlns:a16="http://schemas.microsoft.com/office/drawing/2014/main" id="{54208891-9E09-4C49-A736-CF66BA682F32}"/>
               </a:ext>
             </a:extLst>
           </p:cNvPr>
@@ -6385,7 +6385,7 @@
     </p:spTree>
     <p:extLst>
       <p:ext uri="{BB962C8B-B14F-4D97-AF65-F5344CB8AC3E}">
-        <p14:creationId xmlns:p14="http://schemas.microsoft.com/office/powerpoint/2010/main" val="1007423205"/>
+        <p14:creationId xmlns:p14="http://schemas.microsoft.com/office/powerpoint/2010/main" val="98413026"/>
       </p:ext>
     </p:extLst>
   </p:cSld>
@@ -6416,7 +6416,7 @@
           <p:cNvPr id="14" name="">
             <a:extLst xmlns:a="http://schemas.openxmlformats.org/drawingml/2006/main">
               <a:ext uri="{FF2B5EF4-FFF2-40B4-BE49-F238E27FC236}">
-                <a16:creationId xmlns:a16="http://schemas.microsoft.com/office/drawing/2014/main" id="{A1003167-4931-4F65-9C52-62D33362F2B3}"/>
+                <a16:creationId xmlns:a16="http://schemas.microsoft.com/office/drawing/2014/main" id="{F4E8D548-49EA-4245-8F39-34A28A4345A4}"/>
               </a:ext>
             </a:extLst>
           </p:cNvPr>
@@ -6426,10 +6426,10 @@
           <p:nvPr/>
         </p:nvPicPr>
         <p:blipFill>
-          <a:blip xmlns:r="http://schemas.openxmlformats.org/officeDocument/2006/relationships" xmlns:a="http://schemas.openxmlformats.org/drawingml/2006/main" r:embed="Rc10e2fcc32224dc5">
+          <a:blip xmlns:r="http://schemas.openxmlformats.org/officeDocument/2006/relationships" xmlns:a="http://schemas.openxmlformats.org/drawingml/2006/main" r:embed="R5d7c6c93870e4591">
             <a:extLst>
               <a:ext uri="{96DAC541-7B7A-43D3-8B79-37D633B846F1}">
-                <asvg:svgBlip xmlns:asvg="http://schemas.microsoft.com/office/drawing/2016/SVG/main" r:embed="R6acf40bddba4411e"/>
+                <asvg:svgBlip xmlns:asvg="http://schemas.microsoft.com/office/drawing/2016/SVG/main" r:embed="R73af28bc109e49ff"/>
               </a:ext>
             </a:extLst>
           </a:blip>
@@ -6450,7 +6450,7 @@
           <p:cNvPr id="2" name="title">
             <a:extLst xmlns:a="http://schemas.openxmlformats.org/drawingml/2006/main">
               <a:ext uri="{FF2B5EF4-FFF2-40B4-BE49-F238E27FC236}">
-                <a16:creationId xmlns:a16="http://schemas.microsoft.com/office/drawing/2014/main" id="{D69449AE-EC41-49AB-B754-75D174A2F84A}"/>
+                <a16:creationId xmlns:a16="http://schemas.microsoft.com/office/drawing/2014/main" id="{BE81FB77-4E8A-4C66-AB5C-EA36A4F06DA9}"/>
               </a:ext>
             </a:extLst>
           </p:cNvPr>
@@ -6612,7 +6612,7 @@
           <p:cNvPr id="3" name="page">
             <a:extLst xmlns:a="http://schemas.openxmlformats.org/drawingml/2006/main">
               <a:ext uri="{FF2B5EF4-FFF2-40B4-BE49-F238E27FC236}">
-                <a16:creationId xmlns:a16="http://schemas.microsoft.com/office/drawing/2014/main" id="{22B0F046-B0D6-46E6-973A-7EEF6A2810CD}"/>
+                <a16:creationId xmlns:a16="http://schemas.microsoft.com/office/drawing/2014/main" id="{9DF30089-AEEC-4B11-A190-2055F98DD72F}"/>
               </a:ext>
             </a:extLst>
           </p:cNvPr>
@@ -6768,7 +6768,7 @@
           <p:cNvPr id="4" name="body">
             <a:extLst xmlns:a="http://schemas.openxmlformats.org/drawingml/2006/main">
               <a:ext uri="{FF2B5EF4-FFF2-40B4-BE49-F238E27FC236}">
-                <a16:creationId xmlns:a16="http://schemas.microsoft.com/office/drawing/2014/main" id="{B0A9D3ED-A7C1-4265-B281-D8DDAE711B52}"/>
+                <a16:creationId xmlns:a16="http://schemas.microsoft.com/office/drawing/2014/main" id="{6F7BFBD1-15BE-433C-8CB2-8375E820EF46}"/>
               </a:ext>
             </a:extLst>
           </p:cNvPr>
@@ -6930,7 +6930,7 @@
           <p:cNvPr id="5" name="body">
             <a:extLst xmlns:a="http://schemas.openxmlformats.org/drawingml/2006/main">
               <a:ext uri="{FF2B5EF4-FFF2-40B4-BE49-F238E27FC236}">
-                <a16:creationId xmlns:a16="http://schemas.microsoft.com/office/drawing/2014/main" id="{9703DEF3-1509-4782-BC58-358667274B94}"/>
+                <a16:creationId xmlns:a16="http://schemas.microsoft.com/office/drawing/2014/main" id="{6DD76752-FE0A-4393-AF46-340404741F92}"/>
               </a:ext>
             </a:extLst>
           </p:cNvPr>
@@ -7092,7 +7092,7 @@
           <p:cNvPr id="6" name="body">
             <a:extLst xmlns:a="http://schemas.openxmlformats.org/drawingml/2006/main">
               <a:ext uri="{FF2B5EF4-FFF2-40B4-BE49-F238E27FC236}">
-                <a16:creationId xmlns:a16="http://schemas.microsoft.com/office/drawing/2014/main" id="{14AC07B8-3345-4130-B562-11CECC7A63E2}"/>
+                <a16:creationId xmlns:a16="http://schemas.microsoft.com/office/drawing/2014/main" id="{CED7C219-E5CD-44F3-9880-4A4C04A37366}"/>
               </a:ext>
             </a:extLst>
           </p:cNvPr>
@@ -7254,7 +7254,7 @@
           <p:cNvPr id="7" name="body">
             <a:extLst xmlns:a="http://schemas.openxmlformats.org/drawingml/2006/main">
               <a:ext uri="{FF2B5EF4-FFF2-40B4-BE49-F238E27FC236}">
-                <a16:creationId xmlns:a16="http://schemas.microsoft.com/office/drawing/2014/main" id="{E637C18B-FA27-4861-A0DE-09EC73BECD4D}"/>
+                <a16:creationId xmlns:a16="http://schemas.microsoft.com/office/drawing/2014/main" id="{5F601409-955F-4714-9CF3-EF0F1998ED2C}"/>
               </a:ext>
             </a:extLst>
           </p:cNvPr>
@@ -7416,7 +7416,7 @@
           <p:cNvPr id="8" name="body">
             <a:extLst xmlns:a="http://schemas.openxmlformats.org/drawingml/2006/main">
               <a:ext uri="{FF2B5EF4-FFF2-40B4-BE49-F238E27FC236}">
-                <a16:creationId xmlns:a16="http://schemas.microsoft.com/office/drawing/2014/main" id="{C4A0AC33-9328-46B2-AECE-E56BB602B527}"/>
+                <a16:creationId xmlns:a16="http://schemas.microsoft.com/office/drawing/2014/main" id="{76A59AA5-E52E-4BAC-ABFF-A146D153C469}"/>
               </a:ext>
             </a:extLst>
           </p:cNvPr>
@@ -7578,7 +7578,7 @@
           <p:cNvPr id="9" name="body">
             <a:extLst xmlns:a="http://schemas.openxmlformats.org/drawingml/2006/main">
               <a:ext uri="{FF2B5EF4-FFF2-40B4-BE49-F238E27FC236}">
-                <a16:creationId xmlns:a16="http://schemas.microsoft.com/office/drawing/2014/main" id="{0E0763B2-61B6-4BFC-B118-CE5E83F56BF1}"/>
+                <a16:creationId xmlns:a16="http://schemas.microsoft.com/office/drawing/2014/main" id="{2AE8CF01-3873-4B64-B25C-8B64BDBF15B8}"/>
               </a:ext>
             </a:extLst>
           </p:cNvPr>
@@ -7740,7 +7740,7 @@
           <p:cNvPr id="10" name="body">
             <a:extLst xmlns:a="http://schemas.openxmlformats.org/drawingml/2006/main">
               <a:ext uri="{FF2B5EF4-FFF2-40B4-BE49-F238E27FC236}">
-                <a16:creationId xmlns:a16="http://schemas.microsoft.com/office/drawing/2014/main" id="{0371F54F-DD40-4188-8D6D-D459568A7136}"/>
+                <a16:creationId xmlns:a16="http://schemas.microsoft.com/office/drawing/2014/main" id="{05CC2FF5-2786-4F14-BC98-54F8998717DF}"/>
               </a:ext>
             </a:extLst>
           </p:cNvPr>
@@ -7902,7 +7902,7 @@
           <p:cNvPr id="11" name="body">
             <a:extLst xmlns:a="http://schemas.openxmlformats.org/drawingml/2006/main">
               <a:ext uri="{FF2B5EF4-FFF2-40B4-BE49-F238E27FC236}">
-                <a16:creationId xmlns:a16="http://schemas.microsoft.com/office/drawing/2014/main" id="{19B01D45-3793-4AC2-87D8-7000CE431338}"/>
+                <a16:creationId xmlns:a16="http://schemas.microsoft.com/office/drawing/2014/main" id="{61935C7A-5CB9-4C92-AA4E-D9615F55FE88}"/>
               </a:ext>
             </a:extLst>
           </p:cNvPr>
@@ -8064,7 +8064,7 @@
           <p:cNvPr id="12" name="body">
             <a:extLst xmlns:a="http://schemas.openxmlformats.org/drawingml/2006/main">
               <a:ext uri="{FF2B5EF4-FFF2-40B4-BE49-F238E27FC236}">
-                <a16:creationId xmlns:a16="http://schemas.microsoft.com/office/drawing/2014/main" id="{B58338A2-652F-492A-9E65-73994D8CA5AA}"/>
+                <a16:creationId xmlns:a16="http://schemas.microsoft.com/office/drawing/2014/main" id="{7E14293E-335C-48F7-9B8A-27FF8171A042}"/>
               </a:ext>
             </a:extLst>
           </p:cNvPr>
@@ -8226,7 +8226,7 @@
           <p:cNvPr id="13" name="source-note">
             <a:extLst xmlns:a="http://schemas.openxmlformats.org/drawingml/2006/main">
               <a:ext uri="{FF2B5EF4-FFF2-40B4-BE49-F238E27FC236}">
-                <a16:creationId xmlns:a16="http://schemas.microsoft.com/office/drawing/2014/main" id="{7C9987A5-03EF-40B6-9AB7-BE3449668493}"/>
+                <a16:creationId xmlns:a16="http://schemas.microsoft.com/office/drawing/2014/main" id="{1AEC754E-956F-4652-B284-06E01C6AA4A0}"/>
               </a:ext>
             </a:extLst>
           </p:cNvPr>
@@ -8386,7 +8386,7 @@
     </p:spTree>
     <p:extLst>
       <p:ext uri="{BB962C8B-B14F-4D97-AF65-F5344CB8AC3E}">
-        <p14:creationId xmlns:p14="http://schemas.microsoft.com/office/powerpoint/2010/main" val="1454624714"/>
+        <p14:creationId xmlns:p14="http://schemas.microsoft.com/office/powerpoint/2010/main" val="1921461682"/>
       </p:ext>
     </p:extLst>
   </p:cSld>
@@ -8414,10 +8414,10 @@
       </p:grpSpPr>
       <p:pic>
         <p:nvPicPr>
-          <p:cNvPr id="9" name="">
+          <p:cNvPr id="10" name="">
             <a:extLst xmlns:a="http://schemas.openxmlformats.org/drawingml/2006/main">
               <a:ext uri="{FF2B5EF4-FFF2-40B4-BE49-F238E27FC236}">
-                <a16:creationId xmlns:a16="http://schemas.microsoft.com/office/drawing/2014/main" id="{E8527038-6F4F-43B8-9D47-F35052F69949}"/>
+                <a16:creationId xmlns:a16="http://schemas.microsoft.com/office/drawing/2014/main" id="{F37BD65C-EBC8-4A64-8BDB-475F6C6F2033}"/>
               </a:ext>
             </a:extLst>
           </p:cNvPr>
@@ -8427,10 +8427,10 @@
           <p:nvPr/>
         </p:nvPicPr>
         <p:blipFill>
-          <a:blip xmlns:r="http://schemas.openxmlformats.org/officeDocument/2006/relationships" xmlns:a="http://schemas.openxmlformats.org/drawingml/2006/main" r:embed="R969f619179784f36">
+          <a:blip xmlns:r="http://schemas.openxmlformats.org/officeDocument/2006/relationships" xmlns:a="http://schemas.openxmlformats.org/drawingml/2006/main" r:embed="Ra6a04bb5c3124055">
             <a:extLst>
               <a:ext uri="{96DAC541-7B7A-43D3-8B79-37D633B846F1}">
-                <asvg:svgBlip xmlns:asvg="http://schemas.microsoft.com/office/drawing/2016/SVG/main" r:embed="Re314c1b62f324d2e"/>
+                <asvg:svgBlip xmlns:asvg="http://schemas.microsoft.com/office/drawing/2016/SVG/main" r:embed="Rfe9ee70ee79540c4"/>
               </a:ext>
             </a:extLst>
           </a:blip>
@@ -8451,7 +8451,7 @@
           <p:cNvPr id="2" name="page">
             <a:extLst xmlns:a="http://schemas.openxmlformats.org/drawingml/2006/main">
               <a:ext uri="{FF2B5EF4-FFF2-40B4-BE49-F238E27FC236}">
-                <a16:creationId xmlns:a16="http://schemas.microsoft.com/office/drawing/2014/main" id="{BB213EE8-35FA-4B99-AD3A-6EC71B8F04A5}"/>
+                <a16:creationId xmlns:a16="http://schemas.microsoft.com/office/drawing/2014/main" id="{A5603607-7CD6-46B4-B4FB-BF09BCD6240C}"/>
               </a:ext>
             </a:extLst>
           </p:cNvPr>
@@ -8607,7 +8607,7 @@
           <p:cNvPr id="3" name="title">
             <a:extLst xmlns:a="http://schemas.openxmlformats.org/drawingml/2006/main">
               <a:ext uri="{FF2B5EF4-FFF2-40B4-BE49-F238E27FC236}">
-                <a16:creationId xmlns:a16="http://schemas.microsoft.com/office/drawing/2014/main" id="{53CBB4E3-7B15-4178-A572-2D9A14FB75DA}"/>
+                <a16:creationId xmlns:a16="http://schemas.microsoft.com/office/drawing/2014/main" id="{C4F9992B-A847-4B8F-B754-D09B7FFAB764}"/>
               </a:ext>
             </a:extLst>
           </p:cNvPr>
@@ -8796,7 +8796,7 @@
           <p:cNvPr id="4" name="body">
             <a:extLst xmlns:a="http://schemas.openxmlformats.org/drawingml/2006/main">
               <a:ext uri="{FF2B5EF4-FFF2-40B4-BE49-F238E27FC236}">
-                <a16:creationId xmlns:a16="http://schemas.microsoft.com/office/drawing/2014/main" id="{59901D1F-D49A-4292-98B1-E23E0976572B}"/>
+                <a16:creationId xmlns:a16="http://schemas.microsoft.com/office/drawing/2014/main" id="{68E0FF9E-8D84-4905-8091-C070983B3BBD}"/>
               </a:ext>
             </a:extLst>
           </p:cNvPr>
@@ -8985,7 +8985,7 @@
           <p:cNvPr id="5" name="body">
             <a:extLst xmlns:a="http://schemas.openxmlformats.org/drawingml/2006/main">
               <a:ext uri="{FF2B5EF4-FFF2-40B4-BE49-F238E27FC236}">
-                <a16:creationId xmlns:a16="http://schemas.microsoft.com/office/drawing/2014/main" id="{38324EBE-7C0B-4B67-B2D7-732AB8C6E341}"/>
+                <a16:creationId xmlns:a16="http://schemas.microsoft.com/office/drawing/2014/main" id="{1529AF59-053F-403D-A5B9-9AE0B029C2F6}"/>
               </a:ext>
             </a:extLst>
           </p:cNvPr>
@@ -9147,7 +9147,7 @@
           <p:cNvPr id="6" name="body">
             <a:extLst xmlns:a="http://schemas.openxmlformats.org/drawingml/2006/main">
               <a:ext uri="{FF2B5EF4-FFF2-40B4-BE49-F238E27FC236}">
-                <a16:creationId xmlns:a16="http://schemas.microsoft.com/office/drawing/2014/main" id="{849979A5-44E2-4E1B-BA0A-3416E9A97CC6}"/>
+                <a16:creationId xmlns:a16="http://schemas.microsoft.com/office/drawing/2014/main" id="{87E4B560-B5E7-4DAE-93E2-EE5226412DE4}"/>
               </a:ext>
             </a:extLst>
           </p:cNvPr>
@@ -9306,10 +9306,172 @@
       </p:sp>
       <p:sp>
         <p:nvSpPr>
-          <p:cNvPr id="7" name="body">
+          <p:cNvPr id="7" name="source-note">
             <a:extLst xmlns:a="http://schemas.openxmlformats.org/drawingml/2006/main">
               <a:ext uri="{FF2B5EF4-FFF2-40B4-BE49-F238E27FC236}">
-                <a16:creationId xmlns:a16="http://schemas.microsoft.com/office/drawing/2014/main" id="{20DEBEEF-C765-44FA-94EB-F57F7264A70F}"/>
+                <a16:creationId xmlns:a16="http://schemas.microsoft.com/office/drawing/2014/main" id="{80510D39-2935-4B49-8E22-32B3A0C00670}"/>
+              </a:ext>
+            </a:extLst>
+          </p:cNvPr>
+          <p:cNvSpPr>
+            <a:spLocks xmlns:a="http://schemas.openxmlformats.org/drawingml/2006/main" noGrp="1"/>
+          </p:cNvSpPr>
+          <p:nvPr/>
+        </p:nvSpPr>
+        <p:spPr>
+          <a:xfrm xmlns:a="http://schemas.openxmlformats.org/drawingml/2006/main">
+            <a:off x="609600" y="6210300"/>
+            <a:ext cx="7620000" cy="266700"/>
+          </a:xfrm>
+          <a:prstGeom xmlns:a="http://schemas.openxmlformats.org/drawingml/2006/main" prst="rect">
+            <a:avLst/>
+          </a:prstGeom>
+          <a:noFill xmlns:a="http://schemas.openxmlformats.org/drawingml/2006/main"/>
+          <a:ln xmlns:a="http://schemas.openxmlformats.org/drawingml/2006/main" w="0">
+            <a:noFill/>
+          </a:ln>
+        </p:spPr>
+        <p:txBody>
+          <a:bodyPr xmlns:a="http://schemas.openxmlformats.org/drawingml/2006/main" lIns="0" tIns="0" rIns="0" bIns="0" anchor="t">
+            <a:noAutofit/>
+          </a:bodyPr>
+          <a:lstStyle xmlns:a="http://schemas.openxmlformats.org/drawingml/2006/main">
+            <a:defPPr>
+              <a:defRPr sz="1200" b="0">
+                <a:solidFill>
+                  <a:srgbClr val="F1DCE2"/>
+                </a:solidFill>
+                <a:latin typeface="Be Vietnam Pro"/>
+                <a:ea typeface="Be Vietnam Pro"/>
+                <a:cs typeface="Be Vietnam Pro"/>
+              </a:defRPr>
+            </a:defPPr>
+            <a:lvl1pPr>
+              <a:defRPr sz="1200" b="0">
+                <a:solidFill>
+                  <a:srgbClr val="F1DCE2"/>
+                </a:solidFill>
+                <a:latin typeface="Be Vietnam Pro"/>
+                <a:ea typeface="Be Vietnam Pro"/>
+                <a:cs typeface="Be Vietnam Pro"/>
+              </a:defRPr>
+            </a:lvl1pPr>
+            <a:lvl2pPr>
+              <a:defRPr sz="1200" b="0">
+                <a:solidFill>
+                  <a:srgbClr val="F1DCE2"/>
+                </a:solidFill>
+                <a:latin typeface="Be Vietnam Pro"/>
+                <a:ea typeface="Be Vietnam Pro"/>
+                <a:cs typeface="Be Vietnam Pro"/>
+              </a:defRPr>
+            </a:lvl2pPr>
+            <a:lvl3pPr>
+              <a:defRPr sz="1200" b="0">
+                <a:solidFill>
+                  <a:srgbClr val="F1DCE2"/>
+                </a:solidFill>
+                <a:latin typeface="Be Vietnam Pro"/>
+                <a:ea typeface="Be Vietnam Pro"/>
+                <a:cs typeface="Be Vietnam Pro"/>
+              </a:defRPr>
+            </a:lvl3pPr>
+            <a:lvl4pPr>
+              <a:defRPr sz="1200" b="0">
+                <a:solidFill>
+                  <a:srgbClr val="F1DCE2"/>
+                </a:solidFill>
+                <a:latin typeface="Be Vietnam Pro"/>
+                <a:ea typeface="Be Vietnam Pro"/>
+                <a:cs typeface="Be Vietnam Pro"/>
+              </a:defRPr>
+            </a:lvl4pPr>
+            <a:lvl5pPr>
+              <a:defRPr sz="1200" b="0">
+                <a:solidFill>
+                  <a:srgbClr val="F1DCE2"/>
+                </a:solidFill>
+                <a:latin typeface="Be Vietnam Pro"/>
+                <a:ea typeface="Be Vietnam Pro"/>
+                <a:cs typeface="Be Vietnam Pro"/>
+              </a:defRPr>
+            </a:lvl5pPr>
+            <a:lvl6pPr>
+              <a:defRPr sz="1200" b="0">
+                <a:solidFill>
+                  <a:srgbClr val="F1DCE2"/>
+                </a:solidFill>
+                <a:latin typeface="Be Vietnam Pro"/>
+                <a:ea typeface="Be Vietnam Pro"/>
+                <a:cs typeface="Be Vietnam Pro"/>
+              </a:defRPr>
+            </a:lvl6pPr>
+            <a:lvl7pPr>
+              <a:defRPr sz="1200" b="0">
+                <a:solidFill>
+                  <a:srgbClr val="F1DCE2"/>
+                </a:solidFill>
+                <a:latin typeface="Be Vietnam Pro"/>
+                <a:ea typeface="Be Vietnam Pro"/>
+                <a:cs typeface="Be Vietnam Pro"/>
+              </a:defRPr>
+            </a:lvl7pPr>
+            <a:lvl8pPr>
+              <a:defRPr sz="1200" b="0">
+                <a:solidFill>
+                  <a:srgbClr val="F1DCE2"/>
+                </a:solidFill>
+                <a:latin typeface="Be Vietnam Pro"/>
+                <a:ea typeface="Be Vietnam Pro"/>
+                <a:cs typeface="Be Vietnam Pro"/>
+              </a:defRPr>
+            </a:lvl8pPr>
+            <a:lvl9pPr>
+              <a:defRPr sz="1200" b="0">
+                <a:solidFill>
+                  <a:srgbClr val="F1DCE2"/>
+                </a:solidFill>
+                <a:latin typeface="Be Vietnam Pro"/>
+                <a:ea typeface="Be Vietnam Pro"/>
+                <a:cs typeface="Be Vietnam Pro"/>
+              </a:defRPr>
+            </a:lvl9pPr>
+          </a:lstStyle>
+          <a:p xmlns:a="http://schemas.openxmlformats.org/drawingml/2006/main">
+            <a:pPr>
+              <a:lnSpc>
+                <a:spcPct val="116000"/>
+              </a:lnSpc>
+              <a:buNone/>
+              <a:defRPr sz="1200" b="0">
+                <a:solidFill>
+                  <a:srgbClr val="F1DCE2"/>
+                </a:solidFill>
+                <a:latin typeface="Be Vietnam Pro"/>
+                <a:ea typeface="Be Vietnam Pro"/>
+                <a:cs typeface="Be Vietnam Pro"/>
+              </a:defRPr>
+            </a:pPr>
+            <a:r>
+              <a:rPr sz="1200" b="0">
+                <a:solidFill>
+                  <a:srgbClr val="F1DCE2"/>
+                </a:solidFill>
+                <a:latin typeface="Be Vietnam Pro"/>
+                <a:ea typeface="Be Vietnam Pro"/>
+                <a:cs typeface="Be Vietnam Pro"/>
+              </a:rPr>
+              <a:t>Simulated payments. Solana devnet.</a:t>
+            </a:r>
+          </a:p>
+        </p:txBody>
+      </p:sp>
+      <p:sp>
+        <p:nvSpPr>
+          <p:cNvPr id="8" name="body">
+            <a:extLst xmlns:a="http://schemas.openxmlformats.org/drawingml/2006/main">
+              <a:ext uri="{FF2B5EF4-FFF2-40B4-BE49-F238E27FC236}">
+                <a16:creationId xmlns:a16="http://schemas.microsoft.com/office/drawing/2014/main" id="{F4D66371-261C-4041-A4DD-70FAD93FDBDB}"/>
               </a:ext>
             </a:extLst>
           </p:cNvPr>
@@ -9468,10 +9630,10 @@
       </p:sp>
       <p:sp>
         <p:nvSpPr>
-          <p:cNvPr id="8" name="body">
+          <p:cNvPr id="9" name="body">
             <a:extLst xmlns:a="http://schemas.openxmlformats.org/drawingml/2006/main">
               <a:ext uri="{FF2B5EF4-FFF2-40B4-BE49-F238E27FC236}">
-                <a16:creationId xmlns:a16="http://schemas.microsoft.com/office/drawing/2014/main" id="{13CD8A62-F4AE-46D0-A7EC-5021325A1C5A}"/>
+                <a16:creationId xmlns:a16="http://schemas.microsoft.com/office/drawing/2014/main" id="{E5A53FC9-9298-4365-AD2E-55C07C0AD4BD}"/>
               </a:ext>
             </a:extLst>
           </p:cNvPr>
@@ -9631,7 +9793,7 @@
     </p:spTree>
     <p:extLst>
       <p:ext uri="{BB962C8B-B14F-4D97-AF65-F5344CB8AC3E}">
-        <p14:creationId xmlns:p14="http://schemas.microsoft.com/office/powerpoint/2010/main" val="1627747094"/>
+        <p14:creationId xmlns:p14="http://schemas.microsoft.com/office/powerpoint/2010/main" val="1971031299"/>
       </p:ext>
     </p:extLst>
   </p:cSld>
@@ -9662,7 +9824,7 @@
           <p:cNvPr id="14" name="">
             <a:extLst xmlns:a="http://schemas.openxmlformats.org/drawingml/2006/main">
               <a:ext uri="{FF2B5EF4-FFF2-40B4-BE49-F238E27FC236}">
-                <a16:creationId xmlns:a16="http://schemas.microsoft.com/office/drawing/2014/main" id="{DB55480D-530E-456C-A9F7-5FC4A852C547}"/>
+                <a16:creationId xmlns:a16="http://schemas.microsoft.com/office/drawing/2014/main" id="{C5DE6C04-BCD4-4F58-84E2-FCF695AE238B}"/>
               </a:ext>
             </a:extLst>
           </p:cNvPr>
@@ -9672,10 +9834,10 @@
           <p:nvPr/>
         </p:nvPicPr>
         <p:blipFill>
-          <a:blip xmlns:r="http://schemas.openxmlformats.org/officeDocument/2006/relationships" xmlns:a="http://schemas.openxmlformats.org/drawingml/2006/main" r:embed="Rc53f9bac80694003">
+          <a:blip xmlns:r="http://schemas.openxmlformats.org/officeDocument/2006/relationships" xmlns:a="http://schemas.openxmlformats.org/drawingml/2006/main" r:embed="R0c6c78e27e894b9f">
             <a:extLst>
               <a:ext uri="{96DAC541-7B7A-43D3-8B79-37D633B846F1}">
-                <asvg:svgBlip xmlns:asvg="http://schemas.microsoft.com/office/drawing/2016/SVG/main" r:embed="Ra471ff74c4844b00"/>
+                <asvg:svgBlip xmlns:asvg="http://schemas.microsoft.com/office/drawing/2016/SVG/main" r:embed="R96294a99041945ab"/>
               </a:ext>
             </a:extLst>
           </a:blip>
@@ -9696,7 +9858,7 @@
           <p:cNvPr id="2" name="title">
             <a:extLst xmlns:a="http://schemas.openxmlformats.org/drawingml/2006/main">
               <a:ext uri="{FF2B5EF4-FFF2-40B4-BE49-F238E27FC236}">
-                <a16:creationId xmlns:a16="http://schemas.microsoft.com/office/drawing/2014/main" id="{75ACD9C6-807F-4850-85CB-9070644ED563}"/>
+                <a16:creationId xmlns:a16="http://schemas.microsoft.com/office/drawing/2014/main" id="{B5111A39-06CF-4B76-8E81-6026888F8C4D}"/>
               </a:ext>
             </a:extLst>
           </p:cNvPr>
@@ -9858,7 +10020,7 @@
           <p:cNvPr id="3" name="page">
             <a:extLst xmlns:a="http://schemas.openxmlformats.org/drawingml/2006/main">
               <a:ext uri="{FF2B5EF4-FFF2-40B4-BE49-F238E27FC236}">
-                <a16:creationId xmlns:a16="http://schemas.microsoft.com/office/drawing/2014/main" id="{49428A07-98A4-40BF-BA80-C7BD6BC7E031}"/>
+                <a16:creationId xmlns:a16="http://schemas.microsoft.com/office/drawing/2014/main" id="{C959E26E-3343-4B77-B593-092CA57B5890}"/>
               </a:ext>
             </a:extLst>
           </p:cNvPr>
@@ -10014,7 +10176,7 @@
           <p:cNvPr id="4" name="body">
             <a:extLst xmlns:a="http://schemas.openxmlformats.org/drawingml/2006/main">
               <a:ext uri="{FF2B5EF4-FFF2-40B4-BE49-F238E27FC236}">
-                <a16:creationId xmlns:a16="http://schemas.microsoft.com/office/drawing/2014/main" id="{CFEF9770-C28F-4D74-9D7F-C9FCF14744DF}"/>
+                <a16:creationId xmlns:a16="http://schemas.microsoft.com/office/drawing/2014/main" id="{1D8DEC59-57DE-4E7D-9B4E-3BDEA9E3D25A}"/>
               </a:ext>
             </a:extLst>
           </p:cNvPr>
@@ -10176,7 +10338,7 @@
           <p:cNvPr id="5" name="body">
             <a:extLst xmlns:a="http://schemas.openxmlformats.org/drawingml/2006/main">
               <a:ext uri="{FF2B5EF4-FFF2-40B4-BE49-F238E27FC236}">
-                <a16:creationId xmlns:a16="http://schemas.microsoft.com/office/drawing/2014/main" id="{EB967B76-AAC2-4E8A-9E77-69382BAF6DE1}"/>
+                <a16:creationId xmlns:a16="http://schemas.microsoft.com/office/drawing/2014/main" id="{93D7277C-1A1E-49EA-8152-634CB03CFDC9}"/>
               </a:ext>
             </a:extLst>
           </p:cNvPr>
@@ -10338,7 +10500,7 @@
           <p:cNvPr id="6" name="body">
             <a:extLst xmlns:a="http://schemas.openxmlformats.org/drawingml/2006/main">
               <a:ext uri="{FF2B5EF4-FFF2-40B4-BE49-F238E27FC236}">
-                <a16:creationId xmlns:a16="http://schemas.microsoft.com/office/drawing/2014/main" id="{F71A9541-59F7-46E9-8D86-FD16BC31ED01}"/>
+                <a16:creationId xmlns:a16="http://schemas.microsoft.com/office/drawing/2014/main" id="{D98F61E1-0102-4A06-AE44-2BE73ECE05B1}"/>
               </a:ext>
             </a:extLst>
           </p:cNvPr>
@@ -10500,7 +10662,7 @@
           <p:cNvPr id="7" name="body">
             <a:extLst xmlns:a="http://schemas.openxmlformats.org/drawingml/2006/main">
               <a:ext uri="{FF2B5EF4-FFF2-40B4-BE49-F238E27FC236}">
-                <a16:creationId xmlns:a16="http://schemas.microsoft.com/office/drawing/2014/main" id="{C7A658D0-97AA-4D1C-AAFD-91FECD2F9442}"/>
+                <a16:creationId xmlns:a16="http://schemas.microsoft.com/office/drawing/2014/main" id="{2E482332-3A13-4F22-856D-ABFEE3B70B13}"/>
               </a:ext>
             </a:extLst>
           </p:cNvPr>
@@ -10662,7 +10824,7 @@
           <p:cNvPr id="8" name="body">
             <a:extLst xmlns:a="http://schemas.openxmlformats.org/drawingml/2006/main">
               <a:ext uri="{FF2B5EF4-FFF2-40B4-BE49-F238E27FC236}">
-                <a16:creationId xmlns:a16="http://schemas.microsoft.com/office/drawing/2014/main" id="{E219CE58-9708-4B1F-9B32-F66A9443CF01}"/>
+                <a16:creationId xmlns:a16="http://schemas.microsoft.com/office/drawing/2014/main" id="{CA3E975D-79F1-4889-9992-03CCC2D63A4C}"/>
               </a:ext>
             </a:extLst>
           </p:cNvPr>
@@ -10824,7 +10986,7 @@
           <p:cNvPr id="9" name="body">
             <a:extLst xmlns:a="http://schemas.openxmlformats.org/drawingml/2006/main">
               <a:ext uri="{FF2B5EF4-FFF2-40B4-BE49-F238E27FC236}">
-                <a16:creationId xmlns:a16="http://schemas.microsoft.com/office/drawing/2014/main" id="{61639916-63CA-4B71-8E7C-73CC3A89F36F}"/>
+                <a16:creationId xmlns:a16="http://schemas.microsoft.com/office/drawing/2014/main" id="{14B4ABD1-00B0-4DE8-86B4-BB4AA49AAB8A}"/>
               </a:ext>
             </a:extLst>
           </p:cNvPr>
@@ -10986,7 +11148,7 @@
           <p:cNvPr id="10" name="body">
             <a:extLst xmlns:a="http://schemas.openxmlformats.org/drawingml/2006/main">
               <a:ext uri="{FF2B5EF4-FFF2-40B4-BE49-F238E27FC236}">
-                <a16:creationId xmlns:a16="http://schemas.microsoft.com/office/drawing/2014/main" id="{243ECAEE-B28B-4647-BA9A-35C7C659D4A0}"/>
+                <a16:creationId xmlns:a16="http://schemas.microsoft.com/office/drawing/2014/main" id="{B428F937-EB66-4AA2-8CDC-FF0A79FF87B2}"/>
               </a:ext>
             </a:extLst>
           </p:cNvPr>
@@ -11148,7 +11310,7 @@
           <p:cNvPr id="11" name="body">
             <a:extLst xmlns:a="http://schemas.openxmlformats.org/drawingml/2006/main">
               <a:ext uri="{FF2B5EF4-FFF2-40B4-BE49-F238E27FC236}">
-                <a16:creationId xmlns:a16="http://schemas.microsoft.com/office/drawing/2014/main" id="{8E1D899E-9F65-40B2-90B9-BB9B6424431E}"/>
+                <a16:creationId xmlns:a16="http://schemas.microsoft.com/office/drawing/2014/main" id="{9ECB0900-B9F8-44DD-A92D-C5D5C5DA4365}"/>
               </a:ext>
             </a:extLst>
           </p:cNvPr>
@@ -11310,7 +11472,7 @@
           <p:cNvPr id="12" name="body">
             <a:extLst xmlns:a="http://schemas.openxmlformats.org/drawingml/2006/main">
               <a:ext uri="{FF2B5EF4-FFF2-40B4-BE49-F238E27FC236}">
-                <a16:creationId xmlns:a16="http://schemas.microsoft.com/office/drawing/2014/main" id="{A506D915-1D58-47E1-A0B1-ACC658D9E7DC}"/>
+                <a16:creationId xmlns:a16="http://schemas.microsoft.com/office/drawing/2014/main" id="{AB7B37DC-4C1F-4579-8423-312677527585}"/>
               </a:ext>
             </a:extLst>
           </p:cNvPr>
@@ -11472,7 +11634,7 @@
           <p:cNvPr id="13" name="source-note">
             <a:extLst xmlns:a="http://schemas.openxmlformats.org/drawingml/2006/main">
               <a:ext uri="{FF2B5EF4-FFF2-40B4-BE49-F238E27FC236}">
-                <a16:creationId xmlns:a16="http://schemas.microsoft.com/office/drawing/2014/main" id="{B506AB0C-FBEA-40AF-ADEB-3D5F5D3770D4}"/>
+                <a16:creationId xmlns:a16="http://schemas.microsoft.com/office/drawing/2014/main" id="{2F1122F3-C89F-49C7-8FBF-976A6E0B457E}"/>
               </a:ext>
             </a:extLst>
           </p:cNvPr>
@@ -11632,7 +11794,7 @@
     </p:spTree>
     <p:extLst>
       <p:ext uri="{BB962C8B-B14F-4D97-AF65-F5344CB8AC3E}">
-        <p14:creationId xmlns:p14="http://schemas.microsoft.com/office/powerpoint/2010/main" val="2122510651"/>
+        <p14:creationId xmlns:p14="http://schemas.microsoft.com/office/powerpoint/2010/main" val="1044427096"/>
       </p:ext>
     </p:extLst>
   </p:cSld>
@@ -11663,7 +11825,7 @@
           <p:cNvPr id="14" name="">
             <a:extLst xmlns:a="http://schemas.openxmlformats.org/drawingml/2006/main">
               <a:ext uri="{FF2B5EF4-FFF2-40B4-BE49-F238E27FC236}">
-                <a16:creationId xmlns:a16="http://schemas.microsoft.com/office/drawing/2014/main" id="{78EDE4A7-C21B-4E4C-97F0-9804F763771F}"/>
+                <a16:creationId xmlns:a16="http://schemas.microsoft.com/office/drawing/2014/main" id="{77629896-7922-48D9-8FAB-F172A3CDF40D}"/>
               </a:ext>
             </a:extLst>
           </p:cNvPr>
@@ -11673,10 +11835,10 @@
           <p:nvPr/>
         </p:nvPicPr>
         <p:blipFill>
-          <a:blip xmlns:r="http://schemas.openxmlformats.org/officeDocument/2006/relationships" xmlns:a="http://schemas.openxmlformats.org/drawingml/2006/main" r:embed="Rcc838be27d8e47e1">
+          <a:blip xmlns:r="http://schemas.openxmlformats.org/officeDocument/2006/relationships" xmlns:a="http://schemas.openxmlformats.org/drawingml/2006/main" r:embed="R08b7e7e9a0f14400">
             <a:extLst>
               <a:ext uri="{96DAC541-7B7A-43D3-8B79-37D633B846F1}">
-                <asvg:svgBlip xmlns:asvg="http://schemas.microsoft.com/office/drawing/2016/SVG/main" r:embed="Rd2673f81554948d2"/>
+                <asvg:svgBlip xmlns:asvg="http://schemas.microsoft.com/office/drawing/2016/SVG/main" r:embed="R3cbb914746104f65"/>
               </a:ext>
             </a:extLst>
           </a:blip>
@@ -11697,7 +11859,7 @@
           <p:cNvPr id="2" name="title">
             <a:extLst xmlns:a="http://schemas.openxmlformats.org/drawingml/2006/main">
               <a:ext uri="{FF2B5EF4-FFF2-40B4-BE49-F238E27FC236}">
-                <a16:creationId xmlns:a16="http://schemas.microsoft.com/office/drawing/2014/main" id="{D7A57A50-887B-4685-98A7-A4D17C13AE5D}"/>
+                <a16:creationId xmlns:a16="http://schemas.microsoft.com/office/drawing/2014/main" id="{AA5DB990-1352-43E8-B137-09FC4526B3F3}"/>
               </a:ext>
             </a:extLst>
           </p:cNvPr>
@@ -11859,7 +12021,7 @@
           <p:cNvPr id="3" name="body">
             <a:extLst xmlns:a="http://schemas.openxmlformats.org/drawingml/2006/main">
               <a:ext uri="{FF2B5EF4-FFF2-40B4-BE49-F238E27FC236}">
-                <a16:creationId xmlns:a16="http://schemas.microsoft.com/office/drawing/2014/main" id="{861D5AD2-79F4-4E82-B42F-F8A0738E991A}"/>
+                <a16:creationId xmlns:a16="http://schemas.microsoft.com/office/drawing/2014/main" id="{1E58EF20-B977-4746-A6B2-11965DEA28C8}"/>
               </a:ext>
             </a:extLst>
           </p:cNvPr>
@@ -12021,7 +12183,7 @@
           <p:cNvPr id="4" name="page">
             <a:extLst xmlns:a="http://schemas.openxmlformats.org/drawingml/2006/main">
               <a:ext uri="{FF2B5EF4-FFF2-40B4-BE49-F238E27FC236}">
-                <a16:creationId xmlns:a16="http://schemas.microsoft.com/office/drawing/2014/main" id="{FA736478-A744-412A-BF22-03C7E57DFDE1}"/>
+                <a16:creationId xmlns:a16="http://schemas.microsoft.com/office/drawing/2014/main" id="{732FD828-8C03-4E5A-A8DB-526A3A6195A8}"/>
               </a:ext>
             </a:extLst>
           </p:cNvPr>
@@ -12177,7 +12339,7 @@
           <p:cNvPr id="5" name="body">
             <a:extLst xmlns:a="http://schemas.openxmlformats.org/drawingml/2006/main">
               <a:ext uri="{FF2B5EF4-FFF2-40B4-BE49-F238E27FC236}">
-                <a16:creationId xmlns:a16="http://schemas.microsoft.com/office/drawing/2014/main" id="{AFC299CF-8BE5-49BB-9169-651C63EE792A}"/>
+                <a16:creationId xmlns:a16="http://schemas.microsoft.com/office/drawing/2014/main" id="{B96B3EA8-DAE7-4C9A-8531-FB08412E4A2E}"/>
               </a:ext>
             </a:extLst>
           </p:cNvPr>
@@ -12339,7 +12501,7 @@
           <p:cNvPr id="6" name="body">
             <a:extLst xmlns:a="http://schemas.openxmlformats.org/drawingml/2006/main">
               <a:ext uri="{FF2B5EF4-FFF2-40B4-BE49-F238E27FC236}">
-                <a16:creationId xmlns:a16="http://schemas.microsoft.com/office/drawing/2014/main" id="{864B2FF6-6FB2-4ACC-A8B8-6E7F5F41FACD}"/>
+                <a16:creationId xmlns:a16="http://schemas.microsoft.com/office/drawing/2014/main" id="{7555EB02-B715-4264-BDCE-9C47C86E3685}"/>
               </a:ext>
             </a:extLst>
           </p:cNvPr>
@@ -12501,7 +12663,7 @@
           <p:cNvPr id="7" name="body">
             <a:extLst xmlns:a="http://schemas.openxmlformats.org/drawingml/2006/main">
               <a:ext uri="{FF2B5EF4-FFF2-40B4-BE49-F238E27FC236}">
-                <a16:creationId xmlns:a16="http://schemas.microsoft.com/office/drawing/2014/main" id="{76510A30-CA45-4D1B-9F48-42B597ACF829}"/>
+                <a16:creationId xmlns:a16="http://schemas.microsoft.com/office/drawing/2014/main" id="{B6E59349-8CBA-46B0-B3FB-AE26135FAF84}"/>
               </a:ext>
             </a:extLst>
           </p:cNvPr>
@@ -12663,7 +12825,7 @@
           <p:cNvPr id="8" name="body">
             <a:extLst xmlns:a="http://schemas.openxmlformats.org/drawingml/2006/main">
               <a:ext uri="{FF2B5EF4-FFF2-40B4-BE49-F238E27FC236}">
-                <a16:creationId xmlns:a16="http://schemas.microsoft.com/office/drawing/2014/main" id="{2999E833-B206-4C0E-ACD4-ACA144FC3935}"/>
+                <a16:creationId xmlns:a16="http://schemas.microsoft.com/office/drawing/2014/main" id="{B803DA31-2772-4A5C-937C-E33E373A8E70}"/>
               </a:ext>
             </a:extLst>
           </p:cNvPr>
@@ -12825,7 +12987,7 @@
           <p:cNvPr id="9" name="body">
             <a:extLst xmlns:a="http://schemas.openxmlformats.org/drawingml/2006/main">
               <a:ext uri="{FF2B5EF4-FFF2-40B4-BE49-F238E27FC236}">
-                <a16:creationId xmlns:a16="http://schemas.microsoft.com/office/drawing/2014/main" id="{B2DFEE03-3BC3-4C0B-BE83-DD46A8065388}"/>
+                <a16:creationId xmlns:a16="http://schemas.microsoft.com/office/drawing/2014/main" id="{5E63B970-F259-4531-81E4-6F353BFFB887}"/>
               </a:ext>
             </a:extLst>
           </p:cNvPr>
@@ -12987,7 +13149,7 @@
           <p:cNvPr id="10" name="body">
             <a:extLst xmlns:a="http://schemas.openxmlformats.org/drawingml/2006/main">
               <a:ext uri="{FF2B5EF4-FFF2-40B4-BE49-F238E27FC236}">
-                <a16:creationId xmlns:a16="http://schemas.microsoft.com/office/drawing/2014/main" id="{3EC9907D-62C5-4497-A599-83CDCBA42FF0}"/>
+                <a16:creationId xmlns:a16="http://schemas.microsoft.com/office/drawing/2014/main" id="{51E1F1C9-865F-4417-9447-91E1918DCA9A}"/>
               </a:ext>
             </a:extLst>
           </p:cNvPr>
@@ -13149,7 +13311,7 @@
           <p:cNvPr id="11" name="body">
             <a:extLst xmlns:a="http://schemas.openxmlformats.org/drawingml/2006/main">
               <a:ext uri="{FF2B5EF4-FFF2-40B4-BE49-F238E27FC236}">
-                <a16:creationId xmlns:a16="http://schemas.microsoft.com/office/drawing/2014/main" id="{91546EAD-9DA2-4D30-A2A2-BEA186B8D256}"/>
+                <a16:creationId xmlns:a16="http://schemas.microsoft.com/office/drawing/2014/main" id="{DC26DFAD-0178-4E13-BC9D-41E9A229ADD7}"/>
               </a:ext>
             </a:extLst>
           </p:cNvPr>
@@ -13311,7 +13473,7 @@
           <p:cNvPr id="12" name="body">
             <a:extLst xmlns:a="http://schemas.openxmlformats.org/drawingml/2006/main">
               <a:ext uri="{FF2B5EF4-FFF2-40B4-BE49-F238E27FC236}">
-                <a16:creationId xmlns:a16="http://schemas.microsoft.com/office/drawing/2014/main" id="{08F7263D-B304-4729-AE71-5F1DEC51A651}"/>
+                <a16:creationId xmlns:a16="http://schemas.microsoft.com/office/drawing/2014/main" id="{5A4DDC15-88E0-49ED-AA57-F3F386D1A5A4}"/>
               </a:ext>
             </a:extLst>
           </p:cNvPr>
@@ -13473,7 +13635,7 @@
           <p:cNvPr id="13" name="body">
             <a:extLst xmlns:a="http://schemas.openxmlformats.org/drawingml/2006/main">
               <a:ext uri="{FF2B5EF4-FFF2-40B4-BE49-F238E27FC236}">
-                <a16:creationId xmlns:a16="http://schemas.microsoft.com/office/drawing/2014/main" id="{4F64D6A6-608A-4C33-8080-0585C3BD8E26}"/>
+                <a16:creationId xmlns:a16="http://schemas.microsoft.com/office/drawing/2014/main" id="{0651CD44-F0D1-4965-A1BA-8207004445D8}"/>
               </a:ext>
             </a:extLst>
           </p:cNvPr>
@@ -13633,7 +13795,7 @@
     </p:spTree>
     <p:extLst>
       <p:ext uri="{BB962C8B-B14F-4D97-AF65-F5344CB8AC3E}">
-        <p14:creationId xmlns:p14="http://schemas.microsoft.com/office/powerpoint/2010/main" val="226221397"/>
+        <p14:creationId xmlns:p14="http://schemas.microsoft.com/office/powerpoint/2010/main" val="791008354"/>
       </p:ext>
     </p:extLst>
   </p:cSld>
@@ -13664,7 +13826,7 @@
           <p:cNvPr id="18" name="">
             <a:extLst xmlns:a="http://schemas.openxmlformats.org/drawingml/2006/main">
               <a:ext uri="{FF2B5EF4-FFF2-40B4-BE49-F238E27FC236}">
-                <a16:creationId xmlns:a16="http://schemas.microsoft.com/office/drawing/2014/main" id="{8324A18E-B4C2-4E30-AF3F-7BDE0E7BEDC0}"/>
+                <a16:creationId xmlns:a16="http://schemas.microsoft.com/office/drawing/2014/main" id="{C675D8DC-0FAE-45D2-B392-99EB1090A10E}"/>
               </a:ext>
             </a:extLst>
           </p:cNvPr>
@@ -13674,10 +13836,10 @@
           <p:nvPr/>
         </p:nvPicPr>
         <p:blipFill>
-          <a:blip xmlns:r="http://schemas.openxmlformats.org/officeDocument/2006/relationships" xmlns:a="http://schemas.openxmlformats.org/drawingml/2006/main" r:embed="R2b76128c47424cfa">
+          <a:blip xmlns:r="http://schemas.openxmlformats.org/officeDocument/2006/relationships" xmlns:a="http://schemas.openxmlformats.org/drawingml/2006/main" r:embed="R2ca089fb2078424a">
             <a:extLst>
               <a:ext uri="{96DAC541-7B7A-43D3-8B79-37D633B846F1}">
-                <asvg:svgBlip xmlns:asvg="http://schemas.microsoft.com/office/drawing/2016/SVG/main" r:embed="R3d0bc4c5c47c4f61"/>
+                <asvg:svgBlip xmlns:asvg="http://schemas.microsoft.com/office/drawing/2016/SVG/main" r:embed="R2e870fdf6a3f4d05"/>
               </a:ext>
             </a:extLst>
           </a:blip>
@@ -13698,7 +13860,7 @@
           <p:cNvPr id="2" name="title">
             <a:extLst xmlns:a="http://schemas.openxmlformats.org/drawingml/2006/main">
               <a:ext uri="{FF2B5EF4-FFF2-40B4-BE49-F238E27FC236}">
-                <a16:creationId xmlns:a16="http://schemas.microsoft.com/office/drawing/2014/main" id="{9AF3D79C-984F-4682-9EEA-AC806017852B}"/>
+                <a16:creationId xmlns:a16="http://schemas.microsoft.com/office/drawing/2014/main" id="{0DF283E0-4A42-47C7-8FA6-25289A030E7A}"/>
               </a:ext>
             </a:extLst>
           </p:cNvPr>
@@ -13860,7 +14022,7 @@
           <p:cNvPr id="3" name="page">
             <a:extLst xmlns:a="http://schemas.openxmlformats.org/drawingml/2006/main">
               <a:ext uri="{FF2B5EF4-FFF2-40B4-BE49-F238E27FC236}">
-                <a16:creationId xmlns:a16="http://schemas.microsoft.com/office/drawing/2014/main" id="{59D76C01-59CD-4B96-93EB-B177F0AB2394}"/>
+                <a16:creationId xmlns:a16="http://schemas.microsoft.com/office/drawing/2014/main" id="{79B1A333-6731-4B81-B58B-BBD49D20D112}"/>
               </a:ext>
             </a:extLst>
           </p:cNvPr>
@@ -14016,7 +14178,7 @@
           <p:cNvPr id="4" name="body">
             <a:extLst xmlns:a="http://schemas.openxmlformats.org/drawingml/2006/main">
               <a:ext uri="{FF2B5EF4-FFF2-40B4-BE49-F238E27FC236}">
-                <a16:creationId xmlns:a16="http://schemas.microsoft.com/office/drawing/2014/main" id="{DF15FFDF-B819-4975-879A-2572C3482E29}"/>
+                <a16:creationId xmlns:a16="http://schemas.microsoft.com/office/drawing/2014/main" id="{E96B7470-6A59-4851-949E-6D8A33BE9750}"/>
               </a:ext>
             </a:extLst>
           </p:cNvPr>
@@ -14178,7 +14340,7 @@
           <p:cNvPr id="5" name="body">
             <a:extLst xmlns:a="http://schemas.openxmlformats.org/drawingml/2006/main">
               <a:ext uri="{FF2B5EF4-FFF2-40B4-BE49-F238E27FC236}">
-                <a16:creationId xmlns:a16="http://schemas.microsoft.com/office/drawing/2014/main" id="{BA0836A5-6ED7-4DE1-BA13-28E6C5A419FD}"/>
+                <a16:creationId xmlns:a16="http://schemas.microsoft.com/office/drawing/2014/main" id="{697E8471-FD18-4A54-82CD-92854211B754}"/>
               </a:ext>
             </a:extLst>
           </p:cNvPr>
@@ -14340,7 +14502,7 @@
           <p:cNvPr id="6" name="body">
             <a:extLst xmlns:a="http://schemas.openxmlformats.org/drawingml/2006/main">
               <a:ext uri="{FF2B5EF4-FFF2-40B4-BE49-F238E27FC236}">
-                <a16:creationId xmlns:a16="http://schemas.microsoft.com/office/drawing/2014/main" id="{CECD5B6F-9D33-4F40-AC54-4623DC93CD75}"/>
+                <a16:creationId xmlns:a16="http://schemas.microsoft.com/office/drawing/2014/main" id="{4D1E9B57-8B61-48B6-BD82-21D486CDB174}"/>
               </a:ext>
             </a:extLst>
           </p:cNvPr>
@@ -14502,7 +14664,7 @@
           <p:cNvPr id="7" name="body">
             <a:extLst xmlns:a="http://schemas.openxmlformats.org/drawingml/2006/main">
               <a:ext uri="{FF2B5EF4-FFF2-40B4-BE49-F238E27FC236}">
-                <a16:creationId xmlns:a16="http://schemas.microsoft.com/office/drawing/2014/main" id="{06BA6E53-DA11-4B0F-A5DD-5311A1B30A6F}"/>
+                <a16:creationId xmlns:a16="http://schemas.microsoft.com/office/drawing/2014/main" id="{85299081-B3E7-4D2C-969A-6B6BC10D3E34}"/>
               </a:ext>
             </a:extLst>
           </p:cNvPr>
@@ -14664,7 +14826,7 @@
           <p:cNvPr id="8" name="body">
             <a:extLst xmlns:a="http://schemas.openxmlformats.org/drawingml/2006/main">
               <a:ext uri="{FF2B5EF4-FFF2-40B4-BE49-F238E27FC236}">
-                <a16:creationId xmlns:a16="http://schemas.microsoft.com/office/drawing/2014/main" id="{7965EFBC-1BCA-4124-8C02-14CFA2119BDF}"/>
+                <a16:creationId xmlns:a16="http://schemas.microsoft.com/office/drawing/2014/main" id="{44572BE2-131E-4F36-A7CD-13AB9E885BF4}"/>
               </a:ext>
             </a:extLst>
           </p:cNvPr>
@@ -14826,7 +14988,7 @@
           <p:cNvPr id="9" name="body">
             <a:extLst xmlns:a="http://schemas.openxmlformats.org/drawingml/2006/main">
               <a:ext uri="{FF2B5EF4-FFF2-40B4-BE49-F238E27FC236}">
-                <a16:creationId xmlns:a16="http://schemas.microsoft.com/office/drawing/2014/main" id="{3695723A-B5BB-49C2-AAD5-678C031D9647}"/>
+                <a16:creationId xmlns:a16="http://schemas.microsoft.com/office/drawing/2014/main" id="{0F44D8AB-2BC0-4A40-B635-F4BDECA5C904}"/>
               </a:ext>
             </a:extLst>
           </p:cNvPr>
@@ -14988,7 +15150,7 @@
           <p:cNvPr id="10" name="body">
             <a:extLst xmlns:a="http://schemas.openxmlformats.org/drawingml/2006/main">
               <a:ext uri="{FF2B5EF4-FFF2-40B4-BE49-F238E27FC236}">
-                <a16:creationId xmlns:a16="http://schemas.microsoft.com/office/drawing/2014/main" id="{FCCF7C9E-8414-43FE-8B14-ADCE289174CB}"/>
+                <a16:creationId xmlns:a16="http://schemas.microsoft.com/office/drawing/2014/main" id="{DDE56349-92D3-41C9-917E-646DE245D56E}"/>
               </a:ext>
             </a:extLst>
           </p:cNvPr>
@@ -15150,7 +15312,7 @@
           <p:cNvPr id="11" name="body">
             <a:extLst xmlns:a="http://schemas.openxmlformats.org/drawingml/2006/main">
               <a:ext uri="{FF2B5EF4-FFF2-40B4-BE49-F238E27FC236}">
-                <a16:creationId xmlns:a16="http://schemas.microsoft.com/office/drawing/2014/main" id="{FDA74C3F-91FA-43F1-A3D5-869505AAB59F}"/>
+                <a16:creationId xmlns:a16="http://schemas.microsoft.com/office/drawing/2014/main" id="{3FB08C1F-EFCE-4841-AA49-45A684FD1FEC}"/>
               </a:ext>
             </a:extLst>
           </p:cNvPr>
@@ -15312,7 +15474,7 @@
           <p:cNvPr id="12" name="body">
             <a:extLst xmlns:a="http://schemas.openxmlformats.org/drawingml/2006/main">
               <a:ext uri="{FF2B5EF4-FFF2-40B4-BE49-F238E27FC236}">
-                <a16:creationId xmlns:a16="http://schemas.microsoft.com/office/drawing/2014/main" id="{11CB8FCF-0C7A-4D91-AD46-CD7DA7B4D115}"/>
+                <a16:creationId xmlns:a16="http://schemas.microsoft.com/office/drawing/2014/main" id="{66865212-3690-48FA-B430-89628CA7C1F2}"/>
               </a:ext>
             </a:extLst>
           </p:cNvPr>
@@ -15474,7 +15636,7 @@
           <p:cNvPr id="13" name="body">
             <a:extLst xmlns:a="http://schemas.openxmlformats.org/drawingml/2006/main">
               <a:ext uri="{FF2B5EF4-FFF2-40B4-BE49-F238E27FC236}">
-                <a16:creationId xmlns:a16="http://schemas.microsoft.com/office/drawing/2014/main" id="{9ABC4BA5-AFEB-483C-808B-664F7358817E}"/>
+                <a16:creationId xmlns:a16="http://schemas.microsoft.com/office/drawing/2014/main" id="{784529D1-31B0-43E2-B4F5-8E949B343BE7}"/>
               </a:ext>
             </a:extLst>
           </p:cNvPr>
@@ -15636,7 +15798,7 @@
           <p:cNvPr id="14" name="body">
             <a:extLst xmlns:a="http://schemas.openxmlformats.org/drawingml/2006/main">
               <a:ext uri="{FF2B5EF4-FFF2-40B4-BE49-F238E27FC236}">
-                <a16:creationId xmlns:a16="http://schemas.microsoft.com/office/drawing/2014/main" id="{74B78859-01C5-4E18-A3DB-EBBD6136232D}"/>
+                <a16:creationId xmlns:a16="http://schemas.microsoft.com/office/drawing/2014/main" id="{15C9669F-447D-4A11-AFD3-09A2E173DEE4}"/>
               </a:ext>
             </a:extLst>
           </p:cNvPr>
@@ -15798,7 +15960,7 @@
           <p:cNvPr id="15" name="body">
             <a:extLst xmlns:a="http://schemas.openxmlformats.org/drawingml/2006/main">
               <a:ext uri="{FF2B5EF4-FFF2-40B4-BE49-F238E27FC236}">
-                <a16:creationId xmlns:a16="http://schemas.microsoft.com/office/drawing/2014/main" id="{364AC9C4-B79A-4AE5-8E75-B5E842A95911}"/>
+                <a16:creationId xmlns:a16="http://schemas.microsoft.com/office/drawing/2014/main" id="{121E8C67-BA9E-4F03-8E53-13FAEB0DCCE2}"/>
               </a:ext>
             </a:extLst>
           </p:cNvPr>
@@ -15960,7 +16122,7 @@
           <p:cNvPr id="16" name="">
             <a:extLst xmlns:a="http://schemas.openxmlformats.org/drawingml/2006/main">
               <a:ext uri="{FF2B5EF4-FFF2-40B4-BE49-F238E27FC236}">
-                <a16:creationId xmlns:a16="http://schemas.microsoft.com/office/drawing/2014/main" id="{4AED8EFE-6AE5-40A9-8A1D-B482B8901BE8}"/>
+                <a16:creationId xmlns:a16="http://schemas.microsoft.com/office/drawing/2014/main" id="{D435B813-5E60-430F-AF7D-699E6C16A144}"/>
               </a:ext>
             </a:extLst>
           </p:cNvPr>
@@ -15970,7 +16132,7 @@
           <p:nvPr/>
         </p:nvPicPr>
         <p:blipFill>
-          <a:blip xmlns:r="http://schemas.openxmlformats.org/officeDocument/2006/relationships" xmlns:a="http://schemas.openxmlformats.org/drawingml/2006/main" r:embed="Rdf1a6ceaaa0a40e6"/>
+          <a:blip xmlns:r="http://schemas.openxmlformats.org/officeDocument/2006/relationships" xmlns:a="http://schemas.openxmlformats.org/drawingml/2006/main" r:embed="R76dae6be98d442d1"/>
           <a:stretch xmlns:a="http://schemas.openxmlformats.org/drawingml/2006/main"/>
         </p:blipFill>
         <p:spPr>
@@ -15988,7 +16150,7 @@
           <p:cNvPr id="17" name="source-note">
             <a:extLst xmlns:a="http://schemas.openxmlformats.org/drawingml/2006/main">
               <a:ext uri="{FF2B5EF4-FFF2-40B4-BE49-F238E27FC236}">
-                <a16:creationId xmlns:a16="http://schemas.microsoft.com/office/drawing/2014/main" id="{585BB2BC-D236-462C-A47D-2E41F22A09D1}"/>
+                <a16:creationId xmlns:a16="http://schemas.microsoft.com/office/drawing/2014/main" id="{FB3B495B-5FB9-42AF-87F0-087F29C6F8E2}"/>
               </a:ext>
             </a:extLst>
           </p:cNvPr>
@@ -16148,7 +16310,7 @@
     </p:spTree>
     <p:extLst>
       <p:ext uri="{BB962C8B-B14F-4D97-AF65-F5344CB8AC3E}">
-        <p14:creationId xmlns:p14="http://schemas.microsoft.com/office/powerpoint/2010/main" val="801653944"/>
+        <p14:creationId xmlns:p14="http://schemas.microsoft.com/office/powerpoint/2010/main" val="1801515763"/>
       </p:ext>
     </p:extLst>
   </p:cSld>
@@ -16179,7 +16341,7 @@
           <p:cNvPr id="8" name="">
             <a:extLst xmlns:a="http://schemas.openxmlformats.org/drawingml/2006/main">
               <a:ext uri="{FF2B5EF4-FFF2-40B4-BE49-F238E27FC236}">
-                <a16:creationId xmlns:a16="http://schemas.microsoft.com/office/drawing/2014/main" id="{096B1F61-FB27-4D65-873B-7CB74130E10C}"/>
+                <a16:creationId xmlns:a16="http://schemas.microsoft.com/office/drawing/2014/main" id="{91EAC45D-C2F5-44BB-AC3C-1521E5FB7BF9}"/>
               </a:ext>
             </a:extLst>
           </p:cNvPr>
@@ -16189,10 +16351,10 @@
           <p:nvPr/>
         </p:nvPicPr>
         <p:blipFill>
-          <a:blip xmlns:r="http://schemas.openxmlformats.org/officeDocument/2006/relationships" xmlns:a="http://schemas.openxmlformats.org/drawingml/2006/main" r:embed="R2267f7090f6842ae">
+          <a:blip xmlns:r="http://schemas.openxmlformats.org/officeDocument/2006/relationships" xmlns:a="http://schemas.openxmlformats.org/drawingml/2006/main" r:embed="R1ed75f54b08f4a15">
             <a:extLst>
               <a:ext uri="{96DAC541-7B7A-43D3-8B79-37D633B846F1}">
-                <asvg:svgBlip xmlns:asvg="http://schemas.microsoft.com/office/drawing/2016/SVG/main" r:embed="R5856cdae123e4802"/>
+                <asvg:svgBlip xmlns:asvg="http://schemas.microsoft.com/office/drawing/2016/SVG/main" r:embed="Rdc833d34c6d84618"/>
               </a:ext>
             </a:extLst>
           </a:blip>
@@ -16213,7 +16375,7 @@
           <p:cNvPr id="2" name="title">
             <a:extLst xmlns:a="http://schemas.openxmlformats.org/drawingml/2006/main">
               <a:ext uri="{FF2B5EF4-FFF2-40B4-BE49-F238E27FC236}">
-                <a16:creationId xmlns:a16="http://schemas.microsoft.com/office/drawing/2014/main" id="{224575F5-7674-4041-91F6-C74255BB388E}"/>
+                <a16:creationId xmlns:a16="http://schemas.microsoft.com/office/drawing/2014/main" id="{5A08F8D9-2070-4947-80C8-8B05F569FB64}"/>
               </a:ext>
             </a:extLst>
           </p:cNvPr>
@@ -16375,7 +16537,7 @@
           <p:cNvPr id="3" name="page">
             <a:extLst xmlns:a="http://schemas.openxmlformats.org/drawingml/2006/main">
               <a:ext uri="{FF2B5EF4-FFF2-40B4-BE49-F238E27FC236}">
-                <a16:creationId xmlns:a16="http://schemas.microsoft.com/office/drawing/2014/main" id="{0D25A90C-81D4-4935-911B-1B24E5F7796C}"/>
+                <a16:creationId xmlns:a16="http://schemas.microsoft.com/office/drawing/2014/main" id="{16C75041-3699-4A5C-8EE5-F20E9E6D52DB}"/>
               </a:ext>
             </a:extLst>
           </p:cNvPr>
@@ -16531,7 +16693,7 @@
           <p:cNvPr id="4" name="">
             <a:extLst xmlns:a="http://schemas.openxmlformats.org/drawingml/2006/main">
               <a:ext uri="{FF2B5EF4-FFF2-40B4-BE49-F238E27FC236}">
-                <a16:creationId xmlns:a16="http://schemas.microsoft.com/office/drawing/2014/main" id="{C4184E10-C691-4A29-B0C9-F2C19BE95DA2}"/>
+                <a16:creationId xmlns:a16="http://schemas.microsoft.com/office/drawing/2014/main" id="{4A8D471C-ED73-4C39-BCD3-F5D60CBEF23F}"/>
               </a:ext>
             </a:extLst>
           </p:cNvPr>
@@ -16541,7 +16703,7 @@
           <p:nvPr/>
         </p:nvPicPr>
         <p:blipFill>
-          <a:blip xmlns:r="http://schemas.openxmlformats.org/officeDocument/2006/relationships" xmlns:a="http://schemas.openxmlformats.org/drawingml/2006/main" r:embed="R1697506f61d04ee5"/>
+          <a:blip xmlns:r="http://schemas.openxmlformats.org/officeDocument/2006/relationships" xmlns:a="http://schemas.openxmlformats.org/drawingml/2006/main" r:embed="Rd4a7ab1d8ac843d2"/>
           <a:stretch xmlns:a="http://schemas.openxmlformats.org/drawingml/2006/main"/>
         </p:blipFill>
         <p:spPr>
@@ -16559,7 +16721,7 @@
           <p:cNvPr id="5" name="">
             <a:extLst xmlns:a="http://schemas.openxmlformats.org/drawingml/2006/main">
               <a:ext uri="{FF2B5EF4-FFF2-40B4-BE49-F238E27FC236}">
-                <a16:creationId xmlns:a16="http://schemas.microsoft.com/office/drawing/2014/main" id="{284BA8D8-0A3D-4992-8EE9-D0D2CCB96D0A}"/>
+                <a16:creationId xmlns:a16="http://schemas.microsoft.com/office/drawing/2014/main" id="{CDE1E9C5-E011-438E-A10F-4000A9F1AFB7}"/>
               </a:ext>
             </a:extLst>
           </p:cNvPr>
@@ -16569,7 +16731,7 @@
           <p:nvPr/>
         </p:nvPicPr>
         <p:blipFill>
-          <a:blip xmlns:r="http://schemas.openxmlformats.org/officeDocument/2006/relationships" xmlns:a="http://schemas.openxmlformats.org/drawingml/2006/main" r:embed="R9cfbb7befc88416f"/>
+          <a:blip xmlns:r="http://schemas.openxmlformats.org/officeDocument/2006/relationships" xmlns:a="http://schemas.openxmlformats.org/drawingml/2006/main" r:embed="R491b0286f12a4481"/>
           <a:stretch xmlns:a="http://schemas.openxmlformats.org/drawingml/2006/main"/>
         </p:blipFill>
         <p:spPr>
@@ -16587,7 +16749,7 @@
           <p:cNvPr id="6" name="body">
             <a:extLst xmlns:a="http://schemas.openxmlformats.org/drawingml/2006/main">
               <a:ext uri="{FF2B5EF4-FFF2-40B4-BE49-F238E27FC236}">
-                <a16:creationId xmlns:a16="http://schemas.microsoft.com/office/drawing/2014/main" id="{2A91A674-BD4D-4D04-9E95-9B84DE0616C0}"/>
+                <a16:creationId xmlns:a16="http://schemas.microsoft.com/office/drawing/2014/main" id="{5D7D7C08-B342-43C7-900A-B22A142A6E9F}"/>
               </a:ext>
             </a:extLst>
           </p:cNvPr>
@@ -16776,7 +16938,7 @@
           <p:cNvPr id="7" name="body">
             <a:extLst xmlns:a="http://schemas.openxmlformats.org/drawingml/2006/main">
               <a:ext uri="{FF2B5EF4-FFF2-40B4-BE49-F238E27FC236}">
-                <a16:creationId xmlns:a16="http://schemas.microsoft.com/office/drawing/2014/main" id="{D62FFE0A-8468-4EE0-A7C0-71AF280E0344}"/>
+                <a16:creationId xmlns:a16="http://schemas.microsoft.com/office/drawing/2014/main" id="{61C74EFF-A117-481A-B335-637D92499424}"/>
               </a:ext>
             </a:extLst>
           </p:cNvPr>
@@ -17000,7 +17162,7 @@
     </p:spTree>
     <p:extLst>
       <p:ext uri="{BB962C8B-B14F-4D97-AF65-F5344CB8AC3E}">
-        <p14:creationId xmlns:p14="http://schemas.microsoft.com/office/powerpoint/2010/main" val="361060462"/>
+        <p14:creationId xmlns:p14="http://schemas.microsoft.com/office/powerpoint/2010/main" val="201970832"/>
       </p:ext>
     </p:extLst>
   </p:cSld>
@@ -17031,7 +17193,7 @@
           <p:cNvPr id="8" name="">
             <a:extLst xmlns:a="http://schemas.openxmlformats.org/drawingml/2006/main">
               <a:ext uri="{FF2B5EF4-FFF2-40B4-BE49-F238E27FC236}">
-                <a16:creationId xmlns:a16="http://schemas.microsoft.com/office/drawing/2014/main" id="{43FB47E5-CD66-448B-8EAC-F6CFB949F016}"/>
+                <a16:creationId xmlns:a16="http://schemas.microsoft.com/office/drawing/2014/main" id="{CA5244EB-012D-4CBE-9203-9FE796DF75A7}"/>
               </a:ext>
             </a:extLst>
           </p:cNvPr>
@@ -17041,10 +17203,10 @@
           <p:nvPr/>
         </p:nvPicPr>
         <p:blipFill>
-          <a:blip xmlns:r="http://schemas.openxmlformats.org/officeDocument/2006/relationships" xmlns:a="http://schemas.openxmlformats.org/drawingml/2006/main" r:embed="Rf9d89929c4fd4b45">
+          <a:blip xmlns:r="http://schemas.openxmlformats.org/officeDocument/2006/relationships" xmlns:a="http://schemas.openxmlformats.org/drawingml/2006/main" r:embed="Ra4ee8eaf03844052">
             <a:extLst>
               <a:ext uri="{96DAC541-7B7A-43D3-8B79-37D633B846F1}">
-                <asvg:svgBlip xmlns:asvg="http://schemas.microsoft.com/office/drawing/2016/SVG/main" r:embed="Rc37eb143ad8f477d"/>
+                <asvg:svgBlip xmlns:asvg="http://schemas.microsoft.com/office/drawing/2016/SVG/main" r:embed="R94b1b4f21e0241a5"/>
               </a:ext>
             </a:extLst>
           </a:blip>
@@ -17065,7 +17227,7 @@
           <p:cNvPr id="2" name="title">
             <a:extLst xmlns:a="http://schemas.openxmlformats.org/drawingml/2006/main">
               <a:ext uri="{FF2B5EF4-FFF2-40B4-BE49-F238E27FC236}">
-                <a16:creationId xmlns:a16="http://schemas.microsoft.com/office/drawing/2014/main" id="{24E8954E-5D40-4264-BE76-B6373282F8C8}"/>
+                <a16:creationId xmlns:a16="http://schemas.microsoft.com/office/drawing/2014/main" id="{0A0364A8-6A25-41BC-907F-05B20FF9D8C3}"/>
               </a:ext>
             </a:extLst>
           </p:cNvPr>
@@ -17227,7 +17389,7 @@
           <p:cNvPr id="3" name="page">
             <a:extLst xmlns:a="http://schemas.openxmlformats.org/drawingml/2006/main">
               <a:ext uri="{FF2B5EF4-FFF2-40B4-BE49-F238E27FC236}">
-                <a16:creationId xmlns:a16="http://schemas.microsoft.com/office/drawing/2014/main" id="{1CA14E3E-DE47-4351-B2AC-CEB19EAD39DA}"/>
+                <a16:creationId xmlns:a16="http://schemas.microsoft.com/office/drawing/2014/main" id="{C26AA3CD-9208-4356-BAA0-28FA3D81EC88}"/>
               </a:ext>
             </a:extLst>
           </p:cNvPr>
@@ -17383,7 +17545,7 @@
           <p:cNvPr id="4" name="">
             <a:extLst xmlns:a="http://schemas.openxmlformats.org/drawingml/2006/main">
               <a:ext uri="{FF2B5EF4-FFF2-40B4-BE49-F238E27FC236}">
-                <a16:creationId xmlns:a16="http://schemas.microsoft.com/office/drawing/2014/main" id="{C18E9383-5489-4A13-9F1B-0F301A5F7B2C}"/>
+                <a16:creationId xmlns:a16="http://schemas.microsoft.com/office/drawing/2014/main" id="{6AA7A09B-9049-4288-9B0D-8943FA0F4E59}"/>
               </a:ext>
             </a:extLst>
           </p:cNvPr>
@@ -17393,7 +17555,7 @@
           <p:nvPr/>
         </p:nvPicPr>
         <p:blipFill>
-          <a:blip xmlns:r="http://schemas.openxmlformats.org/officeDocument/2006/relationships" xmlns:a="http://schemas.openxmlformats.org/drawingml/2006/main" r:embed="Reb9e9007d2194223"/>
+          <a:blip xmlns:r="http://schemas.openxmlformats.org/officeDocument/2006/relationships" xmlns:a="http://schemas.openxmlformats.org/drawingml/2006/main" r:embed="R7e421a90b4e54d2b"/>
           <a:stretch xmlns:a="http://schemas.openxmlformats.org/drawingml/2006/main"/>
         </p:blipFill>
         <p:spPr>
@@ -17411,7 +17573,7 @@
           <p:cNvPr id="5" name="body">
             <a:extLst xmlns:a="http://schemas.openxmlformats.org/drawingml/2006/main">
               <a:ext uri="{FF2B5EF4-FFF2-40B4-BE49-F238E27FC236}">
-                <a16:creationId xmlns:a16="http://schemas.microsoft.com/office/drawing/2014/main" id="{0421B242-A370-4F63-AE3C-BC793B2CC2FB}"/>
+                <a16:creationId xmlns:a16="http://schemas.microsoft.com/office/drawing/2014/main" id="{D6FAF70D-4359-4079-93D7-2CFD196541F6}"/>
               </a:ext>
             </a:extLst>
           </p:cNvPr>
@@ -17600,7 +17762,7 @@
           <p:cNvPr id="6" name="body">
             <a:extLst xmlns:a="http://schemas.openxmlformats.org/drawingml/2006/main">
               <a:ext uri="{FF2B5EF4-FFF2-40B4-BE49-F238E27FC236}">
-                <a16:creationId xmlns:a16="http://schemas.microsoft.com/office/drawing/2014/main" id="{C396A489-BA4D-452A-B644-BE8AF8CEE069}"/>
+                <a16:creationId xmlns:a16="http://schemas.microsoft.com/office/drawing/2014/main" id="{07BEF6C9-4E62-4E2E-811B-05A36D97DDB0}"/>
               </a:ext>
             </a:extLst>
           </p:cNvPr>
@@ -17794,7 +17956,7 @@
           <p:cNvPr id="7" name="source-note">
             <a:extLst xmlns:a="http://schemas.openxmlformats.org/drawingml/2006/main">
               <a:ext uri="{FF2B5EF4-FFF2-40B4-BE49-F238E27FC236}">
-                <a16:creationId xmlns:a16="http://schemas.microsoft.com/office/drawing/2014/main" id="{F5BCB1D4-8467-4827-B9E8-E226D23F983E}"/>
+                <a16:creationId xmlns:a16="http://schemas.microsoft.com/office/drawing/2014/main" id="{282FA67B-B7D5-45DD-AD90-9AC669789A12}"/>
               </a:ext>
             </a:extLst>
           </p:cNvPr>
@@ -17954,7 +18116,7 @@
     </p:spTree>
     <p:extLst>
       <p:ext uri="{BB962C8B-B14F-4D97-AF65-F5344CB8AC3E}">
-        <p14:creationId xmlns:p14="http://schemas.microsoft.com/office/powerpoint/2010/main" val="72472188"/>
+        <p14:creationId xmlns:p14="http://schemas.microsoft.com/office/powerpoint/2010/main" val="3077326"/>
       </p:ext>
     </p:extLst>
   </p:cSld>
@@ -17985,7 +18147,7 @@
           <p:cNvPr id="10" name="">
             <a:extLst xmlns:a="http://schemas.openxmlformats.org/drawingml/2006/main">
               <a:ext uri="{FF2B5EF4-FFF2-40B4-BE49-F238E27FC236}">
-                <a16:creationId xmlns:a16="http://schemas.microsoft.com/office/drawing/2014/main" id="{0A8A593E-3A4F-46CA-9733-C36D69DE000A}"/>
+                <a16:creationId xmlns:a16="http://schemas.microsoft.com/office/drawing/2014/main" id="{80CF9A73-0EEA-4BA9-89E0-70D1368BCF98}"/>
               </a:ext>
             </a:extLst>
           </p:cNvPr>
@@ -17995,10 +18157,10 @@
           <p:nvPr/>
         </p:nvPicPr>
         <p:blipFill>
-          <a:blip xmlns:r="http://schemas.openxmlformats.org/officeDocument/2006/relationships" xmlns:a="http://schemas.openxmlformats.org/drawingml/2006/main" r:embed="R9cbe5ebb9e5e4542">
+          <a:blip xmlns:r="http://schemas.openxmlformats.org/officeDocument/2006/relationships" xmlns:a="http://schemas.openxmlformats.org/drawingml/2006/main" r:embed="R9b4fbdb1fb44434b">
             <a:extLst>
               <a:ext uri="{96DAC541-7B7A-43D3-8B79-37D633B846F1}">
-                <asvg:svgBlip xmlns:asvg="http://schemas.microsoft.com/office/drawing/2016/SVG/main" r:embed="Rc83c964b43e344df"/>
+                <asvg:svgBlip xmlns:asvg="http://schemas.microsoft.com/office/drawing/2016/SVG/main" r:embed="Rce378ebae1f540d6"/>
               </a:ext>
             </a:extLst>
           </a:blip>
@@ -18019,7 +18181,7 @@
           <p:cNvPr id="2" name="title">
             <a:extLst xmlns:a="http://schemas.openxmlformats.org/drawingml/2006/main">
               <a:ext uri="{FF2B5EF4-FFF2-40B4-BE49-F238E27FC236}">
-                <a16:creationId xmlns:a16="http://schemas.microsoft.com/office/drawing/2014/main" id="{47BE81D9-DA56-4716-BF2D-AED790BEE61F}"/>
+                <a16:creationId xmlns:a16="http://schemas.microsoft.com/office/drawing/2014/main" id="{101FA226-1000-4772-92E7-15C361FC2DAD}"/>
               </a:ext>
             </a:extLst>
           </p:cNvPr>
@@ -18181,7 +18343,7 @@
           <p:cNvPr id="3" name="page">
             <a:extLst xmlns:a="http://schemas.openxmlformats.org/drawingml/2006/main">
               <a:ext uri="{FF2B5EF4-FFF2-40B4-BE49-F238E27FC236}">
-                <a16:creationId xmlns:a16="http://schemas.microsoft.com/office/drawing/2014/main" id="{F340C217-D10B-44AC-A6EC-8AABBD68C870}"/>
+                <a16:creationId xmlns:a16="http://schemas.microsoft.com/office/drawing/2014/main" id="{FAC532EC-EBAD-437E-BCB3-212D5F373DA5}"/>
               </a:ext>
             </a:extLst>
           </p:cNvPr>
@@ -18337,7 +18499,7 @@
           <p:cNvPr id="4" name="body">
             <a:extLst xmlns:a="http://schemas.openxmlformats.org/drawingml/2006/main">
               <a:ext uri="{FF2B5EF4-FFF2-40B4-BE49-F238E27FC236}">
-                <a16:creationId xmlns:a16="http://schemas.microsoft.com/office/drawing/2014/main" id="{7012B97F-6853-44C4-9665-4BE9DFC763C2}"/>
+                <a16:creationId xmlns:a16="http://schemas.microsoft.com/office/drawing/2014/main" id="{C6737D77-E8A5-4EC4-959E-AF8293557C37}"/>
               </a:ext>
             </a:extLst>
           </p:cNvPr>
@@ -18499,7 +18661,7 @@
           <p:cNvPr id="5" name="body">
             <a:extLst xmlns:a="http://schemas.openxmlformats.org/drawingml/2006/main">
               <a:ext uri="{FF2B5EF4-FFF2-40B4-BE49-F238E27FC236}">
-                <a16:creationId xmlns:a16="http://schemas.microsoft.com/office/drawing/2014/main" id="{37D63134-166F-42C0-87D6-E1E866949445}"/>
+                <a16:creationId xmlns:a16="http://schemas.microsoft.com/office/drawing/2014/main" id="{5B01CBF8-A698-4209-8149-3113DCB34F3E}"/>
               </a:ext>
             </a:extLst>
           </p:cNvPr>
@@ -18511,7 +18673,7 @@
         <p:spPr>
           <a:xfrm xmlns:a="http://schemas.openxmlformats.org/drawingml/2006/main">
             <a:off x="609600" y="2914650"/>
-            <a:ext cx="3952875" cy="809625"/>
+            <a:ext cx="3952875" cy="952500"/>
           </a:xfrm>
           <a:prstGeom xmlns:a="http://schemas.openxmlformats.org/drawingml/2006/main" prst="rect">
             <a:avLst/>
@@ -18651,7 +18813,34 @@
                 <a:ea typeface="Be Vietnam Pro"/>
                 <a:cs typeface="Be Vietnam Pro"/>
               </a:rPr>
-              <a:t>Stored off-chain through IPFS and Pinata.</a:t>
+              <a:t>Supabase Storage in the demo.</a:t>
+            </a:r>
+          </a:p>
+          <a:p xmlns:a="http://schemas.openxmlformats.org/drawingml/2006/main">
+            <a:pPr>
+              <a:lnSpc>
+                <a:spcPct val="116000"/>
+              </a:lnSpc>
+              <a:buNone/>
+              <a:defRPr sz="2025" b="0">
+                <a:solidFill>
+                  <a:srgbClr val="665F68"/>
+                </a:solidFill>
+                <a:latin typeface="Be Vietnam Pro"/>
+                <a:ea typeface="Be Vietnam Pro"/>
+                <a:cs typeface="Be Vietnam Pro"/>
+              </a:defRPr>
+            </a:pPr>
+            <a:r>
+              <a:rPr sz="2025" b="0">
+                <a:solidFill>
+                  <a:srgbClr val="665F68"/>
+                </a:solidFill>
+                <a:latin typeface="Be Vietnam Pro"/>
+                <a:ea typeface="Be Vietnam Pro"/>
+                <a:cs typeface="Be Vietnam Pro"/>
+              </a:rPr>
+              <a:t>IPFS/Pinata support in code.</a:t>
             </a:r>
           </a:p>
         </p:txBody>
@@ -18661,7 +18850,7 @@
           <p:cNvPr id="6" name="body">
             <a:extLst xmlns:a="http://schemas.openxmlformats.org/drawingml/2006/main">
               <a:ext uri="{FF2B5EF4-FFF2-40B4-BE49-F238E27FC236}">
-                <a16:creationId xmlns:a16="http://schemas.microsoft.com/office/drawing/2014/main" id="{4F13DBA1-2159-4DA0-82AE-1E213C6C3804}"/>
+                <a16:creationId xmlns:a16="http://schemas.microsoft.com/office/drawing/2014/main" id="{F09FBD5A-FF2E-488D-A6B1-8B639E05AC95}"/>
               </a:ext>
             </a:extLst>
           </p:cNvPr>
@@ -18823,7 +19012,7 @@
           <p:cNvPr id="7" name="body">
             <a:extLst xmlns:a="http://schemas.openxmlformats.org/drawingml/2006/main">
               <a:ext uri="{FF2B5EF4-FFF2-40B4-BE49-F238E27FC236}">
-                <a16:creationId xmlns:a16="http://schemas.microsoft.com/office/drawing/2014/main" id="{26C80C30-90DA-4184-9659-2A57A1B1925E}"/>
+                <a16:creationId xmlns:a16="http://schemas.microsoft.com/office/drawing/2014/main" id="{5C936461-38DB-4C42-B012-5293984B2EA1}"/>
               </a:ext>
             </a:extLst>
           </p:cNvPr>
@@ -18985,7 +19174,7 @@
           <p:cNvPr id="8" name="">
             <a:extLst xmlns:a="http://schemas.openxmlformats.org/drawingml/2006/main">
               <a:ext uri="{FF2B5EF4-FFF2-40B4-BE49-F238E27FC236}">
-                <a16:creationId xmlns:a16="http://schemas.microsoft.com/office/drawing/2014/main" id="{9D03079C-C928-48D9-9A18-B7E230050BC0}"/>
+                <a16:creationId xmlns:a16="http://schemas.microsoft.com/office/drawing/2014/main" id="{52B22DE7-F70F-4575-B71E-A23947492FE2}"/>
               </a:ext>
             </a:extLst>
           </p:cNvPr>
@@ -18995,7 +19184,7 @@
           <p:nvPr/>
         </p:nvPicPr>
         <p:blipFill>
-          <a:blip xmlns:r="http://schemas.openxmlformats.org/officeDocument/2006/relationships" xmlns:a="http://schemas.openxmlformats.org/drawingml/2006/main" r:embed="Rbe5c7adbdd784120"/>
+          <a:blip xmlns:r="http://schemas.openxmlformats.org/officeDocument/2006/relationships" xmlns:a="http://schemas.openxmlformats.org/drawingml/2006/main" r:embed="R0a32ae08891e4c93"/>
           <a:stretch xmlns:a="http://schemas.openxmlformats.org/drawingml/2006/main"/>
         </p:blipFill>
         <p:spPr>
@@ -19013,7 +19202,7 @@
           <p:cNvPr id="9" name="source-note">
             <a:extLst xmlns:a="http://schemas.openxmlformats.org/drawingml/2006/main">
               <a:ext uri="{FF2B5EF4-FFF2-40B4-BE49-F238E27FC236}">
-                <a16:creationId xmlns:a16="http://schemas.microsoft.com/office/drawing/2014/main" id="{811E4032-BDC9-4E8F-B7AC-B72D0F79938A}"/>
+                <a16:creationId xmlns:a16="http://schemas.microsoft.com/office/drawing/2014/main" id="{CEA4C0BD-7DA6-4F3B-8C36-11B7C7DA5FBD}"/>
               </a:ext>
             </a:extLst>
           </p:cNvPr>
@@ -19173,7 +19362,7 @@
     </p:spTree>
     <p:extLst>
       <p:ext uri="{BB962C8B-B14F-4D97-AF65-F5344CB8AC3E}">
-        <p14:creationId xmlns:p14="http://schemas.microsoft.com/office/powerpoint/2010/main" val="114664749"/>
+        <p14:creationId xmlns:p14="http://schemas.microsoft.com/office/powerpoint/2010/main" val="1190115989"/>
       </p:ext>
     </p:extLst>
   </p:cSld>
@@ -19204,7 +19393,7 @@
           <p:cNvPr id="16" name="">
             <a:extLst xmlns:a="http://schemas.openxmlformats.org/drawingml/2006/main">
               <a:ext uri="{FF2B5EF4-FFF2-40B4-BE49-F238E27FC236}">
-                <a16:creationId xmlns:a16="http://schemas.microsoft.com/office/drawing/2014/main" id="{CDC7206F-1F55-4348-9122-F98798CE2F11}"/>
+                <a16:creationId xmlns:a16="http://schemas.microsoft.com/office/drawing/2014/main" id="{C6C31FC9-9139-4093-BAE1-90B353A33C40}"/>
               </a:ext>
             </a:extLst>
           </p:cNvPr>
@@ -19214,10 +19403,10 @@
           <p:nvPr/>
         </p:nvPicPr>
         <p:blipFill>
-          <a:blip xmlns:r="http://schemas.openxmlformats.org/officeDocument/2006/relationships" xmlns:a="http://schemas.openxmlformats.org/drawingml/2006/main" r:embed="Rb234f6e9681240a5">
+          <a:blip xmlns:r="http://schemas.openxmlformats.org/officeDocument/2006/relationships" xmlns:a="http://schemas.openxmlformats.org/drawingml/2006/main" r:embed="R516ea89f15e54a99">
             <a:extLst>
               <a:ext uri="{96DAC541-7B7A-43D3-8B79-37D633B846F1}">
-                <asvg:svgBlip xmlns:asvg="http://schemas.microsoft.com/office/drawing/2016/SVG/main" r:embed="Rb2bd85ffcb8a4b94"/>
+                <asvg:svgBlip xmlns:asvg="http://schemas.microsoft.com/office/drawing/2016/SVG/main" r:embed="R92a33ab6e6a04af4"/>
               </a:ext>
             </a:extLst>
           </a:blip>
@@ -19238,7 +19427,7 @@
           <p:cNvPr id="2" name="title">
             <a:extLst xmlns:a="http://schemas.openxmlformats.org/drawingml/2006/main">
               <a:ext uri="{FF2B5EF4-FFF2-40B4-BE49-F238E27FC236}">
-                <a16:creationId xmlns:a16="http://schemas.microsoft.com/office/drawing/2014/main" id="{00E1F1DB-3645-4FEE-8D67-B78BD5270BB8}"/>
+                <a16:creationId xmlns:a16="http://schemas.microsoft.com/office/drawing/2014/main" id="{D9792B7E-A193-4B12-9170-F58C2DF4E4CE}"/>
               </a:ext>
             </a:extLst>
           </p:cNvPr>
@@ -19400,7 +19589,7 @@
           <p:cNvPr id="3" name="page">
             <a:extLst xmlns:a="http://schemas.openxmlformats.org/drawingml/2006/main">
               <a:ext uri="{FF2B5EF4-FFF2-40B4-BE49-F238E27FC236}">
-                <a16:creationId xmlns:a16="http://schemas.microsoft.com/office/drawing/2014/main" id="{552285D1-F2B3-4343-A5C4-01DD1EB64E86}"/>
+                <a16:creationId xmlns:a16="http://schemas.microsoft.com/office/drawing/2014/main" id="{6EAC37AD-552D-4F51-A779-159E13326F12}"/>
               </a:ext>
             </a:extLst>
           </p:cNvPr>
@@ -19556,7 +19745,7 @@
           <p:cNvPr id="4" name="body">
             <a:extLst xmlns:a="http://schemas.openxmlformats.org/drawingml/2006/main">
               <a:ext uri="{FF2B5EF4-FFF2-40B4-BE49-F238E27FC236}">
-                <a16:creationId xmlns:a16="http://schemas.microsoft.com/office/drawing/2014/main" id="{1E7F035F-EAF6-47A7-AA66-E5E5ED8A2CB5}"/>
+                <a16:creationId xmlns:a16="http://schemas.microsoft.com/office/drawing/2014/main" id="{84211834-454C-4009-8FB5-B2A7DB144E97}"/>
               </a:ext>
             </a:extLst>
           </p:cNvPr>
@@ -19718,7 +19907,7 @@
           <p:cNvPr id="5" name="body">
             <a:extLst xmlns:a="http://schemas.openxmlformats.org/drawingml/2006/main">
               <a:ext uri="{FF2B5EF4-FFF2-40B4-BE49-F238E27FC236}">
-                <a16:creationId xmlns:a16="http://schemas.microsoft.com/office/drawing/2014/main" id="{2E9DB462-87CA-46A6-A382-A668A22C0F08}"/>
+                <a16:creationId xmlns:a16="http://schemas.microsoft.com/office/drawing/2014/main" id="{1D9F02FB-1A97-4BA2-9E0E-D3A9226F81F9}"/>
               </a:ext>
             </a:extLst>
           </p:cNvPr>
@@ -19880,7 +20069,7 @@
           <p:cNvPr id="6" name="body">
             <a:extLst xmlns:a="http://schemas.openxmlformats.org/drawingml/2006/main">
               <a:ext uri="{FF2B5EF4-FFF2-40B4-BE49-F238E27FC236}">
-                <a16:creationId xmlns:a16="http://schemas.microsoft.com/office/drawing/2014/main" id="{FFFC6247-B76C-43CB-AF8A-DBB140763976}"/>
+                <a16:creationId xmlns:a16="http://schemas.microsoft.com/office/drawing/2014/main" id="{B16E2593-5747-454A-BB83-904AF3FA24CA}"/>
               </a:ext>
             </a:extLst>
           </p:cNvPr>
@@ -20042,7 +20231,7 @@
           <p:cNvPr id="7" name="body">
             <a:extLst xmlns:a="http://schemas.openxmlformats.org/drawingml/2006/main">
               <a:ext uri="{FF2B5EF4-FFF2-40B4-BE49-F238E27FC236}">
-                <a16:creationId xmlns:a16="http://schemas.microsoft.com/office/drawing/2014/main" id="{35910636-6D31-4D8F-80D3-11508A2D09F7}"/>
+                <a16:creationId xmlns:a16="http://schemas.microsoft.com/office/drawing/2014/main" id="{5CF7CE6D-9EEF-4114-8161-DFB51791BFF3}"/>
               </a:ext>
             </a:extLst>
           </p:cNvPr>
@@ -20204,7 +20393,7 @@
           <p:cNvPr id="8" name="body">
             <a:extLst xmlns:a="http://schemas.openxmlformats.org/drawingml/2006/main">
               <a:ext uri="{FF2B5EF4-FFF2-40B4-BE49-F238E27FC236}">
-                <a16:creationId xmlns:a16="http://schemas.microsoft.com/office/drawing/2014/main" id="{9D97AA59-36A8-49B2-B9C5-4AA7D52365BC}"/>
+                <a16:creationId xmlns:a16="http://schemas.microsoft.com/office/drawing/2014/main" id="{163C839C-9E7C-4344-8841-EC4E96DE50D7}"/>
               </a:ext>
             </a:extLst>
           </p:cNvPr>
@@ -20356,7 +20545,7 @@
                 <a:ea typeface="Be Vietnam Pro"/>
                 <a:cs typeface="Be Vietnam Pro"/>
               </a:rPr>
-              <a:t>Node.js, Express and MongoDB</a:t>
+              <a:t>Node.js, Express, MongoDB and PayOS</a:t>
             </a:r>
           </a:p>
         </p:txBody>
@@ -20366,7 +20555,7 @@
           <p:cNvPr id="9" name="body">
             <a:extLst xmlns:a="http://schemas.openxmlformats.org/drawingml/2006/main">
               <a:ext uri="{FF2B5EF4-FFF2-40B4-BE49-F238E27FC236}">
-                <a16:creationId xmlns:a16="http://schemas.microsoft.com/office/drawing/2014/main" id="{BC032562-ABE8-4709-ACFE-FC0845A2ED65}"/>
+                <a16:creationId xmlns:a16="http://schemas.microsoft.com/office/drawing/2014/main" id="{2B9EBB36-00AC-4171-978A-00873D5A4E69}"/>
               </a:ext>
             </a:extLst>
           </p:cNvPr>
@@ -20518,7 +20707,7 @@
                 <a:ea typeface="Be Vietnam Pro"/>
                 <a:cs typeface="Be Vietnam Pro"/>
               </a:rPr>
-              <a:t>JWT and Google OAuth, with PayOS payments</a:t>
+              <a:t>JWT and Google OAuth. The public demo simulates payments.</a:t>
             </a:r>
           </a:p>
         </p:txBody>
@@ -20528,7 +20717,7 @@
           <p:cNvPr id="10" name="body">
             <a:extLst xmlns:a="http://schemas.openxmlformats.org/drawingml/2006/main">
               <a:ext uri="{FF2B5EF4-FFF2-40B4-BE49-F238E27FC236}">
-                <a16:creationId xmlns:a16="http://schemas.microsoft.com/office/drawing/2014/main" id="{CB5147DA-9935-4168-B703-4718597149CC}"/>
+                <a16:creationId xmlns:a16="http://schemas.microsoft.com/office/drawing/2014/main" id="{4158E0F5-E697-4EA3-85D4-853A0A886199}"/>
               </a:ext>
             </a:extLst>
           </p:cNvPr>
@@ -20690,7 +20879,7 @@
           <p:cNvPr id="11" name="body">
             <a:extLst xmlns:a="http://schemas.openxmlformats.org/drawingml/2006/main">
               <a:ext uri="{FF2B5EF4-FFF2-40B4-BE49-F238E27FC236}">
-                <a16:creationId xmlns:a16="http://schemas.microsoft.com/office/drawing/2014/main" id="{5DBB43A5-21AF-446E-AC91-CEE07D1051BE}"/>
+                <a16:creationId xmlns:a16="http://schemas.microsoft.com/office/drawing/2014/main" id="{5529F1FB-9F10-4DBB-8791-D26C64A6A735}"/>
               </a:ext>
             </a:extLst>
           </p:cNvPr>
@@ -20842,7 +21031,7 @@
                 <a:ea typeface="Be Vietnam Pro"/>
                 <a:cs typeface="Be Vietnam Pro"/>
               </a:rPr>
-              <a:t>Solana Web3.js, Metaplex and IPFS</a:t>
+              <a:t>Solana Web3.js and Metaplex</a:t>
             </a:r>
           </a:p>
         </p:txBody>
@@ -20852,7 +21041,7 @@
           <p:cNvPr id="12" name="body">
             <a:extLst xmlns:a="http://schemas.openxmlformats.org/drawingml/2006/main">
               <a:ext uri="{FF2B5EF4-FFF2-40B4-BE49-F238E27FC236}">
-                <a16:creationId xmlns:a16="http://schemas.microsoft.com/office/drawing/2014/main" id="{94DD6DB6-B800-4169-A266-AFFEC9B6CAAE}"/>
+                <a16:creationId xmlns:a16="http://schemas.microsoft.com/office/drawing/2014/main" id="{0B0BF8B0-2B05-41A6-A130-66BD40972170}"/>
               </a:ext>
             </a:extLst>
           </p:cNvPr>
@@ -21004,7 +21193,7 @@
                 <a:ea typeface="Be Vietnam Pro"/>
                 <a:cs typeface="Be Vietnam Pro"/>
               </a:rPr>
-              <a:t>Devnet NFT minting and file references</a:t>
+              <a:t>Supabase Storage in the demo. IPFS/Pinata support in code.</a:t>
             </a:r>
           </a:p>
         </p:txBody>
@@ -21014,7 +21203,7 @@
           <p:cNvPr id="13" name="body">
             <a:extLst xmlns:a="http://schemas.openxmlformats.org/drawingml/2006/main">
               <a:ext uri="{FF2B5EF4-FFF2-40B4-BE49-F238E27FC236}">
-                <a16:creationId xmlns:a16="http://schemas.microsoft.com/office/drawing/2014/main" id="{0A6B53A7-AA7F-45EF-B98A-31C8730B5070}"/>
+                <a16:creationId xmlns:a16="http://schemas.microsoft.com/office/drawing/2014/main" id="{D8EC62A6-7B95-40BA-B22B-FCC2D8D0BBE7}"/>
               </a:ext>
             </a:extLst>
           </p:cNvPr>
@@ -21176,7 +21365,7 @@
           <p:cNvPr id="14" name="body">
             <a:extLst xmlns:a="http://schemas.openxmlformats.org/drawingml/2006/main">
               <a:ext uri="{FF2B5EF4-FFF2-40B4-BE49-F238E27FC236}">
-                <a16:creationId xmlns:a16="http://schemas.microsoft.com/office/drawing/2014/main" id="{BD151927-F6D9-4141-839C-34B24B4F47C0}"/>
+                <a16:creationId xmlns:a16="http://schemas.microsoft.com/office/drawing/2014/main" id="{9E7641A0-7BC9-4375-937D-E373983F402D}"/>
               </a:ext>
             </a:extLst>
           </p:cNvPr>
@@ -21338,7 +21527,7 @@
           <p:cNvPr id="15" name="body">
             <a:extLst xmlns:a="http://schemas.openxmlformats.org/drawingml/2006/main">
               <a:ext uri="{FF2B5EF4-FFF2-40B4-BE49-F238E27FC236}">
-                <a16:creationId xmlns:a16="http://schemas.microsoft.com/office/drawing/2014/main" id="{28A92D5F-8DF5-4FA7-9BC3-76B09827C2BD}"/>
+                <a16:creationId xmlns:a16="http://schemas.microsoft.com/office/drawing/2014/main" id="{497C7371-3126-40C8-9B52-BB3E84CA2FC0}"/>
               </a:ext>
             </a:extLst>
           </p:cNvPr>
@@ -21498,7 +21687,7 @@
     </p:spTree>
     <p:extLst>
       <p:ext uri="{BB962C8B-B14F-4D97-AF65-F5344CB8AC3E}">
-        <p14:creationId xmlns:p14="http://schemas.microsoft.com/office/powerpoint/2010/main" val="1092982406"/>
+        <p14:creationId xmlns:p14="http://schemas.microsoft.com/office/powerpoint/2010/main" val="1512353081"/>
       </p:ext>
     </p:extLst>
   </p:cSld>
@@ -21529,7 +21718,7 @@
           <p:cNvPr id="11" name="">
             <a:extLst xmlns:a="http://schemas.openxmlformats.org/drawingml/2006/main">
               <a:ext uri="{FF2B5EF4-FFF2-40B4-BE49-F238E27FC236}">
-                <a16:creationId xmlns:a16="http://schemas.microsoft.com/office/drawing/2014/main" id="{675C3C84-42DE-4DC0-8543-A85771E79BD7}"/>
+                <a16:creationId xmlns:a16="http://schemas.microsoft.com/office/drawing/2014/main" id="{2338E385-1837-4024-8E1F-192DA0A33F0C}"/>
               </a:ext>
             </a:extLst>
           </p:cNvPr>
@@ -21539,10 +21728,10 @@
           <p:nvPr/>
         </p:nvPicPr>
         <p:blipFill>
-          <a:blip xmlns:r="http://schemas.openxmlformats.org/officeDocument/2006/relationships" xmlns:a="http://schemas.openxmlformats.org/drawingml/2006/main" r:embed="R7bc63ecb8abb424b">
+          <a:blip xmlns:r="http://schemas.openxmlformats.org/officeDocument/2006/relationships" xmlns:a="http://schemas.openxmlformats.org/drawingml/2006/main" r:embed="R0922117a9d8e4c14">
             <a:extLst>
               <a:ext uri="{96DAC541-7B7A-43D3-8B79-37D633B846F1}">
-                <asvg:svgBlip xmlns:asvg="http://schemas.microsoft.com/office/drawing/2016/SVG/main" r:embed="Rb592af37e0e0459d"/>
+                <asvg:svgBlip xmlns:asvg="http://schemas.microsoft.com/office/drawing/2016/SVG/main" r:embed="Rc4e4e2fa35334437"/>
               </a:ext>
             </a:extLst>
           </a:blip>
@@ -21563,7 +21752,7 @@
           <p:cNvPr id="2" name="title">
             <a:extLst xmlns:a="http://schemas.openxmlformats.org/drawingml/2006/main">
               <a:ext uri="{FF2B5EF4-FFF2-40B4-BE49-F238E27FC236}">
-                <a16:creationId xmlns:a16="http://schemas.microsoft.com/office/drawing/2014/main" id="{2FBEDBCE-25C6-4E95-B11B-F29AB915899E}"/>
+                <a16:creationId xmlns:a16="http://schemas.microsoft.com/office/drawing/2014/main" id="{15F770F3-6136-4FAD-8DF8-BA61ADEAB2D9}"/>
               </a:ext>
             </a:extLst>
           </p:cNvPr>
@@ -21725,7 +21914,7 @@
           <p:cNvPr id="3" name="page">
             <a:extLst xmlns:a="http://schemas.openxmlformats.org/drawingml/2006/main">
               <a:ext uri="{FF2B5EF4-FFF2-40B4-BE49-F238E27FC236}">
-                <a16:creationId xmlns:a16="http://schemas.microsoft.com/office/drawing/2014/main" id="{4054B3E1-3A0C-4386-A78C-09782D51F81D}"/>
+                <a16:creationId xmlns:a16="http://schemas.microsoft.com/office/drawing/2014/main" id="{4E0E9D3A-72EE-49A3-B8D4-538434A9E28C}"/>
               </a:ext>
             </a:extLst>
           </p:cNvPr>
@@ -21881,7 +22070,7 @@
           <p:cNvPr id="4" name="body">
             <a:extLst xmlns:a="http://schemas.openxmlformats.org/drawingml/2006/main">
               <a:ext uri="{FF2B5EF4-FFF2-40B4-BE49-F238E27FC236}">
-                <a16:creationId xmlns:a16="http://schemas.microsoft.com/office/drawing/2014/main" id="{610C273D-EE9A-4D67-A8BB-51DC6CD7E0CB}"/>
+                <a16:creationId xmlns:a16="http://schemas.microsoft.com/office/drawing/2014/main" id="{8433E757-0FB2-4467-BF57-C50CB24C550E}"/>
               </a:ext>
             </a:extLst>
           </p:cNvPr>
@@ -22043,7 +22232,7 @@
           <p:cNvPr id="5" name="body">
             <a:extLst xmlns:a="http://schemas.openxmlformats.org/drawingml/2006/main">
               <a:ext uri="{FF2B5EF4-FFF2-40B4-BE49-F238E27FC236}">
-                <a16:creationId xmlns:a16="http://schemas.microsoft.com/office/drawing/2014/main" id="{5F088D3A-651C-4CFD-84F6-FA31EA435DB1}"/>
+                <a16:creationId xmlns:a16="http://schemas.microsoft.com/office/drawing/2014/main" id="{8CAFF3CE-FE70-4705-A2B7-180597E64EAE}"/>
               </a:ext>
             </a:extLst>
           </p:cNvPr>
@@ -22205,7 +22394,7 @@
           <p:cNvPr id="6" name="body">
             <a:extLst xmlns:a="http://schemas.openxmlformats.org/drawingml/2006/main">
               <a:ext uri="{FF2B5EF4-FFF2-40B4-BE49-F238E27FC236}">
-                <a16:creationId xmlns:a16="http://schemas.microsoft.com/office/drawing/2014/main" id="{EDD964D0-591A-43D6-94CF-DF95F5B6FA7C}"/>
+                <a16:creationId xmlns:a16="http://schemas.microsoft.com/office/drawing/2014/main" id="{293F6767-6B81-4B8C-AB01-081D702D1FDF}"/>
               </a:ext>
             </a:extLst>
           </p:cNvPr>
@@ -22421,7 +22610,7 @@
           <p:cNvPr id="7" name="body">
             <a:extLst xmlns:a="http://schemas.openxmlformats.org/drawingml/2006/main">
               <a:ext uri="{FF2B5EF4-FFF2-40B4-BE49-F238E27FC236}">
-                <a16:creationId xmlns:a16="http://schemas.microsoft.com/office/drawing/2014/main" id="{6828362C-DED1-490A-B772-9D38517BB2F2}"/>
+                <a16:creationId xmlns:a16="http://schemas.microsoft.com/office/drawing/2014/main" id="{F9EAED9E-CB2F-45B2-B702-3557DFFBF6DE}"/>
               </a:ext>
             </a:extLst>
           </p:cNvPr>
@@ -22583,7 +22772,7 @@
           <p:cNvPr id="8" name="body">
             <a:extLst xmlns:a="http://schemas.openxmlformats.org/drawingml/2006/main">
               <a:ext uri="{FF2B5EF4-FFF2-40B4-BE49-F238E27FC236}">
-                <a16:creationId xmlns:a16="http://schemas.microsoft.com/office/drawing/2014/main" id="{8280F3C4-A5BC-46EC-99D1-C8023037930C}"/>
+                <a16:creationId xmlns:a16="http://schemas.microsoft.com/office/drawing/2014/main" id="{B972096B-E30E-4895-9E27-23432F2F70BC}"/>
               </a:ext>
             </a:extLst>
           </p:cNvPr>
@@ -22745,7 +22934,7 @@
           <p:cNvPr id="9" name="body">
             <a:extLst xmlns:a="http://schemas.openxmlformats.org/drawingml/2006/main">
               <a:ext uri="{FF2B5EF4-FFF2-40B4-BE49-F238E27FC236}">
-                <a16:creationId xmlns:a16="http://schemas.microsoft.com/office/drawing/2014/main" id="{D9E2F503-22CF-4C31-9445-611F0A566284}"/>
+                <a16:creationId xmlns:a16="http://schemas.microsoft.com/office/drawing/2014/main" id="{ED9514D0-46D0-4AE6-8720-943AB3416050}"/>
               </a:ext>
             </a:extLst>
           </p:cNvPr>
@@ -22961,7 +23150,7 @@
           <p:cNvPr id="10" name="source-note">
             <a:extLst xmlns:a="http://schemas.openxmlformats.org/drawingml/2006/main">
               <a:ext uri="{FF2B5EF4-FFF2-40B4-BE49-F238E27FC236}">
-                <a16:creationId xmlns:a16="http://schemas.microsoft.com/office/drawing/2014/main" id="{5641C883-C089-4485-8F30-972D3ACEC2CA}"/>
+                <a16:creationId xmlns:a16="http://schemas.microsoft.com/office/drawing/2014/main" id="{D1F42FB2-C6A7-4243-8365-882FBDECF7DF}"/>
               </a:ext>
             </a:extLst>
           </p:cNvPr>
@@ -23121,7 +23310,7 @@
     </p:spTree>
     <p:extLst>
       <p:ext uri="{BB962C8B-B14F-4D97-AF65-F5344CB8AC3E}">
-        <p14:creationId xmlns:p14="http://schemas.microsoft.com/office/powerpoint/2010/main" val="266843536"/>
+        <p14:creationId xmlns:p14="http://schemas.microsoft.com/office/powerpoint/2010/main" val="787760996"/>
       </p:ext>
     </p:extLst>
   </p:cSld>

</xml_diff>

<commit_message>
docs: align pitch with private document fingerprint model
</commit_message>
<xml_diff>
--- a/public/pitch/trustify-pitch.pptx
+++ b/public/pitch/trustify-pitch.pptx
@@ -2,24 +2,24 @@
 <file path=ppt/presentation.xml><?xml version="1.0" encoding="utf-8"?>
 <p:presentation xmlns:p="http://schemas.openxmlformats.org/presentationml/2006/main">
   <p:sldMasterIdLst>
-    <p:sldMasterId xmlns:r="http://schemas.openxmlformats.org/officeDocument/2006/relationships" id="2147483648" r:id="R0e79cf8b55ad4b21"/>
+    <p:sldMasterId xmlns:r="http://schemas.openxmlformats.org/officeDocument/2006/relationships" id="2147483648" r:id="R0deeb0e3aa1546ac"/>
   </p:sldMasterIdLst>
   <p:notesMasterIdLst>
-    <p:notesMasterId xmlns:r="http://schemas.openxmlformats.org/officeDocument/2006/relationships" r:id="R27dec79570b8423f"/>
+    <p:notesMasterId xmlns:r="http://schemas.openxmlformats.org/officeDocument/2006/relationships" r:id="R98e301ce6fe2422d"/>
   </p:notesMasterIdLst>
   <p:sldIdLst>
-    <p:sldId xmlns:r="http://schemas.openxmlformats.org/officeDocument/2006/relationships" id="256" r:id="Rb6f8f37c25a04df3"/>
-    <p:sldId xmlns:r="http://schemas.openxmlformats.org/officeDocument/2006/relationships" id="257" r:id="R33d3e646551f4f15"/>
-    <p:sldId xmlns:r="http://schemas.openxmlformats.org/officeDocument/2006/relationships" id="258" r:id="R26894316ff7146c3"/>
-    <p:sldId xmlns:r="http://schemas.openxmlformats.org/officeDocument/2006/relationships" id="259" r:id="Rfe609679e0ac4043"/>
-    <p:sldId xmlns:r="http://schemas.openxmlformats.org/officeDocument/2006/relationships" id="260" r:id="R6d61e8fcf0d6486e"/>
-    <p:sldId xmlns:r="http://schemas.openxmlformats.org/officeDocument/2006/relationships" id="261" r:id="R91ebb2f3f73c4403"/>
-    <p:sldId xmlns:r="http://schemas.openxmlformats.org/officeDocument/2006/relationships" id="262" r:id="Re1de6e1c6d754dcc"/>
-    <p:sldId xmlns:r="http://schemas.openxmlformats.org/officeDocument/2006/relationships" id="263" r:id="Rdd05f281ff854ff8"/>
-    <p:sldId xmlns:r="http://schemas.openxmlformats.org/officeDocument/2006/relationships" id="264" r:id="R1922a7aa28f14ec2"/>
-    <p:sldId xmlns:r="http://schemas.openxmlformats.org/officeDocument/2006/relationships" id="265" r:id="R06f4a867542f40eb"/>
-    <p:sldId xmlns:r="http://schemas.openxmlformats.org/officeDocument/2006/relationships" id="266" r:id="R16398b599f1841f8"/>
-    <p:sldId xmlns:r="http://schemas.openxmlformats.org/officeDocument/2006/relationships" id="267" r:id="R77f30fc79c0146e7"/>
+    <p:sldId xmlns:r="http://schemas.openxmlformats.org/officeDocument/2006/relationships" id="256" r:id="Rd9d2ffcc35fb462c"/>
+    <p:sldId xmlns:r="http://schemas.openxmlformats.org/officeDocument/2006/relationships" id="257" r:id="Rf2ed3e3fb2e94295"/>
+    <p:sldId xmlns:r="http://schemas.openxmlformats.org/officeDocument/2006/relationships" id="258" r:id="R5a9617ecff16493a"/>
+    <p:sldId xmlns:r="http://schemas.openxmlformats.org/officeDocument/2006/relationships" id="259" r:id="Rbb823e2a2e5a482f"/>
+    <p:sldId xmlns:r="http://schemas.openxmlformats.org/officeDocument/2006/relationships" id="260" r:id="R33815e4f474a4c1f"/>
+    <p:sldId xmlns:r="http://schemas.openxmlformats.org/officeDocument/2006/relationships" id="261" r:id="Rc49b1e460a964f0b"/>
+    <p:sldId xmlns:r="http://schemas.openxmlformats.org/officeDocument/2006/relationships" id="262" r:id="R60b0d82f75cf4450"/>
+    <p:sldId xmlns:r="http://schemas.openxmlformats.org/officeDocument/2006/relationships" id="263" r:id="R16644838d61047db"/>
+    <p:sldId xmlns:r="http://schemas.openxmlformats.org/officeDocument/2006/relationships" id="264" r:id="Rc08121020e3a46b4"/>
+    <p:sldId xmlns:r="http://schemas.openxmlformats.org/officeDocument/2006/relationships" id="265" r:id="Raa30d6673d004f36"/>
+    <p:sldId xmlns:r="http://schemas.openxmlformats.org/officeDocument/2006/relationships" id="266" r:id="Ra12864fe31574758"/>
+    <p:sldId xmlns:r="http://schemas.openxmlformats.org/officeDocument/2006/relationships" id="267" r:id="R56f51ef59ce1477e"/>
   </p:sldIdLst>
   <p:sldSz cx="12192000" cy="6858000"/>
   <p:notesSz cx="6858000" cy="9144000"/>
@@ -1083,7 +1083,7 @@
           <a:lstStyle xmlns:a="http://schemas.openxmlformats.org/drawingml/2006/main"/>
           <a:p xmlns:a="http://schemas.openxmlformats.org/drawingml/2006/main">
             <a:r>
-              <a:t>Blockchain implementation: https://github.com/sloweyyy/Trustify-Backend/blob/main/src/config/blockchain.js and src/services/notarization.service.js. Verification UI: https://github.com/sloweyyy/Trustify-Frontend/blob/main/docs/design/screenshots/final/states/public-verify-record-desktop.png. The public demo stores files and metadata in Supabase Storage. IPFS/Pinata pinning is supported in code. Metadata references are minted on Solana devnet. Live-demo configuration verified by the maintainer in https://github.com/sloweyyy/Trustify-Frontend/pull/50. NFT possession/metadata is not proof of legal validity or complete confidentiality.</a:t>
+              <a:t>Blockchain implementation: https://github.com/sloweyyy/Trustify-Backend/blob/main/src/config/blockchain.js and src/services/notarization.service.js. Verification UI: https://github.com/sloweyyy/Trustify-Frontend/blob/main/docs/design/screenshots/final/states/public-verify-record-desktop.png. Document files are kept in private storage. Solana devnet NFTs record the file SHA-256 fingerprint for comparison against a copy held by the verifier. Backend privacy update: https://github.com/sloweyyy/Trustify-Backend/pull/16. Live-demo configuration verified by the maintainer in https://github.com/sloweyyy/Trustify-Frontend/pull/50. NFT possession/metadata is not proof of legal validity or complete confidentiality.</a:t>
             </a:r>
           </a:p>
         </p:txBody>
@@ -1153,7 +1153,7 @@
           <a:lstStyle xmlns:a="http://schemas.openxmlformats.org/drawingml/2006/main"/>
           <a:p xmlns:a="http://schemas.openxmlformats.org/drawingml/2006/main">
             <a:r>
-              <a:t>Verified against frontend package.json/README and backend package.json, src/config/blockchain.js, src/services/chatbot.service.js and src/services/payment.service.js. Source: https://github.com/sloweyyy/Trustify-Frontend and https://github.com/sloweyyy/Trustify-Backend. Gemini supplies procedural guidance, not implemented document generation. PayOS is the supported payment integration. The current public demo simulates payments, as verified by the maintainer in https://github.com/sloweyyy/Trustify-Frontend/pull/50. The demo uses Supabase Storage for files/metadata, with IPFS/Pinata support in code.</a:t>
+              <a:t>Verified against frontend package.json/README and backend package.json, src/config/blockchain.js, src/services/chatbot.service.js and src/services/payment.service.js. Source: https://github.com/sloweyyy/Trustify-Frontend and https://github.com/sloweyyy/Trustify-Backend. Gemini supplies procedural guidance, not implemented document generation. PayOS is the supported payment integration. The current public demo simulates payments, as verified by the maintainer in https://github.com/sloweyyy/Trustify-Frontend/pull/50. Documents stay in private storage; the NFT records a SHA-256 fingerprint. Backend privacy update: https://github.com/sloweyyy/Trustify-Backend/pull/16.</a:t>
             </a:r>
           </a:p>
         </p:txBody>
@@ -1270,7 +1270,7 @@
           <p:cNvPr id="3" name="Title">
             <a:extLst xmlns:a="http://schemas.openxmlformats.org/drawingml/2006/main">
               <a:ext uri="{FF2B5EF4-FFF2-40B4-BE49-F238E27FC236}">
-                <a16:creationId xmlns:a16="http://schemas.microsoft.com/office/drawing/2014/main" id="{699EA64F-7F90-4C51-8314-9FFC025A3963}"/>
+                <a16:creationId xmlns:a16="http://schemas.microsoft.com/office/drawing/2014/main" id="{E7D52A58-995C-4344-83D4-E9CCB8DF9A66}"/>
               </a:ext>
             </a:extLst>
           </p:cNvPr>
@@ -1499,7 +1499,7 @@
           <p:cNvPr id="2" name="Subtitle">
             <a:extLst xmlns:a="http://schemas.openxmlformats.org/drawingml/2006/main">
               <a:ext uri="{FF2B5EF4-FFF2-40B4-BE49-F238E27FC236}">
-                <a16:creationId xmlns:a16="http://schemas.microsoft.com/office/drawing/2014/main" id="{D121FBFF-B982-44BC-B4F8-7AFCC4D4660B}"/>
+                <a16:creationId xmlns:a16="http://schemas.microsoft.com/office/drawing/2014/main" id="{6E4E4B42-46E7-491E-A074-F2FD507D7D2C}"/>
               </a:ext>
             </a:extLst>
           </p:cNvPr>
@@ -1745,7 +1745,7 @@
           <p:cNvPr id="2" name="Section title">
             <a:extLst xmlns:a="http://schemas.openxmlformats.org/drawingml/2006/main">
               <a:ext uri="{FF2B5EF4-FFF2-40B4-BE49-F238E27FC236}">
-                <a16:creationId xmlns:a16="http://schemas.microsoft.com/office/drawing/2014/main" id="{44FDA90C-F65D-4425-A52A-CEE5E71209DE}"/>
+                <a16:creationId xmlns:a16="http://schemas.microsoft.com/office/drawing/2014/main" id="{8B4BFEC0-7557-42B9-999F-4925B4CFDA23}"/>
               </a:ext>
             </a:extLst>
           </p:cNvPr>
@@ -1991,7 +1991,7 @@
           <p:cNvPr id="3" name="Title">
             <a:extLst xmlns:a="http://schemas.openxmlformats.org/drawingml/2006/main">
               <a:ext uri="{FF2B5EF4-FFF2-40B4-BE49-F238E27FC236}">
-                <a16:creationId xmlns:a16="http://schemas.microsoft.com/office/drawing/2014/main" id="{BFFCD74B-F0BE-4A36-850B-11435E45B045}"/>
+                <a16:creationId xmlns:a16="http://schemas.microsoft.com/office/drawing/2014/main" id="{B84DDCFE-7397-48E1-98F2-28167FE34EB8}"/>
               </a:ext>
             </a:extLst>
           </p:cNvPr>
@@ -2220,7 +2220,7 @@
           <p:cNvPr id="2" name="Body">
             <a:extLst xmlns:a="http://schemas.openxmlformats.org/drawingml/2006/main">
               <a:ext uri="{FF2B5EF4-FFF2-40B4-BE49-F238E27FC236}">
-                <a16:creationId xmlns:a16="http://schemas.microsoft.com/office/drawing/2014/main" id="{B901BCE0-D499-4B99-A599-3F7E0A8DCB02}"/>
+                <a16:creationId xmlns:a16="http://schemas.microsoft.com/office/drawing/2014/main" id="{E0673187-5B81-48BA-A116-4512BEDEFD6B}"/>
               </a:ext>
             </a:extLst>
           </p:cNvPr>
@@ -2466,7 +2466,7 @@
           <p:cNvPr id="4" name="Title">
             <a:extLst xmlns:a="http://schemas.openxmlformats.org/drawingml/2006/main">
               <a:ext uri="{FF2B5EF4-FFF2-40B4-BE49-F238E27FC236}">
-                <a16:creationId xmlns:a16="http://schemas.microsoft.com/office/drawing/2014/main" id="{50882001-4222-4386-9AC7-194317571D75}"/>
+                <a16:creationId xmlns:a16="http://schemas.microsoft.com/office/drawing/2014/main" id="{6EB5AFA0-30C4-40DC-9836-96D37940DDE8}"/>
               </a:ext>
             </a:extLst>
           </p:cNvPr>
@@ -2695,7 +2695,7 @@
           <p:cNvPr id="2" name="Left column">
             <a:extLst xmlns:a="http://schemas.openxmlformats.org/drawingml/2006/main">
               <a:ext uri="{FF2B5EF4-FFF2-40B4-BE49-F238E27FC236}">
-                <a16:creationId xmlns:a16="http://schemas.microsoft.com/office/drawing/2014/main" id="{8AA9071A-B1BE-4EF7-8034-AB256E62CA9E}"/>
+                <a16:creationId xmlns:a16="http://schemas.microsoft.com/office/drawing/2014/main" id="{26C3B18B-D65E-41D5-93C5-9870C8DEF140}"/>
               </a:ext>
             </a:extLst>
           </p:cNvPr>
@@ -2924,7 +2924,7 @@
           <p:cNvPr id="3" name="Right column">
             <a:extLst xmlns:a="http://schemas.openxmlformats.org/drawingml/2006/main">
               <a:ext uri="{FF2B5EF4-FFF2-40B4-BE49-F238E27FC236}">
-                <a16:creationId xmlns:a16="http://schemas.microsoft.com/office/drawing/2014/main" id="{EEAA6425-1B2C-4053-BD05-45F0C65705AB}"/>
+                <a16:creationId xmlns:a16="http://schemas.microsoft.com/office/drawing/2014/main" id="{0CD3DCC9-25D1-4C29-A7F5-B5004670FDE7}"/>
               </a:ext>
             </a:extLst>
           </p:cNvPr>
@@ -3170,7 +3170,7 @@
           <p:cNvPr id="3" name="Title">
             <a:extLst xmlns:a="http://schemas.openxmlformats.org/drawingml/2006/main">
               <a:ext uri="{FF2B5EF4-FFF2-40B4-BE49-F238E27FC236}">
-                <a16:creationId xmlns:a16="http://schemas.microsoft.com/office/drawing/2014/main" id="{83A0F751-A0DA-4D22-AD6D-9CD316AE09BD}"/>
+                <a16:creationId xmlns:a16="http://schemas.microsoft.com/office/drawing/2014/main" id="{03D7C9D5-E76B-4DFB-9D05-F7983AEA1BBA}"/>
               </a:ext>
             </a:extLst>
           </p:cNvPr>
@@ -3399,7 +3399,7 @@
           <p:cNvPr id="2" name="Left column">
             <a:extLst xmlns:a="http://schemas.openxmlformats.org/drawingml/2006/main">
               <a:ext uri="{FF2B5EF4-FFF2-40B4-BE49-F238E27FC236}">
-                <a16:creationId xmlns:a16="http://schemas.microsoft.com/office/drawing/2014/main" id="{5AE9946E-0B09-4713-BCC2-91C4D8EDBB2D}"/>
+                <a16:creationId xmlns:a16="http://schemas.microsoft.com/office/drawing/2014/main" id="{A7D0B647-41B3-4EA1-9DB1-4F17B8FF0695}"/>
               </a:ext>
             </a:extLst>
           </p:cNvPr>
@@ -3666,12 +3666,12 @@
   </p:cSld>
   <p:clrMap bg1="lt1" tx1="dk1" bg2="lt2" tx2="dk2" accent1="accent1" accent2="accent2" accent3="accent3" accent4="accent4" accent5="accent5" accent6="accent6" hlink="hlink" folHlink="folHlink"/>
   <p:sldLayoutIdLst>
-    <p:sldLayoutId xmlns:r="http://schemas.openxmlformats.org/officeDocument/2006/relationships" id="2147483649" r:id="Rb002474a746c4769"/>
-    <p:sldLayoutId xmlns:r="http://schemas.openxmlformats.org/officeDocument/2006/relationships" id="2147483650" r:id="Reafe9b5bf9c84716"/>
-    <p:sldLayoutId xmlns:r="http://schemas.openxmlformats.org/officeDocument/2006/relationships" id="2147483651" r:id="Rb19bc67969594272"/>
-    <p:sldLayoutId xmlns:r="http://schemas.openxmlformats.org/officeDocument/2006/relationships" id="2147483652" r:id="R68fb8bd9e4974a95"/>
-    <p:sldLayoutId xmlns:r="http://schemas.openxmlformats.org/officeDocument/2006/relationships" id="2147483653" r:id="Rd33438a829ab436c"/>
-    <p:sldLayoutId xmlns:r="http://schemas.openxmlformats.org/officeDocument/2006/relationships" id="2147483654" r:id="Rcdac3e41dc2f4357"/>
+    <p:sldLayoutId xmlns:r="http://schemas.openxmlformats.org/officeDocument/2006/relationships" id="2147483649" r:id="R602a14485db0432c"/>
+    <p:sldLayoutId xmlns:r="http://schemas.openxmlformats.org/officeDocument/2006/relationships" id="2147483650" r:id="Ra8b4ad11be18427d"/>
+    <p:sldLayoutId xmlns:r="http://schemas.openxmlformats.org/officeDocument/2006/relationships" id="2147483651" r:id="Rf3e01eada3574ee0"/>
+    <p:sldLayoutId xmlns:r="http://schemas.openxmlformats.org/officeDocument/2006/relationships" id="2147483652" r:id="R1305ccbfe26d4923"/>
+    <p:sldLayoutId xmlns:r="http://schemas.openxmlformats.org/officeDocument/2006/relationships" id="2147483653" r:id="Rd5233bcdfac14526"/>
+    <p:sldLayoutId xmlns:r="http://schemas.openxmlformats.org/officeDocument/2006/relationships" id="2147483654" r:id="R4987a0989e6a42d1"/>
   </p:sldLayoutIdLst>
   <p:txStyles>
     <p:titleStyle>
@@ -4222,7 +4222,7 @@
           <p:cNvPr id="7" name="">
             <a:extLst xmlns:a="http://schemas.openxmlformats.org/drawingml/2006/main">
               <a:ext uri="{FF2B5EF4-FFF2-40B4-BE49-F238E27FC236}">
-                <a16:creationId xmlns:a16="http://schemas.microsoft.com/office/drawing/2014/main" id="{9FBE619B-5DD1-48EA-8A18-ECEBD65A9BFA}"/>
+                <a16:creationId xmlns:a16="http://schemas.microsoft.com/office/drawing/2014/main" id="{199CD240-4AEF-46BA-A9B4-DBDA1749A3E3}"/>
               </a:ext>
             </a:extLst>
           </p:cNvPr>
@@ -4232,10 +4232,10 @@
           <p:nvPr/>
         </p:nvPicPr>
         <p:blipFill>
-          <a:blip xmlns:r="http://schemas.openxmlformats.org/officeDocument/2006/relationships" xmlns:a="http://schemas.openxmlformats.org/drawingml/2006/main" r:embed="R11b7c8cf56b54d0a">
+          <a:blip xmlns:r="http://schemas.openxmlformats.org/officeDocument/2006/relationships" xmlns:a="http://schemas.openxmlformats.org/drawingml/2006/main" r:embed="Rbfb9763bb8c94c73">
             <a:extLst>
               <a:ext uri="{96DAC541-7B7A-43D3-8B79-37D633B846F1}">
-                <asvg:svgBlip xmlns:asvg="http://schemas.microsoft.com/office/drawing/2016/SVG/main" r:embed="Rfda0b987cd9a4311"/>
+                <asvg:svgBlip xmlns:asvg="http://schemas.microsoft.com/office/drawing/2016/SVG/main" r:embed="Rf65b625e9fcf4f85"/>
               </a:ext>
             </a:extLst>
           </a:blip>
@@ -4256,7 +4256,7 @@
           <p:cNvPr id="2" name="page">
             <a:extLst xmlns:a="http://schemas.openxmlformats.org/drawingml/2006/main">
               <a:ext uri="{FF2B5EF4-FFF2-40B4-BE49-F238E27FC236}">
-                <a16:creationId xmlns:a16="http://schemas.microsoft.com/office/drawing/2014/main" id="{401AD806-996B-41A0-9067-40DB6CFA6F46}"/>
+                <a16:creationId xmlns:a16="http://schemas.microsoft.com/office/drawing/2014/main" id="{EA7CA855-60FE-4C24-9533-380C0404D488}"/>
               </a:ext>
             </a:extLst>
           </p:cNvPr>
@@ -4412,7 +4412,7 @@
           <p:cNvPr id="3" name="title">
             <a:extLst xmlns:a="http://schemas.openxmlformats.org/drawingml/2006/main">
               <a:ext uri="{FF2B5EF4-FFF2-40B4-BE49-F238E27FC236}">
-                <a16:creationId xmlns:a16="http://schemas.microsoft.com/office/drawing/2014/main" id="{DC53EAAF-FC4D-4697-8F86-21B3EAE37595}"/>
+                <a16:creationId xmlns:a16="http://schemas.microsoft.com/office/drawing/2014/main" id="{EFB3A0CE-591A-4639-8DCB-2945F40928FD}"/>
               </a:ext>
             </a:extLst>
           </p:cNvPr>
@@ -4628,7 +4628,7 @@
           <p:cNvPr id="4" name="body">
             <a:extLst xmlns:a="http://schemas.openxmlformats.org/drawingml/2006/main">
               <a:ext uri="{FF2B5EF4-FFF2-40B4-BE49-F238E27FC236}">
-                <a16:creationId xmlns:a16="http://schemas.microsoft.com/office/drawing/2014/main" id="{5BC1DC0E-F9C5-4EA3-94A2-1B2EBF9861BA}"/>
+                <a16:creationId xmlns:a16="http://schemas.microsoft.com/office/drawing/2014/main" id="{C8AE341D-2652-4911-B016-FF1C293D7AA9}"/>
               </a:ext>
             </a:extLst>
           </p:cNvPr>
@@ -4817,7 +4817,7 @@
           <p:cNvPr id="5" name="body">
             <a:extLst xmlns:a="http://schemas.openxmlformats.org/drawingml/2006/main">
               <a:ext uri="{FF2B5EF4-FFF2-40B4-BE49-F238E27FC236}">
-                <a16:creationId xmlns:a16="http://schemas.microsoft.com/office/drawing/2014/main" id="{65DBCED9-A3C3-4D2C-AFE7-3648B105A966}"/>
+                <a16:creationId xmlns:a16="http://schemas.microsoft.com/office/drawing/2014/main" id="{4B48302B-B4C7-4360-9274-7333ED595034}"/>
               </a:ext>
             </a:extLst>
           </p:cNvPr>
@@ -5006,7 +5006,7 @@
           <p:cNvPr id="6" name="">
             <a:extLst xmlns:a="http://schemas.openxmlformats.org/drawingml/2006/main">
               <a:ext uri="{FF2B5EF4-FFF2-40B4-BE49-F238E27FC236}">
-                <a16:creationId xmlns:a16="http://schemas.microsoft.com/office/drawing/2014/main" id="{2E1AC8A9-8795-45F6-9522-77B44B35F271}"/>
+                <a16:creationId xmlns:a16="http://schemas.microsoft.com/office/drawing/2014/main" id="{824681F5-53C6-4FF6-859B-B6BE8E931342}"/>
               </a:ext>
             </a:extLst>
           </p:cNvPr>
@@ -5016,7 +5016,7 @@
           <p:nvPr/>
         </p:nvPicPr>
         <p:blipFill>
-          <a:blip xmlns:r="http://schemas.openxmlformats.org/officeDocument/2006/relationships" xmlns:a="http://schemas.openxmlformats.org/drawingml/2006/main" r:embed="Rffde4868e8a049fe"/>
+          <a:blip xmlns:r="http://schemas.openxmlformats.org/officeDocument/2006/relationships" xmlns:a="http://schemas.openxmlformats.org/drawingml/2006/main" r:embed="Rf8925c12e6274cb0"/>
           <a:stretch xmlns:a="http://schemas.openxmlformats.org/drawingml/2006/main"/>
         </p:blipFill>
         <p:spPr>
@@ -5032,7 +5032,7 @@
     </p:spTree>
     <p:extLst>
       <p:ext uri="{BB962C8B-B14F-4D97-AF65-F5344CB8AC3E}">
-        <p14:creationId xmlns:p14="http://schemas.microsoft.com/office/powerpoint/2010/main" val="552849572"/>
+        <p14:creationId xmlns:p14="http://schemas.microsoft.com/office/powerpoint/2010/main" val="1882836514"/>
       </p:ext>
     </p:extLst>
   </p:cSld>
@@ -5063,7 +5063,7 @@
           <p:cNvPr id="10" name="">
             <a:extLst xmlns:a="http://schemas.openxmlformats.org/drawingml/2006/main">
               <a:ext uri="{FF2B5EF4-FFF2-40B4-BE49-F238E27FC236}">
-                <a16:creationId xmlns:a16="http://schemas.microsoft.com/office/drawing/2014/main" id="{64F8859B-E830-46CB-A7F3-0970DD7A472C}"/>
+                <a16:creationId xmlns:a16="http://schemas.microsoft.com/office/drawing/2014/main" id="{4F64353B-1CC8-4B0D-B7B2-9095AABD062E}"/>
               </a:ext>
             </a:extLst>
           </p:cNvPr>
@@ -5073,10 +5073,10 @@
           <p:nvPr/>
         </p:nvPicPr>
         <p:blipFill>
-          <a:blip xmlns:r="http://schemas.openxmlformats.org/officeDocument/2006/relationships" xmlns:a="http://schemas.openxmlformats.org/drawingml/2006/main" r:embed="R4de3adb746eb4e8d">
+          <a:blip xmlns:r="http://schemas.openxmlformats.org/officeDocument/2006/relationships" xmlns:a="http://schemas.openxmlformats.org/drawingml/2006/main" r:embed="R735ab92dc8cf4c11">
             <a:extLst>
               <a:ext uri="{96DAC541-7B7A-43D3-8B79-37D633B846F1}">
-                <asvg:svgBlip xmlns:asvg="http://schemas.microsoft.com/office/drawing/2016/SVG/main" r:embed="Rd0c5423e34c54705"/>
+                <asvg:svgBlip xmlns:asvg="http://schemas.microsoft.com/office/drawing/2016/SVG/main" r:embed="R2761b0a93790419a"/>
               </a:ext>
             </a:extLst>
           </a:blip>
@@ -5097,7 +5097,7 @@
           <p:cNvPr id="2" name="title">
             <a:extLst xmlns:a="http://schemas.openxmlformats.org/drawingml/2006/main">
               <a:ext uri="{FF2B5EF4-FFF2-40B4-BE49-F238E27FC236}">
-                <a16:creationId xmlns:a16="http://schemas.microsoft.com/office/drawing/2014/main" id="{BBA63D27-A774-486D-B5BC-517C3630AC6C}"/>
+                <a16:creationId xmlns:a16="http://schemas.microsoft.com/office/drawing/2014/main" id="{FA2936D3-AC53-4282-8D16-E9EFE18834B5}"/>
               </a:ext>
             </a:extLst>
           </p:cNvPr>
@@ -5259,7 +5259,7 @@
           <p:cNvPr id="3" name="body">
             <a:extLst xmlns:a="http://schemas.openxmlformats.org/drawingml/2006/main">
               <a:ext uri="{FF2B5EF4-FFF2-40B4-BE49-F238E27FC236}">
-                <a16:creationId xmlns:a16="http://schemas.microsoft.com/office/drawing/2014/main" id="{66706AA4-7DD1-4036-8E03-E1A53546155E}"/>
+                <a16:creationId xmlns:a16="http://schemas.microsoft.com/office/drawing/2014/main" id="{3A978A13-6D1F-4439-996E-36E8C13E41B3}"/>
               </a:ext>
             </a:extLst>
           </p:cNvPr>
@@ -5421,7 +5421,7 @@
           <p:cNvPr id="4" name="page">
             <a:extLst xmlns:a="http://schemas.openxmlformats.org/drawingml/2006/main">
               <a:ext uri="{FF2B5EF4-FFF2-40B4-BE49-F238E27FC236}">
-                <a16:creationId xmlns:a16="http://schemas.microsoft.com/office/drawing/2014/main" id="{1771EA89-5982-4B62-9878-CDACD97B8AF4}"/>
+                <a16:creationId xmlns:a16="http://schemas.microsoft.com/office/drawing/2014/main" id="{8D44D0FD-F03E-4B2B-917B-E612C7337B79}"/>
               </a:ext>
             </a:extLst>
           </p:cNvPr>
@@ -5577,7 +5577,7 @@
           <p:cNvPr id="5" name="body">
             <a:extLst xmlns:a="http://schemas.openxmlformats.org/drawingml/2006/main">
               <a:ext uri="{FF2B5EF4-FFF2-40B4-BE49-F238E27FC236}">
-                <a16:creationId xmlns:a16="http://schemas.microsoft.com/office/drawing/2014/main" id="{A72FF149-5292-4C55-8E73-B85484515640}"/>
+                <a16:creationId xmlns:a16="http://schemas.microsoft.com/office/drawing/2014/main" id="{D8822E47-2973-40D7-A4D8-E8298B28C78E}"/>
               </a:ext>
             </a:extLst>
           </p:cNvPr>
@@ -5739,7 +5739,7 @@
           <p:cNvPr id="6" name="body">
             <a:extLst xmlns:a="http://schemas.openxmlformats.org/drawingml/2006/main">
               <a:ext uri="{FF2B5EF4-FFF2-40B4-BE49-F238E27FC236}">
-                <a16:creationId xmlns:a16="http://schemas.microsoft.com/office/drawing/2014/main" id="{A3CF780B-9E9E-476C-BDE0-CE8874328A93}"/>
+                <a16:creationId xmlns:a16="http://schemas.microsoft.com/office/drawing/2014/main" id="{BB42699D-7789-43E9-A275-E2F09C0943A6}"/>
               </a:ext>
             </a:extLst>
           </p:cNvPr>
@@ -5901,7 +5901,7 @@
           <p:cNvPr id="7" name="body">
             <a:extLst xmlns:a="http://schemas.openxmlformats.org/drawingml/2006/main">
               <a:ext uri="{FF2B5EF4-FFF2-40B4-BE49-F238E27FC236}">
-                <a16:creationId xmlns:a16="http://schemas.microsoft.com/office/drawing/2014/main" id="{3B091675-8D79-42A6-BF39-D85EAA27F36E}"/>
+                <a16:creationId xmlns:a16="http://schemas.microsoft.com/office/drawing/2014/main" id="{2DE9748F-9E69-4D4A-90C1-5C7E5285DC02}"/>
               </a:ext>
             </a:extLst>
           </p:cNvPr>
@@ -6063,7 +6063,7 @@
           <p:cNvPr id="8" name="body">
             <a:extLst xmlns:a="http://schemas.openxmlformats.org/drawingml/2006/main">
               <a:ext uri="{FF2B5EF4-FFF2-40B4-BE49-F238E27FC236}">
-                <a16:creationId xmlns:a16="http://schemas.microsoft.com/office/drawing/2014/main" id="{C1D29B11-094E-4583-BA05-EEAA131D5D6C}"/>
+                <a16:creationId xmlns:a16="http://schemas.microsoft.com/office/drawing/2014/main" id="{B5723B1D-F71F-4631-9685-B08FB59886E6}"/>
               </a:ext>
             </a:extLst>
           </p:cNvPr>
@@ -6225,7 +6225,7 @@
           <p:cNvPr id="9" name="source-note">
             <a:extLst xmlns:a="http://schemas.openxmlformats.org/drawingml/2006/main">
               <a:ext uri="{FF2B5EF4-FFF2-40B4-BE49-F238E27FC236}">
-                <a16:creationId xmlns:a16="http://schemas.microsoft.com/office/drawing/2014/main" id="{54208891-9E09-4C49-A736-CF66BA682F32}"/>
+                <a16:creationId xmlns:a16="http://schemas.microsoft.com/office/drawing/2014/main" id="{1186BD4A-7B95-44BA-AA71-AF580A1083CE}"/>
               </a:ext>
             </a:extLst>
           </p:cNvPr>
@@ -6385,7 +6385,7 @@
     </p:spTree>
     <p:extLst>
       <p:ext uri="{BB962C8B-B14F-4D97-AF65-F5344CB8AC3E}">
-        <p14:creationId xmlns:p14="http://schemas.microsoft.com/office/powerpoint/2010/main" val="98413026"/>
+        <p14:creationId xmlns:p14="http://schemas.microsoft.com/office/powerpoint/2010/main" val="1998073860"/>
       </p:ext>
     </p:extLst>
   </p:cSld>
@@ -6416,7 +6416,7 @@
           <p:cNvPr id="14" name="">
             <a:extLst xmlns:a="http://schemas.openxmlformats.org/drawingml/2006/main">
               <a:ext uri="{FF2B5EF4-FFF2-40B4-BE49-F238E27FC236}">
-                <a16:creationId xmlns:a16="http://schemas.microsoft.com/office/drawing/2014/main" id="{F4E8D548-49EA-4245-8F39-34A28A4345A4}"/>
+                <a16:creationId xmlns:a16="http://schemas.microsoft.com/office/drawing/2014/main" id="{A87AA617-7C30-4CB3-BC57-FEBCCA9498DA}"/>
               </a:ext>
             </a:extLst>
           </p:cNvPr>
@@ -6426,10 +6426,10 @@
           <p:nvPr/>
         </p:nvPicPr>
         <p:blipFill>
-          <a:blip xmlns:r="http://schemas.openxmlformats.org/officeDocument/2006/relationships" xmlns:a="http://schemas.openxmlformats.org/drawingml/2006/main" r:embed="R5d7c6c93870e4591">
+          <a:blip xmlns:r="http://schemas.openxmlformats.org/officeDocument/2006/relationships" xmlns:a="http://schemas.openxmlformats.org/drawingml/2006/main" r:embed="R49daea0f045049f3">
             <a:extLst>
               <a:ext uri="{96DAC541-7B7A-43D3-8B79-37D633B846F1}">
-                <asvg:svgBlip xmlns:asvg="http://schemas.microsoft.com/office/drawing/2016/SVG/main" r:embed="R73af28bc109e49ff"/>
+                <asvg:svgBlip xmlns:asvg="http://schemas.microsoft.com/office/drawing/2016/SVG/main" r:embed="R9b521e31f1064a78"/>
               </a:ext>
             </a:extLst>
           </a:blip>
@@ -6450,7 +6450,7 @@
           <p:cNvPr id="2" name="title">
             <a:extLst xmlns:a="http://schemas.openxmlformats.org/drawingml/2006/main">
               <a:ext uri="{FF2B5EF4-FFF2-40B4-BE49-F238E27FC236}">
-                <a16:creationId xmlns:a16="http://schemas.microsoft.com/office/drawing/2014/main" id="{BE81FB77-4E8A-4C66-AB5C-EA36A4F06DA9}"/>
+                <a16:creationId xmlns:a16="http://schemas.microsoft.com/office/drawing/2014/main" id="{12A0EF97-88D8-4538-BF61-7C7908CF7D91}"/>
               </a:ext>
             </a:extLst>
           </p:cNvPr>
@@ -6612,7 +6612,7 @@
           <p:cNvPr id="3" name="page">
             <a:extLst xmlns:a="http://schemas.openxmlformats.org/drawingml/2006/main">
               <a:ext uri="{FF2B5EF4-FFF2-40B4-BE49-F238E27FC236}">
-                <a16:creationId xmlns:a16="http://schemas.microsoft.com/office/drawing/2014/main" id="{9DF30089-AEEC-4B11-A190-2055F98DD72F}"/>
+                <a16:creationId xmlns:a16="http://schemas.microsoft.com/office/drawing/2014/main" id="{3D7C6BD6-BF57-45CB-AA31-1ADE35F14228}"/>
               </a:ext>
             </a:extLst>
           </p:cNvPr>
@@ -6768,7 +6768,7 @@
           <p:cNvPr id="4" name="body">
             <a:extLst xmlns:a="http://schemas.openxmlformats.org/drawingml/2006/main">
               <a:ext uri="{FF2B5EF4-FFF2-40B4-BE49-F238E27FC236}">
-                <a16:creationId xmlns:a16="http://schemas.microsoft.com/office/drawing/2014/main" id="{6F7BFBD1-15BE-433C-8CB2-8375E820EF46}"/>
+                <a16:creationId xmlns:a16="http://schemas.microsoft.com/office/drawing/2014/main" id="{3D16AE37-8C1A-4E86-BDD1-D56DE4AB18CD}"/>
               </a:ext>
             </a:extLst>
           </p:cNvPr>
@@ -6930,7 +6930,7 @@
           <p:cNvPr id="5" name="body">
             <a:extLst xmlns:a="http://schemas.openxmlformats.org/drawingml/2006/main">
               <a:ext uri="{FF2B5EF4-FFF2-40B4-BE49-F238E27FC236}">
-                <a16:creationId xmlns:a16="http://schemas.microsoft.com/office/drawing/2014/main" id="{6DD76752-FE0A-4393-AF46-340404741F92}"/>
+                <a16:creationId xmlns:a16="http://schemas.microsoft.com/office/drawing/2014/main" id="{DDF2FA6A-BC91-4517-893E-9EEEBE80EA04}"/>
               </a:ext>
             </a:extLst>
           </p:cNvPr>
@@ -7092,7 +7092,7 @@
           <p:cNvPr id="6" name="body">
             <a:extLst xmlns:a="http://schemas.openxmlformats.org/drawingml/2006/main">
               <a:ext uri="{FF2B5EF4-FFF2-40B4-BE49-F238E27FC236}">
-                <a16:creationId xmlns:a16="http://schemas.microsoft.com/office/drawing/2014/main" id="{CED7C219-E5CD-44F3-9880-4A4C04A37366}"/>
+                <a16:creationId xmlns:a16="http://schemas.microsoft.com/office/drawing/2014/main" id="{F9D2FF8F-708D-45AF-B222-949953A01963}"/>
               </a:ext>
             </a:extLst>
           </p:cNvPr>
@@ -7254,7 +7254,7 @@
           <p:cNvPr id="7" name="body">
             <a:extLst xmlns:a="http://schemas.openxmlformats.org/drawingml/2006/main">
               <a:ext uri="{FF2B5EF4-FFF2-40B4-BE49-F238E27FC236}">
-                <a16:creationId xmlns:a16="http://schemas.microsoft.com/office/drawing/2014/main" id="{5F601409-955F-4714-9CF3-EF0F1998ED2C}"/>
+                <a16:creationId xmlns:a16="http://schemas.microsoft.com/office/drawing/2014/main" id="{4C98C166-D571-4A9A-A438-AA0542F05D84}"/>
               </a:ext>
             </a:extLst>
           </p:cNvPr>
@@ -7416,7 +7416,7 @@
           <p:cNvPr id="8" name="body">
             <a:extLst xmlns:a="http://schemas.openxmlformats.org/drawingml/2006/main">
               <a:ext uri="{FF2B5EF4-FFF2-40B4-BE49-F238E27FC236}">
-                <a16:creationId xmlns:a16="http://schemas.microsoft.com/office/drawing/2014/main" id="{76A59AA5-E52E-4BAC-ABFF-A146D153C469}"/>
+                <a16:creationId xmlns:a16="http://schemas.microsoft.com/office/drawing/2014/main" id="{683B12B3-9D21-44C7-9F4E-0C0B59734A9A}"/>
               </a:ext>
             </a:extLst>
           </p:cNvPr>
@@ -7578,7 +7578,7 @@
           <p:cNvPr id="9" name="body">
             <a:extLst xmlns:a="http://schemas.openxmlformats.org/drawingml/2006/main">
               <a:ext uri="{FF2B5EF4-FFF2-40B4-BE49-F238E27FC236}">
-                <a16:creationId xmlns:a16="http://schemas.microsoft.com/office/drawing/2014/main" id="{2AE8CF01-3873-4B64-B25C-8B64BDBF15B8}"/>
+                <a16:creationId xmlns:a16="http://schemas.microsoft.com/office/drawing/2014/main" id="{DA9865CD-E10D-4639-857A-83B22F10FC69}"/>
               </a:ext>
             </a:extLst>
           </p:cNvPr>
@@ -7740,7 +7740,7 @@
           <p:cNvPr id="10" name="body">
             <a:extLst xmlns:a="http://schemas.openxmlformats.org/drawingml/2006/main">
               <a:ext uri="{FF2B5EF4-FFF2-40B4-BE49-F238E27FC236}">
-                <a16:creationId xmlns:a16="http://schemas.microsoft.com/office/drawing/2014/main" id="{05CC2FF5-2786-4F14-BC98-54F8998717DF}"/>
+                <a16:creationId xmlns:a16="http://schemas.microsoft.com/office/drawing/2014/main" id="{4E164CAF-AB5F-4C00-ADF4-CEEB318DEA61}"/>
               </a:ext>
             </a:extLst>
           </p:cNvPr>
@@ -7902,7 +7902,7 @@
           <p:cNvPr id="11" name="body">
             <a:extLst xmlns:a="http://schemas.openxmlformats.org/drawingml/2006/main">
               <a:ext uri="{FF2B5EF4-FFF2-40B4-BE49-F238E27FC236}">
-                <a16:creationId xmlns:a16="http://schemas.microsoft.com/office/drawing/2014/main" id="{61935C7A-5CB9-4C92-AA4E-D9615F55FE88}"/>
+                <a16:creationId xmlns:a16="http://schemas.microsoft.com/office/drawing/2014/main" id="{183E1E88-E140-4189-937D-DA097992308B}"/>
               </a:ext>
             </a:extLst>
           </p:cNvPr>
@@ -8064,7 +8064,7 @@
           <p:cNvPr id="12" name="body">
             <a:extLst xmlns:a="http://schemas.openxmlformats.org/drawingml/2006/main">
               <a:ext uri="{FF2B5EF4-FFF2-40B4-BE49-F238E27FC236}">
-                <a16:creationId xmlns:a16="http://schemas.microsoft.com/office/drawing/2014/main" id="{7E14293E-335C-48F7-9B8A-27FF8171A042}"/>
+                <a16:creationId xmlns:a16="http://schemas.microsoft.com/office/drawing/2014/main" id="{8C2B23DB-4A41-4297-A173-1F5C82B66037}"/>
               </a:ext>
             </a:extLst>
           </p:cNvPr>
@@ -8226,7 +8226,7 @@
           <p:cNvPr id="13" name="source-note">
             <a:extLst xmlns:a="http://schemas.openxmlformats.org/drawingml/2006/main">
               <a:ext uri="{FF2B5EF4-FFF2-40B4-BE49-F238E27FC236}">
-                <a16:creationId xmlns:a16="http://schemas.microsoft.com/office/drawing/2014/main" id="{1AEC754E-956F-4652-B284-06E01C6AA4A0}"/>
+                <a16:creationId xmlns:a16="http://schemas.microsoft.com/office/drawing/2014/main" id="{E3F073BB-99DE-4330-9760-E73953F35F5E}"/>
               </a:ext>
             </a:extLst>
           </p:cNvPr>
@@ -8386,7 +8386,7 @@
     </p:spTree>
     <p:extLst>
       <p:ext uri="{BB962C8B-B14F-4D97-AF65-F5344CB8AC3E}">
-        <p14:creationId xmlns:p14="http://schemas.microsoft.com/office/powerpoint/2010/main" val="1921461682"/>
+        <p14:creationId xmlns:p14="http://schemas.microsoft.com/office/powerpoint/2010/main" val="700056759"/>
       </p:ext>
     </p:extLst>
   </p:cSld>
@@ -8417,7 +8417,7 @@
           <p:cNvPr id="10" name="">
             <a:extLst xmlns:a="http://schemas.openxmlformats.org/drawingml/2006/main">
               <a:ext uri="{FF2B5EF4-FFF2-40B4-BE49-F238E27FC236}">
-                <a16:creationId xmlns:a16="http://schemas.microsoft.com/office/drawing/2014/main" id="{F37BD65C-EBC8-4A64-8BDB-475F6C6F2033}"/>
+                <a16:creationId xmlns:a16="http://schemas.microsoft.com/office/drawing/2014/main" id="{2E3FB991-C5EE-487C-974B-B9103A8C2A32}"/>
               </a:ext>
             </a:extLst>
           </p:cNvPr>
@@ -8427,10 +8427,10 @@
           <p:nvPr/>
         </p:nvPicPr>
         <p:blipFill>
-          <a:blip xmlns:r="http://schemas.openxmlformats.org/officeDocument/2006/relationships" xmlns:a="http://schemas.openxmlformats.org/drawingml/2006/main" r:embed="Ra6a04bb5c3124055">
+          <a:blip xmlns:r="http://schemas.openxmlformats.org/officeDocument/2006/relationships" xmlns:a="http://schemas.openxmlformats.org/drawingml/2006/main" r:embed="R26a3f86f547c49bb">
             <a:extLst>
               <a:ext uri="{96DAC541-7B7A-43D3-8B79-37D633B846F1}">
-                <asvg:svgBlip xmlns:asvg="http://schemas.microsoft.com/office/drawing/2016/SVG/main" r:embed="Rfe9ee70ee79540c4"/>
+                <asvg:svgBlip xmlns:asvg="http://schemas.microsoft.com/office/drawing/2016/SVG/main" r:embed="Rf90a6090419e4e2f"/>
               </a:ext>
             </a:extLst>
           </a:blip>
@@ -8451,7 +8451,7 @@
           <p:cNvPr id="2" name="page">
             <a:extLst xmlns:a="http://schemas.openxmlformats.org/drawingml/2006/main">
               <a:ext uri="{FF2B5EF4-FFF2-40B4-BE49-F238E27FC236}">
-                <a16:creationId xmlns:a16="http://schemas.microsoft.com/office/drawing/2014/main" id="{A5603607-7CD6-46B4-B4FB-BF09BCD6240C}"/>
+                <a16:creationId xmlns:a16="http://schemas.microsoft.com/office/drawing/2014/main" id="{3CEC05F4-2C50-4B83-85A6-FF7862C677D4}"/>
               </a:ext>
             </a:extLst>
           </p:cNvPr>
@@ -8607,7 +8607,7 @@
           <p:cNvPr id="3" name="title">
             <a:extLst xmlns:a="http://schemas.openxmlformats.org/drawingml/2006/main">
               <a:ext uri="{FF2B5EF4-FFF2-40B4-BE49-F238E27FC236}">
-                <a16:creationId xmlns:a16="http://schemas.microsoft.com/office/drawing/2014/main" id="{C4F9992B-A847-4B8F-B754-D09B7FFAB764}"/>
+                <a16:creationId xmlns:a16="http://schemas.microsoft.com/office/drawing/2014/main" id="{115C573D-6BBC-4C85-9F8F-CF9DA806BC99}"/>
               </a:ext>
             </a:extLst>
           </p:cNvPr>
@@ -8796,7 +8796,7 @@
           <p:cNvPr id="4" name="body">
             <a:extLst xmlns:a="http://schemas.openxmlformats.org/drawingml/2006/main">
               <a:ext uri="{FF2B5EF4-FFF2-40B4-BE49-F238E27FC236}">
-                <a16:creationId xmlns:a16="http://schemas.microsoft.com/office/drawing/2014/main" id="{68E0FF9E-8D84-4905-8091-C070983B3BBD}"/>
+                <a16:creationId xmlns:a16="http://schemas.microsoft.com/office/drawing/2014/main" id="{BF62D41B-57C3-448C-AD48-2FA6F80A2AD1}"/>
               </a:ext>
             </a:extLst>
           </p:cNvPr>
@@ -8985,7 +8985,7 @@
           <p:cNvPr id="5" name="body">
             <a:extLst xmlns:a="http://schemas.openxmlformats.org/drawingml/2006/main">
               <a:ext uri="{FF2B5EF4-FFF2-40B4-BE49-F238E27FC236}">
-                <a16:creationId xmlns:a16="http://schemas.microsoft.com/office/drawing/2014/main" id="{1529AF59-053F-403D-A5B9-9AE0B029C2F6}"/>
+                <a16:creationId xmlns:a16="http://schemas.microsoft.com/office/drawing/2014/main" id="{9EA790C8-2F11-46F4-A699-5B0C7BC5D435}"/>
               </a:ext>
             </a:extLst>
           </p:cNvPr>
@@ -9147,7 +9147,7 @@
           <p:cNvPr id="6" name="body">
             <a:extLst xmlns:a="http://schemas.openxmlformats.org/drawingml/2006/main">
               <a:ext uri="{FF2B5EF4-FFF2-40B4-BE49-F238E27FC236}">
-                <a16:creationId xmlns:a16="http://schemas.microsoft.com/office/drawing/2014/main" id="{87E4B560-B5E7-4DAE-93E2-EE5226412DE4}"/>
+                <a16:creationId xmlns:a16="http://schemas.microsoft.com/office/drawing/2014/main" id="{904427F9-EA20-4D4F-976E-46E6CC72921B}"/>
               </a:ext>
             </a:extLst>
           </p:cNvPr>
@@ -9309,7 +9309,7 @@
           <p:cNvPr id="7" name="source-note">
             <a:extLst xmlns:a="http://schemas.openxmlformats.org/drawingml/2006/main">
               <a:ext uri="{FF2B5EF4-FFF2-40B4-BE49-F238E27FC236}">
-                <a16:creationId xmlns:a16="http://schemas.microsoft.com/office/drawing/2014/main" id="{80510D39-2935-4B49-8E22-32B3A0C00670}"/>
+                <a16:creationId xmlns:a16="http://schemas.microsoft.com/office/drawing/2014/main" id="{CCD03270-6836-496F-AA76-F52DFF07305A}"/>
               </a:ext>
             </a:extLst>
           </p:cNvPr>
@@ -9471,7 +9471,7 @@
           <p:cNvPr id="8" name="body">
             <a:extLst xmlns:a="http://schemas.openxmlformats.org/drawingml/2006/main">
               <a:ext uri="{FF2B5EF4-FFF2-40B4-BE49-F238E27FC236}">
-                <a16:creationId xmlns:a16="http://schemas.microsoft.com/office/drawing/2014/main" id="{F4D66371-261C-4041-A4DD-70FAD93FDBDB}"/>
+                <a16:creationId xmlns:a16="http://schemas.microsoft.com/office/drawing/2014/main" id="{5869217B-C696-40F7-AA72-9395C02F9A77}"/>
               </a:ext>
             </a:extLst>
           </p:cNvPr>
@@ -9633,7 +9633,7 @@
           <p:cNvPr id="9" name="body">
             <a:extLst xmlns:a="http://schemas.openxmlformats.org/drawingml/2006/main">
               <a:ext uri="{FF2B5EF4-FFF2-40B4-BE49-F238E27FC236}">
-                <a16:creationId xmlns:a16="http://schemas.microsoft.com/office/drawing/2014/main" id="{E5A53FC9-9298-4365-AD2E-55C07C0AD4BD}"/>
+                <a16:creationId xmlns:a16="http://schemas.microsoft.com/office/drawing/2014/main" id="{0A8EC856-1B9F-436E-A2F9-5365F3584743}"/>
               </a:ext>
             </a:extLst>
           </p:cNvPr>
@@ -9793,7 +9793,7 @@
     </p:spTree>
     <p:extLst>
       <p:ext uri="{BB962C8B-B14F-4D97-AF65-F5344CB8AC3E}">
-        <p14:creationId xmlns:p14="http://schemas.microsoft.com/office/powerpoint/2010/main" val="1971031299"/>
+        <p14:creationId xmlns:p14="http://schemas.microsoft.com/office/powerpoint/2010/main" val="1595170306"/>
       </p:ext>
     </p:extLst>
   </p:cSld>
@@ -9824,7 +9824,7 @@
           <p:cNvPr id="14" name="">
             <a:extLst xmlns:a="http://schemas.openxmlformats.org/drawingml/2006/main">
               <a:ext uri="{FF2B5EF4-FFF2-40B4-BE49-F238E27FC236}">
-                <a16:creationId xmlns:a16="http://schemas.microsoft.com/office/drawing/2014/main" id="{C5DE6C04-BCD4-4F58-84E2-FCF695AE238B}"/>
+                <a16:creationId xmlns:a16="http://schemas.microsoft.com/office/drawing/2014/main" id="{3AF82B5B-2288-4D40-AC23-811EFB1D6DA6}"/>
               </a:ext>
             </a:extLst>
           </p:cNvPr>
@@ -9834,10 +9834,10 @@
           <p:nvPr/>
         </p:nvPicPr>
         <p:blipFill>
-          <a:blip xmlns:r="http://schemas.openxmlformats.org/officeDocument/2006/relationships" xmlns:a="http://schemas.openxmlformats.org/drawingml/2006/main" r:embed="R0c6c78e27e894b9f">
+          <a:blip xmlns:r="http://schemas.openxmlformats.org/officeDocument/2006/relationships" xmlns:a="http://schemas.openxmlformats.org/drawingml/2006/main" r:embed="R51989829011c48d4">
             <a:extLst>
               <a:ext uri="{96DAC541-7B7A-43D3-8B79-37D633B846F1}">
-                <asvg:svgBlip xmlns:asvg="http://schemas.microsoft.com/office/drawing/2016/SVG/main" r:embed="R96294a99041945ab"/>
+                <asvg:svgBlip xmlns:asvg="http://schemas.microsoft.com/office/drawing/2016/SVG/main" r:embed="R8b254640080c43e0"/>
               </a:ext>
             </a:extLst>
           </a:blip>
@@ -9858,7 +9858,7 @@
           <p:cNvPr id="2" name="title">
             <a:extLst xmlns:a="http://schemas.openxmlformats.org/drawingml/2006/main">
               <a:ext uri="{FF2B5EF4-FFF2-40B4-BE49-F238E27FC236}">
-                <a16:creationId xmlns:a16="http://schemas.microsoft.com/office/drawing/2014/main" id="{B5111A39-06CF-4B76-8E81-6026888F8C4D}"/>
+                <a16:creationId xmlns:a16="http://schemas.microsoft.com/office/drawing/2014/main" id="{B523E368-E39F-44B1-8BD7-6377D92BA640}"/>
               </a:ext>
             </a:extLst>
           </p:cNvPr>
@@ -10020,7 +10020,7 @@
           <p:cNvPr id="3" name="page">
             <a:extLst xmlns:a="http://schemas.openxmlformats.org/drawingml/2006/main">
               <a:ext uri="{FF2B5EF4-FFF2-40B4-BE49-F238E27FC236}">
-                <a16:creationId xmlns:a16="http://schemas.microsoft.com/office/drawing/2014/main" id="{C959E26E-3343-4B77-B593-092CA57B5890}"/>
+                <a16:creationId xmlns:a16="http://schemas.microsoft.com/office/drawing/2014/main" id="{86BF91D0-74F3-4B9D-8707-80A43116D441}"/>
               </a:ext>
             </a:extLst>
           </p:cNvPr>
@@ -10176,7 +10176,7 @@
           <p:cNvPr id="4" name="body">
             <a:extLst xmlns:a="http://schemas.openxmlformats.org/drawingml/2006/main">
               <a:ext uri="{FF2B5EF4-FFF2-40B4-BE49-F238E27FC236}">
-                <a16:creationId xmlns:a16="http://schemas.microsoft.com/office/drawing/2014/main" id="{1D8DEC59-57DE-4E7D-9B4E-3BDEA9E3D25A}"/>
+                <a16:creationId xmlns:a16="http://schemas.microsoft.com/office/drawing/2014/main" id="{86B1F7BA-BB0A-4293-8EA6-3DF8105897D8}"/>
               </a:ext>
             </a:extLst>
           </p:cNvPr>
@@ -10338,7 +10338,7 @@
           <p:cNvPr id="5" name="body">
             <a:extLst xmlns:a="http://schemas.openxmlformats.org/drawingml/2006/main">
               <a:ext uri="{FF2B5EF4-FFF2-40B4-BE49-F238E27FC236}">
-                <a16:creationId xmlns:a16="http://schemas.microsoft.com/office/drawing/2014/main" id="{93D7277C-1A1E-49EA-8152-634CB03CFDC9}"/>
+                <a16:creationId xmlns:a16="http://schemas.microsoft.com/office/drawing/2014/main" id="{0E80B08D-D595-4028-AB29-BB69C33C6E2B}"/>
               </a:ext>
             </a:extLst>
           </p:cNvPr>
@@ -10500,7 +10500,7 @@
           <p:cNvPr id="6" name="body">
             <a:extLst xmlns:a="http://schemas.openxmlformats.org/drawingml/2006/main">
               <a:ext uri="{FF2B5EF4-FFF2-40B4-BE49-F238E27FC236}">
-                <a16:creationId xmlns:a16="http://schemas.microsoft.com/office/drawing/2014/main" id="{D98F61E1-0102-4A06-AE44-2BE73ECE05B1}"/>
+                <a16:creationId xmlns:a16="http://schemas.microsoft.com/office/drawing/2014/main" id="{04055D20-5257-47A9-BEE2-F212BD14A51F}"/>
               </a:ext>
             </a:extLst>
           </p:cNvPr>
@@ -10662,7 +10662,7 @@
           <p:cNvPr id="7" name="body">
             <a:extLst xmlns:a="http://schemas.openxmlformats.org/drawingml/2006/main">
               <a:ext uri="{FF2B5EF4-FFF2-40B4-BE49-F238E27FC236}">
-                <a16:creationId xmlns:a16="http://schemas.microsoft.com/office/drawing/2014/main" id="{2E482332-3A13-4F22-856D-ABFEE3B70B13}"/>
+                <a16:creationId xmlns:a16="http://schemas.microsoft.com/office/drawing/2014/main" id="{BDF33322-8F50-454D-AB5B-E3E1B9175103}"/>
               </a:ext>
             </a:extLst>
           </p:cNvPr>
@@ -10824,7 +10824,7 @@
           <p:cNvPr id="8" name="body">
             <a:extLst xmlns:a="http://schemas.openxmlformats.org/drawingml/2006/main">
               <a:ext uri="{FF2B5EF4-FFF2-40B4-BE49-F238E27FC236}">
-                <a16:creationId xmlns:a16="http://schemas.microsoft.com/office/drawing/2014/main" id="{CA3E975D-79F1-4889-9992-03CCC2D63A4C}"/>
+                <a16:creationId xmlns:a16="http://schemas.microsoft.com/office/drawing/2014/main" id="{F0FB8210-0310-49BA-8445-DD4C6A94FF7A}"/>
               </a:ext>
             </a:extLst>
           </p:cNvPr>
@@ -10986,7 +10986,7 @@
           <p:cNvPr id="9" name="body">
             <a:extLst xmlns:a="http://schemas.openxmlformats.org/drawingml/2006/main">
               <a:ext uri="{FF2B5EF4-FFF2-40B4-BE49-F238E27FC236}">
-                <a16:creationId xmlns:a16="http://schemas.microsoft.com/office/drawing/2014/main" id="{14B4ABD1-00B0-4DE8-86B4-BB4AA49AAB8A}"/>
+                <a16:creationId xmlns:a16="http://schemas.microsoft.com/office/drawing/2014/main" id="{C00098EC-45A0-4B95-B19E-43997FC93D5D}"/>
               </a:ext>
             </a:extLst>
           </p:cNvPr>
@@ -11148,7 +11148,7 @@
           <p:cNvPr id="10" name="body">
             <a:extLst xmlns:a="http://schemas.openxmlformats.org/drawingml/2006/main">
               <a:ext uri="{FF2B5EF4-FFF2-40B4-BE49-F238E27FC236}">
-                <a16:creationId xmlns:a16="http://schemas.microsoft.com/office/drawing/2014/main" id="{B428F937-EB66-4AA2-8CDC-FF0A79FF87B2}"/>
+                <a16:creationId xmlns:a16="http://schemas.microsoft.com/office/drawing/2014/main" id="{E1ECA9E0-3B76-4869-8E93-528452236529}"/>
               </a:ext>
             </a:extLst>
           </p:cNvPr>
@@ -11310,7 +11310,7 @@
           <p:cNvPr id="11" name="body">
             <a:extLst xmlns:a="http://schemas.openxmlformats.org/drawingml/2006/main">
               <a:ext uri="{FF2B5EF4-FFF2-40B4-BE49-F238E27FC236}">
-                <a16:creationId xmlns:a16="http://schemas.microsoft.com/office/drawing/2014/main" id="{9ECB0900-B9F8-44DD-A92D-C5D5C5DA4365}"/>
+                <a16:creationId xmlns:a16="http://schemas.microsoft.com/office/drawing/2014/main" id="{7E5D223F-BCCF-473E-924B-D6033674AD9B}"/>
               </a:ext>
             </a:extLst>
           </p:cNvPr>
@@ -11472,7 +11472,7 @@
           <p:cNvPr id="12" name="body">
             <a:extLst xmlns:a="http://schemas.openxmlformats.org/drawingml/2006/main">
               <a:ext uri="{FF2B5EF4-FFF2-40B4-BE49-F238E27FC236}">
-                <a16:creationId xmlns:a16="http://schemas.microsoft.com/office/drawing/2014/main" id="{AB7B37DC-4C1F-4579-8423-312677527585}"/>
+                <a16:creationId xmlns:a16="http://schemas.microsoft.com/office/drawing/2014/main" id="{DD2B2E9C-25F6-4C49-93C9-B0881CBE8CDA}"/>
               </a:ext>
             </a:extLst>
           </p:cNvPr>
@@ -11634,7 +11634,7 @@
           <p:cNvPr id="13" name="source-note">
             <a:extLst xmlns:a="http://schemas.openxmlformats.org/drawingml/2006/main">
               <a:ext uri="{FF2B5EF4-FFF2-40B4-BE49-F238E27FC236}">
-                <a16:creationId xmlns:a16="http://schemas.microsoft.com/office/drawing/2014/main" id="{2F1122F3-C89F-49C7-8FBF-976A6E0B457E}"/>
+                <a16:creationId xmlns:a16="http://schemas.microsoft.com/office/drawing/2014/main" id="{280A6C49-B5FC-4B2C-8C42-AAE65E1DDEB2}"/>
               </a:ext>
             </a:extLst>
           </p:cNvPr>
@@ -11794,7 +11794,7 @@
     </p:spTree>
     <p:extLst>
       <p:ext uri="{BB962C8B-B14F-4D97-AF65-F5344CB8AC3E}">
-        <p14:creationId xmlns:p14="http://schemas.microsoft.com/office/powerpoint/2010/main" val="1044427096"/>
+        <p14:creationId xmlns:p14="http://schemas.microsoft.com/office/powerpoint/2010/main" val="1162679092"/>
       </p:ext>
     </p:extLst>
   </p:cSld>
@@ -11825,7 +11825,7 @@
           <p:cNvPr id="14" name="">
             <a:extLst xmlns:a="http://schemas.openxmlformats.org/drawingml/2006/main">
               <a:ext uri="{FF2B5EF4-FFF2-40B4-BE49-F238E27FC236}">
-                <a16:creationId xmlns:a16="http://schemas.microsoft.com/office/drawing/2014/main" id="{77629896-7922-48D9-8FAB-F172A3CDF40D}"/>
+                <a16:creationId xmlns:a16="http://schemas.microsoft.com/office/drawing/2014/main" id="{27A1E6A3-FED4-4C80-BBD8-6319B24548CD}"/>
               </a:ext>
             </a:extLst>
           </p:cNvPr>
@@ -11835,10 +11835,10 @@
           <p:nvPr/>
         </p:nvPicPr>
         <p:blipFill>
-          <a:blip xmlns:r="http://schemas.openxmlformats.org/officeDocument/2006/relationships" xmlns:a="http://schemas.openxmlformats.org/drawingml/2006/main" r:embed="R08b7e7e9a0f14400">
+          <a:blip xmlns:r="http://schemas.openxmlformats.org/officeDocument/2006/relationships" xmlns:a="http://schemas.openxmlformats.org/drawingml/2006/main" r:embed="Rf34c2203f663496d">
             <a:extLst>
               <a:ext uri="{96DAC541-7B7A-43D3-8B79-37D633B846F1}">
-                <asvg:svgBlip xmlns:asvg="http://schemas.microsoft.com/office/drawing/2016/SVG/main" r:embed="R3cbb914746104f65"/>
+                <asvg:svgBlip xmlns:asvg="http://schemas.microsoft.com/office/drawing/2016/SVG/main" r:embed="R11d2e996d88a4802"/>
               </a:ext>
             </a:extLst>
           </a:blip>
@@ -11859,7 +11859,7 @@
           <p:cNvPr id="2" name="title">
             <a:extLst xmlns:a="http://schemas.openxmlformats.org/drawingml/2006/main">
               <a:ext uri="{FF2B5EF4-FFF2-40B4-BE49-F238E27FC236}">
-                <a16:creationId xmlns:a16="http://schemas.microsoft.com/office/drawing/2014/main" id="{AA5DB990-1352-43E8-B137-09FC4526B3F3}"/>
+                <a16:creationId xmlns:a16="http://schemas.microsoft.com/office/drawing/2014/main" id="{41ACE784-8051-45AD-86F6-2CD8D02CB8AC}"/>
               </a:ext>
             </a:extLst>
           </p:cNvPr>
@@ -12021,7 +12021,7 @@
           <p:cNvPr id="3" name="body">
             <a:extLst xmlns:a="http://schemas.openxmlformats.org/drawingml/2006/main">
               <a:ext uri="{FF2B5EF4-FFF2-40B4-BE49-F238E27FC236}">
-                <a16:creationId xmlns:a16="http://schemas.microsoft.com/office/drawing/2014/main" id="{1E58EF20-B977-4746-A6B2-11965DEA28C8}"/>
+                <a16:creationId xmlns:a16="http://schemas.microsoft.com/office/drawing/2014/main" id="{C71DDD3C-22BB-4782-BD90-4BB1052BB50E}"/>
               </a:ext>
             </a:extLst>
           </p:cNvPr>
@@ -12183,7 +12183,7 @@
           <p:cNvPr id="4" name="page">
             <a:extLst xmlns:a="http://schemas.openxmlformats.org/drawingml/2006/main">
               <a:ext uri="{FF2B5EF4-FFF2-40B4-BE49-F238E27FC236}">
-                <a16:creationId xmlns:a16="http://schemas.microsoft.com/office/drawing/2014/main" id="{732FD828-8C03-4E5A-A8DB-526A3A6195A8}"/>
+                <a16:creationId xmlns:a16="http://schemas.microsoft.com/office/drawing/2014/main" id="{5855C2D9-3B13-44D2-AA5B-72DD14C86EC2}"/>
               </a:ext>
             </a:extLst>
           </p:cNvPr>
@@ -12339,7 +12339,7 @@
           <p:cNvPr id="5" name="body">
             <a:extLst xmlns:a="http://schemas.openxmlformats.org/drawingml/2006/main">
               <a:ext uri="{FF2B5EF4-FFF2-40B4-BE49-F238E27FC236}">
-                <a16:creationId xmlns:a16="http://schemas.microsoft.com/office/drawing/2014/main" id="{B96B3EA8-DAE7-4C9A-8531-FB08412E4A2E}"/>
+                <a16:creationId xmlns:a16="http://schemas.microsoft.com/office/drawing/2014/main" id="{061813E8-914D-4BD1-A7EE-C5CDA448E31B}"/>
               </a:ext>
             </a:extLst>
           </p:cNvPr>
@@ -12501,7 +12501,7 @@
           <p:cNvPr id="6" name="body">
             <a:extLst xmlns:a="http://schemas.openxmlformats.org/drawingml/2006/main">
               <a:ext uri="{FF2B5EF4-FFF2-40B4-BE49-F238E27FC236}">
-                <a16:creationId xmlns:a16="http://schemas.microsoft.com/office/drawing/2014/main" id="{7555EB02-B715-4264-BDCE-9C47C86E3685}"/>
+                <a16:creationId xmlns:a16="http://schemas.microsoft.com/office/drawing/2014/main" id="{58E289F8-F846-4AC4-8BAC-89602F624BEB}"/>
               </a:ext>
             </a:extLst>
           </p:cNvPr>
@@ -12663,7 +12663,7 @@
           <p:cNvPr id="7" name="body">
             <a:extLst xmlns:a="http://schemas.openxmlformats.org/drawingml/2006/main">
               <a:ext uri="{FF2B5EF4-FFF2-40B4-BE49-F238E27FC236}">
-                <a16:creationId xmlns:a16="http://schemas.microsoft.com/office/drawing/2014/main" id="{B6E59349-8CBA-46B0-B3FB-AE26135FAF84}"/>
+                <a16:creationId xmlns:a16="http://schemas.microsoft.com/office/drawing/2014/main" id="{FCE6F045-797C-43B2-8D7F-20AA879BDB49}"/>
               </a:ext>
             </a:extLst>
           </p:cNvPr>
@@ -12825,7 +12825,7 @@
           <p:cNvPr id="8" name="body">
             <a:extLst xmlns:a="http://schemas.openxmlformats.org/drawingml/2006/main">
               <a:ext uri="{FF2B5EF4-FFF2-40B4-BE49-F238E27FC236}">
-                <a16:creationId xmlns:a16="http://schemas.microsoft.com/office/drawing/2014/main" id="{B803DA31-2772-4A5C-937C-E33E373A8E70}"/>
+                <a16:creationId xmlns:a16="http://schemas.microsoft.com/office/drawing/2014/main" id="{1E9D0994-A602-4A86-AB81-FC8A425BE219}"/>
               </a:ext>
             </a:extLst>
           </p:cNvPr>
@@ -12987,7 +12987,7 @@
           <p:cNvPr id="9" name="body">
             <a:extLst xmlns:a="http://schemas.openxmlformats.org/drawingml/2006/main">
               <a:ext uri="{FF2B5EF4-FFF2-40B4-BE49-F238E27FC236}">
-                <a16:creationId xmlns:a16="http://schemas.microsoft.com/office/drawing/2014/main" id="{5E63B970-F259-4531-81E4-6F353BFFB887}"/>
+                <a16:creationId xmlns:a16="http://schemas.microsoft.com/office/drawing/2014/main" id="{AFC53FC3-57FE-469D-8E02-30B654CA464E}"/>
               </a:ext>
             </a:extLst>
           </p:cNvPr>
@@ -13149,7 +13149,7 @@
           <p:cNvPr id="10" name="body">
             <a:extLst xmlns:a="http://schemas.openxmlformats.org/drawingml/2006/main">
               <a:ext uri="{FF2B5EF4-FFF2-40B4-BE49-F238E27FC236}">
-                <a16:creationId xmlns:a16="http://schemas.microsoft.com/office/drawing/2014/main" id="{51E1F1C9-865F-4417-9447-91E1918DCA9A}"/>
+                <a16:creationId xmlns:a16="http://schemas.microsoft.com/office/drawing/2014/main" id="{5152A7E3-49EB-4E60-A698-BD81133D8E3C}"/>
               </a:ext>
             </a:extLst>
           </p:cNvPr>
@@ -13311,7 +13311,7 @@
           <p:cNvPr id="11" name="body">
             <a:extLst xmlns:a="http://schemas.openxmlformats.org/drawingml/2006/main">
               <a:ext uri="{FF2B5EF4-FFF2-40B4-BE49-F238E27FC236}">
-                <a16:creationId xmlns:a16="http://schemas.microsoft.com/office/drawing/2014/main" id="{DC26DFAD-0178-4E13-BC9D-41E9A229ADD7}"/>
+                <a16:creationId xmlns:a16="http://schemas.microsoft.com/office/drawing/2014/main" id="{6ABCCE63-2682-4536-BE92-54AD92CA339F}"/>
               </a:ext>
             </a:extLst>
           </p:cNvPr>
@@ -13473,7 +13473,7 @@
           <p:cNvPr id="12" name="body">
             <a:extLst xmlns:a="http://schemas.openxmlformats.org/drawingml/2006/main">
               <a:ext uri="{FF2B5EF4-FFF2-40B4-BE49-F238E27FC236}">
-                <a16:creationId xmlns:a16="http://schemas.microsoft.com/office/drawing/2014/main" id="{5A4DDC15-88E0-49ED-AA57-F3F386D1A5A4}"/>
+                <a16:creationId xmlns:a16="http://schemas.microsoft.com/office/drawing/2014/main" id="{CB6AE560-5088-4AFD-A954-40432D6CD2EA}"/>
               </a:ext>
             </a:extLst>
           </p:cNvPr>
@@ -13635,7 +13635,7 @@
           <p:cNvPr id="13" name="body">
             <a:extLst xmlns:a="http://schemas.openxmlformats.org/drawingml/2006/main">
               <a:ext uri="{FF2B5EF4-FFF2-40B4-BE49-F238E27FC236}">
-                <a16:creationId xmlns:a16="http://schemas.microsoft.com/office/drawing/2014/main" id="{0651CD44-F0D1-4965-A1BA-8207004445D8}"/>
+                <a16:creationId xmlns:a16="http://schemas.microsoft.com/office/drawing/2014/main" id="{1C678730-623A-4702-841D-1A2E74D85C69}"/>
               </a:ext>
             </a:extLst>
           </p:cNvPr>
@@ -13795,7 +13795,7 @@
     </p:spTree>
     <p:extLst>
       <p:ext uri="{BB962C8B-B14F-4D97-AF65-F5344CB8AC3E}">
-        <p14:creationId xmlns:p14="http://schemas.microsoft.com/office/powerpoint/2010/main" val="791008354"/>
+        <p14:creationId xmlns:p14="http://schemas.microsoft.com/office/powerpoint/2010/main" val="1817665201"/>
       </p:ext>
     </p:extLst>
   </p:cSld>
@@ -13826,7 +13826,7 @@
           <p:cNvPr id="18" name="">
             <a:extLst xmlns:a="http://schemas.openxmlformats.org/drawingml/2006/main">
               <a:ext uri="{FF2B5EF4-FFF2-40B4-BE49-F238E27FC236}">
-                <a16:creationId xmlns:a16="http://schemas.microsoft.com/office/drawing/2014/main" id="{C675D8DC-0FAE-45D2-B392-99EB1090A10E}"/>
+                <a16:creationId xmlns:a16="http://schemas.microsoft.com/office/drawing/2014/main" id="{F1B77480-F9A7-400E-839F-8F0CC294BCCC}"/>
               </a:ext>
             </a:extLst>
           </p:cNvPr>
@@ -13836,10 +13836,10 @@
           <p:nvPr/>
         </p:nvPicPr>
         <p:blipFill>
-          <a:blip xmlns:r="http://schemas.openxmlformats.org/officeDocument/2006/relationships" xmlns:a="http://schemas.openxmlformats.org/drawingml/2006/main" r:embed="R2ca089fb2078424a">
+          <a:blip xmlns:r="http://schemas.openxmlformats.org/officeDocument/2006/relationships" xmlns:a="http://schemas.openxmlformats.org/drawingml/2006/main" r:embed="Ree8cca8464a0410a">
             <a:extLst>
               <a:ext uri="{96DAC541-7B7A-43D3-8B79-37D633B846F1}">
-                <asvg:svgBlip xmlns:asvg="http://schemas.microsoft.com/office/drawing/2016/SVG/main" r:embed="R2e870fdf6a3f4d05"/>
+                <asvg:svgBlip xmlns:asvg="http://schemas.microsoft.com/office/drawing/2016/SVG/main" r:embed="R9c872a9e8e314f77"/>
               </a:ext>
             </a:extLst>
           </a:blip>
@@ -13860,7 +13860,7 @@
           <p:cNvPr id="2" name="title">
             <a:extLst xmlns:a="http://schemas.openxmlformats.org/drawingml/2006/main">
               <a:ext uri="{FF2B5EF4-FFF2-40B4-BE49-F238E27FC236}">
-                <a16:creationId xmlns:a16="http://schemas.microsoft.com/office/drawing/2014/main" id="{0DF283E0-4A42-47C7-8FA6-25289A030E7A}"/>
+                <a16:creationId xmlns:a16="http://schemas.microsoft.com/office/drawing/2014/main" id="{BE3BCC8A-1014-4F1E-88B2-2FC495BD6682}"/>
               </a:ext>
             </a:extLst>
           </p:cNvPr>
@@ -14022,7 +14022,7 @@
           <p:cNvPr id="3" name="page">
             <a:extLst xmlns:a="http://schemas.openxmlformats.org/drawingml/2006/main">
               <a:ext uri="{FF2B5EF4-FFF2-40B4-BE49-F238E27FC236}">
-                <a16:creationId xmlns:a16="http://schemas.microsoft.com/office/drawing/2014/main" id="{79B1A333-6731-4B81-B58B-BBD49D20D112}"/>
+                <a16:creationId xmlns:a16="http://schemas.microsoft.com/office/drawing/2014/main" id="{A2CBB948-156C-46D2-84BE-917F7CB7501F}"/>
               </a:ext>
             </a:extLst>
           </p:cNvPr>
@@ -14178,7 +14178,7 @@
           <p:cNvPr id="4" name="body">
             <a:extLst xmlns:a="http://schemas.openxmlformats.org/drawingml/2006/main">
               <a:ext uri="{FF2B5EF4-FFF2-40B4-BE49-F238E27FC236}">
-                <a16:creationId xmlns:a16="http://schemas.microsoft.com/office/drawing/2014/main" id="{E96B7470-6A59-4851-949E-6D8A33BE9750}"/>
+                <a16:creationId xmlns:a16="http://schemas.microsoft.com/office/drawing/2014/main" id="{52B556C3-D0CC-4038-859F-0F6F77E9A17A}"/>
               </a:ext>
             </a:extLst>
           </p:cNvPr>
@@ -14340,7 +14340,7 @@
           <p:cNvPr id="5" name="body">
             <a:extLst xmlns:a="http://schemas.openxmlformats.org/drawingml/2006/main">
               <a:ext uri="{FF2B5EF4-FFF2-40B4-BE49-F238E27FC236}">
-                <a16:creationId xmlns:a16="http://schemas.microsoft.com/office/drawing/2014/main" id="{697E8471-FD18-4A54-82CD-92854211B754}"/>
+                <a16:creationId xmlns:a16="http://schemas.microsoft.com/office/drawing/2014/main" id="{E72237C3-E39E-4CF0-AB40-1C635365791F}"/>
               </a:ext>
             </a:extLst>
           </p:cNvPr>
@@ -14502,7 +14502,7 @@
           <p:cNvPr id="6" name="body">
             <a:extLst xmlns:a="http://schemas.openxmlformats.org/drawingml/2006/main">
               <a:ext uri="{FF2B5EF4-FFF2-40B4-BE49-F238E27FC236}">
-                <a16:creationId xmlns:a16="http://schemas.microsoft.com/office/drawing/2014/main" id="{4D1E9B57-8B61-48B6-BD82-21D486CDB174}"/>
+                <a16:creationId xmlns:a16="http://schemas.microsoft.com/office/drawing/2014/main" id="{F3C47110-E373-4037-8C6D-1F8DD5CB7482}"/>
               </a:ext>
             </a:extLst>
           </p:cNvPr>
@@ -14664,7 +14664,7 @@
           <p:cNvPr id="7" name="body">
             <a:extLst xmlns:a="http://schemas.openxmlformats.org/drawingml/2006/main">
               <a:ext uri="{FF2B5EF4-FFF2-40B4-BE49-F238E27FC236}">
-                <a16:creationId xmlns:a16="http://schemas.microsoft.com/office/drawing/2014/main" id="{85299081-B3E7-4D2C-969A-6B6BC10D3E34}"/>
+                <a16:creationId xmlns:a16="http://schemas.microsoft.com/office/drawing/2014/main" id="{68AA09E3-E348-49EC-A404-8F5D4D2F638C}"/>
               </a:ext>
             </a:extLst>
           </p:cNvPr>
@@ -14826,7 +14826,7 @@
           <p:cNvPr id="8" name="body">
             <a:extLst xmlns:a="http://schemas.openxmlformats.org/drawingml/2006/main">
               <a:ext uri="{FF2B5EF4-FFF2-40B4-BE49-F238E27FC236}">
-                <a16:creationId xmlns:a16="http://schemas.microsoft.com/office/drawing/2014/main" id="{44572BE2-131E-4F36-A7CD-13AB9E885BF4}"/>
+                <a16:creationId xmlns:a16="http://schemas.microsoft.com/office/drawing/2014/main" id="{8AC49054-58F6-4736-ACC7-1ECDA47B75E1}"/>
               </a:ext>
             </a:extLst>
           </p:cNvPr>
@@ -14988,7 +14988,7 @@
           <p:cNvPr id="9" name="body">
             <a:extLst xmlns:a="http://schemas.openxmlformats.org/drawingml/2006/main">
               <a:ext uri="{FF2B5EF4-FFF2-40B4-BE49-F238E27FC236}">
-                <a16:creationId xmlns:a16="http://schemas.microsoft.com/office/drawing/2014/main" id="{0F44D8AB-2BC0-4A40-B635-F4BDECA5C904}"/>
+                <a16:creationId xmlns:a16="http://schemas.microsoft.com/office/drawing/2014/main" id="{FC32B935-8E27-424E-BA32-384475DE0643}"/>
               </a:ext>
             </a:extLst>
           </p:cNvPr>
@@ -15150,7 +15150,7 @@
           <p:cNvPr id="10" name="body">
             <a:extLst xmlns:a="http://schemas.openxmlformats.org/drawingml/2006/main">
               <a:ext uri="{FF2B5EF4-FFF2-40B4-BE49-F238E27FC236}">
-                <a16:creationId xmlns:a16="http://schemas.microsoft.com/office/drawing/2014/main" id="{DDE56349-92D3-41C9-917E-646DE245D56E}"/>
+                <a16:creationId xmlns:a16="http://schemas.microsoft.com/office/drawing/2014/main" id="{84209626-3851-49FC-A4BD-F60B1BBFD521}"/>
               </a:ext>
             </a:extLst>
           </p:cNvPr>
@@ -15312,7 +15312,7 @@
           <p:cNvPr id="11" name="body">
             <a:extLst xmlns:a="http://schemas.openxmlformats.org/drawingml/2006/main">
               <a:ext uri="{FF2B5EF4-FFF2-40B4-BE49-F238E27FC236}">
-                <a16:creationId xmlns:a16="http://schemas.microsoft.com/office/drawing/2014/main" id="{3FB08C1F-EFCE-4841-AA49-45A684FD1FEC}"/>
+                <a16:creationId xmlns:a16="http://schemas.microsoft.com/office/drawing/2014/main" id="{6D0E80C5-0896-4AF5-82B9-E7007048FBED}"/>
               </a:ext>
             </a:extLst>
           </p:cNvPr>
@@ -15474,7 +15474,7 @@
           <p:cNvPr id="12" name="body">
             <a:extLst xmlns:a="http://schemas.openxmlformats.org/drawingml/2006/main">
               <a:ext uri="{FF2B5EF4-FFF2-40B4-BE49-F238E27FC236}">
-                <a16:creationId xmlns:a16="http://schemas.microsoft.com/office/drawing/2014/main" id="{66865212-3690-48FA-B430-89628CA7C1F2}"/>
+                <a16:creationId xmlns:a16="http://schemas.microsoft.com/office/drawing/2014/main" id="{3FF5C785-032D-4239-8ABB-0DB5E6CC581A}"/>
               </a:ext>
             </a:extLst>
           </p:cNvPr>
@@ -15636,7 +15636,7 @@
           <p:cNvPr id="13" name="body">
             <a:extLst xmlns:a="http://schemas.openxmlformats.org/drawingml/2006/main">
               <a:ext uri="{FF2B5EF4-FFF2-40B4-BE49-F238E27FC236}">
-                <a16:creationId xmlns:a16="http://schemas.microsoft.com/office/drawing/2014/main" id="{784529D1-31B0-43E2-B4F5-8E949B343BE7}"/>
+                <a16:creationId xmlns:a16="http://schemas.microsoft.com/office/drawing/2014/main" id="{FE08CF75-EA09-49EE-A74C-96B22B0BC352}"/>
               </a:ext>
             </a:extLst>
           </p:cNvPr>
@@ -15798,7 +15798,7 @@
           <p:cNvPr id="14" name="body">
             <a:extLst xmlns:a="http://schemas.openxmlformats.org/drawingml/2006/main">
               <a:ext uri="{FF2B5EF4-FFF2-40B4-BE49-F238E27FC236}">
-                <a16:creationId xmlns:a16="http://schemas.microsoft.com/office/drawing/2014/main" id="{15C9669F-447D-4A11-AFD3-09A2E173DEE4}"/>
+                <a16:creationId xmlns:a16="http://schemas.microsoft.com/office/drawing/2014/main" id="{6305FD75-AF7B-49B2-854D-E5FF710381D7}"/>
               </a:ext>
             </a:extLst>
           </p:cNvPr>
@@ -15960,7 +15960,7 @@
           <p:cNvPr id="15" name="body">
             <a:extLst xmlns:a="http://schemas.openxmlformats.org/drawingml/2006/main">
               <a:ext uri="{FF2B5EF4-FFF2-40B4-BE49-F238E27FC236}">
-                <a16:creationId xmlns:a16="http://schemas.microsoft.com/office/drawing/2014/main" id="{121E8C67-BA9E-4F03-8E53-13FAEB0DCCE2}"/>
+                <a16:creationId xmlns:a16="http://schemas.microsoft.com/office/drawing/2014/main" id="{D8B1D57C-97FD-486D-8FF8-6E0A82352F74}"/>
               </a:ext>
             </a:extLst>
           </p:cNvPr>
@@ -16122,7 +16122,7 @@
           <p:cNvPr id="16" name="">
             <a:extLst xmlns:a="http://schemas.openxmlformats.org/drawingml/2006/main">
               <a:ext uri="{FF2B5EF4-FFF2-40B4-BE49-F238E27FC236}">
-                <a16:creationId xmlns:a16="http://schemas.microsoft.com/office/drawing/2014/main" id="{D435B813-5E60-430F-AF7D-699E6C16A144}"/>
+                <a16:creationId xmlns:a16="http://schemas.microsoft.com/office/drawing/2014/main" id="{01EC92E4-E221-464F-93BF-6690ED60E82D}"/>
               </a:ext>
             </a:extLst>
           </p:cNvPr>
@@ -16132,7 +16132,7 @@
           <p:nvPr/>
         </p:nvPicPr>
         <p:blipFill>
-          <a:blip xmlns:r="http://schemas.openxmlformats.org/officeDocument/2006/relationships" xmlns:a="http://schemas.openxmlformats.org/drawingml/2006/main" r:embed="R76dae6be98d442d1"/>
+          <a:blip xmlns:r="http://schemas.openxmlformats.org/officeDocument/2006/relationships" xmlns:a="http://schemas.openxmlformats.org/drawingml/2006/main" r:embed="Rec2611a6f67841e3"/>
           <a:stretch xmlns:a="http://schemas.openxmlformats.org/drawingml/2006/main"/>
         </p:blipFill>
         <p:spPr>
@@ -16150,7 +16150,7 @@
           <p:cNvPr id="17" name="source-note">
             <a:extLst xmlns:a="http://schemas.openxmlformats.org/drawingml/2006/main">
               <a:ext uri="{FF2B5EF4-FFF2-40B4-BE49-F238E27FC236}">
-                <a16:creationId xmlns:a16="http://schemas.microsoft.com/office/drawing/2014/main" id="{FB3B495B-5FB9-42AF-87F0-087F29C6F8E2}"/>
+                <a16:creationId xmlns:a16="http://schemas.microsoft.com/office/drawing/2014/main" id="{3A998281-8322-4B6F-870C-069905F317B0}"/>
               </a:ext>
             </a:extLst>
           </p:cNvPr>
@@ -16310,7 +16310,7 @@
     </p:spTree>
     <p:extLst>
       <p:ext uri="{BB962C8B-B14F-4D97-AF65-F5344CB8AC3E}">
-        <p14:creationId xmlns:p14="http://schemas.microsoft.com/office/powerpoint/2010/main" val="1801515763"/>
+        <p14:creationId xmlns:p14="http://schemas.microsoft.com/office/powerpoint/2010/main" val="799401741"/>
       </p:ext>
     </p:extLst>
   </p:cSld>
@@ -16341,7 +16341,7 @@
           <p:cNvPr id="8" name="">
             <a:extLst xmlns:a="http://schemas.openxmlformats.org/drawingml/2006/main">
               <a:ext uri="{FF2B5EF4-FFF2-40B4-BE49-F238E27FC236}">
-                <a16:creationId xmlns:a16="http://schemas.microsoft.com/office/drawing/2014/main" id="{91EAC45D-C2F5-44BB-AC3C-1521E5FB7BF9}"/>
+                <a16:creationId xmlns:a16="http://schemas.microsoft.com/office/drawing/2014/main" id="{CD11C8A9-355F-444C-91CC-004479B4F838}"/>
               </a:ext>
             </a:extLst>
           </p:cNvPr>
@@ -16351,10 +16351,10 @@
           <p:nvPr/>
         </p:nvPicPr>
         <p:blipFill>
-          <a:blip xmlns:r="http://schemas.openxmlformats.org/officeDocument/2006/relationships" xmlns:a="http://schemas.openxmlformats.org/drawingml/2006/main" r:embed="R1ed75f54b08f4a15">
+          <a:blip xmlns:r="http://schemas.openxmlformats.org/officeDocument/2006/relationships" xmlns:a="http://schemas.openxmlformats.org/drawingml/2006/main" r:embed="R22f5126fcb8942b4">
             <a:extLst>
               <a:ext uri="{96DAC541-7B7A-43D3-8B79-37D633B846F1}">
-                <asvg:svgBlip xmlns:asvg="http://schemas.microsoft.com/office/drawing/2016/SVG/main" r:embed="Rdc833d34c6d84618"/>
+                <asvg:svgBlip xmlns:asvg="http://schemas.microsoft.com/office/drawing/2016/SVG/main" r:embed="Re421f42ca4444987"/>
               </a:ext>
             </a:extLst>
           </a:blip>
@@ -16375,7 +16375,7 @@
           <p:cNvPr id="2" name="title">
             <a:extLst xmlns:a="http://schemas.openxmlformats.org/drawingml/2006/main">
               <a:ext uri="{FF2B5EF4-FFF2-40B4-BE49-F238E27FC236}">
-                <a16:creationId xmlns:a16="http://schemas.microsoft.com/office/drawing/2014/main" id="{5A08F8D9-2070-4947-80C8-8B05F569FB64}"/>
+                <a16:creationId xmlns:a16="http://schemas.microsoft.com/office/drawing/2014/main" id="{66E39773-434D-4055-9EE3-4948A055C470}"/>
               </a:ext>
             </a:extLst>
           </p:cNvPr>
@@ -16537,7 +16537,7 @@
           <p:cNvPr id="3" name="page">
             <a:extLst xmlns:a="http://schemas.openxmlformats.org/drawingml/2006/main">
               <a:ext uri="{FF2B5EF4-FFF2-40B4-BE49-F238E27FC236}">
-                <a16:creationId xmlns:a16="http://schemas.microsoft.com/office/drawing/2014/main" id="{16C75041-3699-4A5C-8EE5-F20E9E6D52DB}"/>
+                <a16:creationId xmlns:a16="http://schemas.microsoft.com/office/drawing/2014/main" id="{57FFEF25-C655-4526-ABF5-A72788BCBDB1}"/>
               </a:ext>
             </a:extLst>
           </p:cNvPr>
@@ -16693,7 +16693,7 @@
           <p:cNvPr id="4" name="">
             <a:extLst xmlns:a="http://schemas.openxmlformats.org/drawingml/2006/main">
               <a:ext uri="{FF2B5EF4-FFF2-40B4-BE49-F238E27FC236}">
-                <a16:creationId xmlns:a16="http://schemas.microsoft.com/office/drawing/2014/main" id="{4A8D471C-ED73-4C39-BCD3-F5D60CBEF23F}"/>
+                <a16:creationId xmlns:a16="http://schemas.microsoft.com/office/drawing/2014/main" id="{A92052C5-F720-45C6-B5D6-5EB0C13A6D03}"/>
               </a:ext>
             </a:extLst>
           </p:cNvPr>
@@ -16703,7 +16703,7 @@
           <p:nvPr/>
         </p:nvPicPr>
         <p:blipFill>
-          <a:blip xmlns:r="http://schemas.openxmlformats.org/officeDocument/2006/relationships" xmlns:a="http://schemas.openxmlformats.org/drawingml/2006/main" r:embed="Rd4a7ab1d8ac843d2"/>
+          <a:blip xmlns:r="http://schemas.openxmlformats.org/officeDocument/2006/relationships" xmlns:a="http://schemas.openxmlformats.org/drawingml/2006/main" r:embed="Re0c8923b8bb04343"/>
           <a:stretch xmlns:a="http://schemas.openxmlformats.org/drawingml/2006/main"/>
         </p:blipFill>
         <p:spPr>
@@ -16721,7 +16721,7 @@
           <p:cNvPr id="5" name="">
             <a:extLst xmlns:a="http://schemas.openxmlformats.org/drawingml/2006/main">
               <a:ext uri="{FF2B5EF4-FFF2-40B4-BE49-F238E27FC236}">
-                <a16:creationId xmlns:a16="http://schemas.microsoft.com/office/drawing/2014/main" id="{CDE1E9C5-E011-438E-A10F-4000A9F1AFB7}"/>
+                <a16:creationId xmlns:a16="http://schemas.microsoft.com/office/drawing/2014/main" id="{61D46D89-1EC6-4543-A4D6-A73BB8D9DE2B}"/>
               </a:ext>
             </a:extLst>
           </p:cNvPr>
@@ -16731,7 +16731,7 @@
           <p:nvPr/>
         </p:nvPicPr>
         <p:blipFill>
-          <a:blip xmlns:r="http://schemas.openxmlformats.org/officeDocument/2006/relationships" xmlns:a="http://schemas.openxmlformats.org/drawingml/2006/main" r:embed="R491b0286f12a4481"/>
+          <a:blip xmlns:r="http://schemas.openxmlformats.org/officeDocument/2006/relationships" xmlns:a="http://schemas.openxmlformats.org/drawingml/2006/main" r:embed="R295b5777a58c4efb"/>
           <a:stretch xmlns:a="http://schemas.openxmlformats.org/drawingml/2006/main"/>
         </p:blipFill>
         <p:spPr>
@@ -16749,7 +16749,7 @@
           <p:cNvPr id="6" name="body">
             <a:extLst xmlns:a="http://schemas.openxmlformats.org/drawingml/2006/main">
               <a:ext uri="{FF2B5EF4-FFF2-40B4-BE49-F238E27FC236}">
-                <a16:creationId xmlns:a16="http://schemas.microsoft.com/office/drawing/2014/main" id="{5D7D7C08-B342-43C7-900A-B22A142A6E9F}"/>
+                <a16:creationId xmlns:a16="http://schemas.microsoft.com/office/drawing/2014/main" id="{34B2AC44-4A51-4D3F-8998-77617E8193A1}"/>
               </a:ext>
             </a:extLst>
           </p:cNvPr>
@@ -16938,7 +16938,7 @@
           <p:cNvPr id="7" name="body">
             <a:extLst xmlns:a="http://schemas.openxmlformats.org/drawingml/2006/main">
               <a:ext uri="{FF2B5EF4-FFF2-40B4-BE49-F238E27FC236}">
-                <a16:creationId xmlns:a16="http://schemas.microsoft.com/office/drawing/2014/main" id="{61C74EFF-A117-481A-B335-637D92499424}"/>
+                <a16:creationId xmlns:a16="http://schemas.microsoft.com/office/drawing/2014/main" id="{FBA4EE99-B033-4ABE-B039-1C5D1138FFC6}"/>
               </a:ext>
             </a:extLst>
           </p:cNvPr>
@@ -17162,7 +17162,7 @@
     </p:spTree>
     <p:extLst>
       <p:ext uri="{BB962C8B-B14F-4D97-AF65-F5344CB8AC3E}">
-        <p14:creationId xmlns:p14="http://schemas.microsoft.com/office/powerpoint/2010/main" val="201970832"/>
+        <p14:creationId xmlns:p14="http://schemas.microsoft.com/office/powerpoint/2010/main" val="802754775"/>
       </p:ext>
     </p:extLst>
   </p:cSld>
@@ -17193,7 +17193,7 @@
           <p:cNvPr id="8" name="">
             <a:extLst xmlns:a="http://schemas.openxmlformats.org/drawingml/2006/main">
               <a:ext uri="{FF2B5EF4-FFF2-40B4-BE49-F238E27FC236}">
-                <a16:creationId xmlns:a16="http://schemas.microsoft.com/office/drawing/2014/main" id="{CA5244EB-012D-4CBE-9203-9FE796DF75A7}"/>
+                <a16:creationId xmlns:a16="http://schemas.microsoft.com/office/drawing/2014/main" id="{2BF83F93-4F0F-428C-9830-1FDC11CFBDC1}"/>
               </a:ext>
             </a:extLst>
           </p:cNvPr>
@@ -17203,10 +17203,10 @@
           <p:nvPr/>
         </p:nvPicPr>
         <p:blipFill>
-          <a:blip xmlns:r="http://schemas.openxmlformats.org/officeDocument/2006/relationships" xmlns:a="http://schemas.openxmlformats.org/drawingml/2006/main" r:embed="Ra4ee8eaf03844052">
+          <a:blip xmlns:r="http://schemas.openxmlformats.org/officeDocument/2006/relationships" xmlns:a="http://schemas.openxmlformats.org/drawingml/2006/main" r:embed="Rb0e214bbce2a4f6c">
             <a:extLst>
               <a:ext uri="{96DAC541-7B7A-43D3-8B79-37D633B846F1}">
-                <asvg:svgBlip xmlns:asvg="http://schemas.microsoft.com/office/drawing/2016/SVG/main" r:embed="R94b1b4f21e0241a5"/>
+                <asvg:svgBlip xmlns:asvg="http://schemas.microsoft.com/office/drawing/2016/SVG/main" r:embed="R6afb9585ea7f4ef3"/>
               </a:ext>
             </a:extLst>
           </a:blip>
@@ -17227,7 +17227,7 @@
           <p:cNvPr id="2" name="title">
             <a:extLst xmlns:a="http://schemas.openxmlformats.org/drawingml/2006/main">
               <a:ext uri="{FF2B5EF4-FFF2-40B4-BE49-F238E27FC236}">
-                <a16:creationId xmlns:a16="http://schemas.microsoft.com/office/drawing/2014/main" id="{0A0364A8-6A25-41BC-907F-05B20FF9D8C3}"/>
+                <a16:creationId xmlns:a16="http://schemas.microsoft.com/office/drawing/2014/main" id="{EA445922-8986-4812-BCF3-6498E4E1E609}"/>
               </a:ext>
             </a:extLst>
           </p:cNvPr>
@@ -17389,7 +17389,7 @@
           <p:cNvPr id="3" name="page">
             <a:extLst xmlns:a="http://schemas.openxmlformats.org/drawingml/2006/main">
               <a:ext uri="{FF2B5EF4-FFF2-40B4-BE49-F238E27FC236}">
-                <a16:creationId xmlns:a16="http://schemas.microsoft.com/office/drawing/2014/main" id="{C26AA3CD-9208-4356-BAA0-28FA3D81EC88}"/>
+                <a16:creationId xmlns:a16="http://schemas.microsoft.com/office/drawing/2014/main" id="{163D7D27-2C5D-4F99-A3FA-8B49B69A7B33}"/>
               </a:ext>
             </a:extLst>
           </p:cNvPr>
@@ -17545,7 +17545,7 @@
           <p:cNvPr id="4" name="">
             <a:extLst xmlns:a="http://schemas.openxmlformats.org/drawingml/2006/main">
               <a:ext uri="{FF2B5EF4-FFF2-40B4-BE49-F238E27FC236}">
-                <a16:creationId xmlns:a16="http://schemas.microsoft.com/office/drawing/2014/main" id="{6AA7A09B-9049-4288-9B0D-8943FA0F4E59}"/>
+                <a16:creationId xmlns:a16="http://schemas.microsoft.com/office/drawing/2014/main" id="{E6FF0DED-DE37-4387-825C-936695945D9D}"/>
               </a:ext>
             </a:extLst>
           </p:cNvPr>
@@ -17555,7 +17555,7 @@
           <p:nvPr/>
         </p:nvPicPr>
         <p:blipFill>
-          <a:blip xmlns:r="http://schemas.openxmlformats.org/officeDocument/2006/relationships" xmlns:a="http://schemas.openxmlformats.org/drawingml/2006/main" r:embed="R7e421a90b4e54d2b"/>
+          <a:blip xmlns:r="http://schemas.openxmlformats.org/officeDocument/2006/relationships" xmlns:a="http://schemas.openxmlformats.org/drawingml/2006/main" r:embed="R9fc87d57ce1345c9"/>
           <a:stretch xmlns:a="http://schemas.openxmlformats.org/drawingml/2006/main"/>
         </p:blipFill>
         <p:spPr>
@@ -17573,7 +17573,7 @@
           <p:cNvPr id="5" name="body">
             <a:extLst xmlns:a="http://schemas.openxmlformats.org/drawingml/2006/main">
               <a:ext uri="{FF2B5EF4-FFF2-40B4-BE49-F238E27FC236}">
-                <a16:creationId xmlns:a16="http://schemas.microsoft.com/office/drawing/2014/main" id="{D6FAF70D-4359-4079-93D7-2CFD196541F6}"/>
+                <a16:creationId xmlns:a16="http://schemas.microsoft.com/office/drawing/2014/main" id="{E0FB1A86-4469-4722-9BBB-201DDD1048E3}"/>
               </a:ext>
             </a:extLst>
           </p:cNvPr>
@@ -17762,7 +17762,7 @@
           <p:cNvPr id="6" name="body">
             <a:extLst xmlns:a="http://schemas.openxmlformats.org/drawingml/2006/main">
               <a:ext uri="{FF2B5EF4-FFF2-40B4-BE49-F238E27FC236}">
-                <a16:creationId xmlns:a16="http://schemas.microsoft.com/office/drawing/2014/main" id="{07BEF6C9-4E62-4E2E-811B-05A36D97DDB0}"/>
+                <a16:creationId xmlns:a16="http://schemas.microsoft.com/office/drawing/2014/main" id="{1442F50A-32E0-41DF-A44E-007A83C401C7}"/>
               </a:ext>
             </a:extLst>
           </p:cNvPr>
@@ -17956,7 +17956,7 @@
           <p:cNvPr id="7" name="source-note">
             <a:extLst xmlns:a="http://schemas.openxmlformats.org/drawingml/2006/main">
               <a:ext uri="{FF2B5EF4-FFF2-40B4-BE49-F238E27FC236}">
-                <a16:creationId xmlns:a16="http://schemas.microsoft.com/office/drawing/2014/main" id="{282FA67B-B7D5-45DD-AD90-9AC669789A12}"/>
+                <a16:creationId xmlns:a16="http://schemas.microsoft.com/office/drawing/2014/main" id="{7BA10462-0BD0-4E26-B8D3-303B48AE43C7}"/>
               </a:ext>
             </a:extLst>
           </p:cNvPr>
@@ -18116,7 +18116,7 @@
     </p:spTree>
     <p:extLst>
       <p:ext uri="{BB962C8B-B14F-4D97-AF65-F5344CB8AC3E}">
-        <p14:creationId xmlns:p14="http://schemas.microsoft.com/office/powerpoint/2010/main" val="3077326"/>
+        <p14:creationId xmlns:p14="http://schemas.microsoft.com/office/powerpoint/2010/main" val="755022682"/>
       </p:ext>
     </p:extLst>
   </p:cSld>
@@ -18147,7 +18147,7 @@
           <p:cNvPr id="10" name="">
             <a:extLst xmlns:a="http://schemas.openxmlformats.org/drawingml/2006/main">
               <a:ext uri="{FF2B5EF4-FFF2-40B4-BE49-F238E27FC236}">
-                <a16:creationId xmlns:a16="http://schemas.microsoft.com/office/drawing/2014/main" id="{80CF9A73-0EEA-4BA9-89E0-70D1368BCF98}"/>
+                <a16:creationId xmlns:a16="http://schemas.microsoft.com/office/drawing/2014/main" id="{87DF1B55-BB4F-4421-9ABF-5BEFF4D6FF25}"/>
               </a:ext>
             </a:extLst>
           </p:cNvPr>
@@ -18157,10 +18157,10 @@
           <p:nvPr/>
         </p:nvPicPr>
         <p:blipFill>
-          <a:blip xmlns:r="http://schemas.openxmlformats.org/officeDocument/2006/relationships" xmlns:a="http://schemas.openxmlformats.org/drawingml/2006/main" r:embed="R9b4fbdb1fb44434b">
+          <a:blip xmlns:r="http://schemas.openxmlformats.org/officeDocument/2006/relationships" xmlns:a="http://schemas.openxmlformats.org/drawingml/2006/main" r:embed="R9e9edbe1c2d9444c">
             <a:extLst>
               <a:ext uri="{96DAC541-7B7A-43D3-8B79-37D633B846F1}">
-                <asvg:svgBlip xmlns:asvg="http://schemas.microsoft.com/office/drawing/2016/SVG/main" r:embed="Rce378ebae1f540d6"/>
+                <asvg:svgBlip xmlns:asvg="http://schemas.microsoft.com/office/drawing/2016/SVG/main" r:embed="Rb97415d41a42403f"/>
               </a:ext>
             </a:extLst>
           </a:blip>
@@ -18181,7 +18181,7 @@
           <p:cNvPr id="2" name="title">
             <a:extLst xmlns:a="http://schemas.openxmlformats.org/drawingml/2006/main">
               <a:ext uri="{FF2B5EF4-FFF2-40B4-BE49-F238E27FC236}">
-                <a16:creationId xmlns:a16="http://schemas.microsoft.com/office/drawing/2014/main" id="{101FA226-1000-4772-92E7-15C361FC2DAD}"/>
+                <a16:creationId xmlns:a16="http://schemas.microsoft.com/office/drawing/2014/main" id="{54FECCCA-B0F9-4107-BB0F-FBDF5D601B1F}"/>
               </a:ext>
             </a:extLst>
           </p:cNvPr>
@@ -18343,7 +18343,7 @@
           <p:cNvPr id="3" name="page">
             <a:extLst xmlns:a="http://schemas.openxmlformats.org/drawingml/2006/main">
               <a:ext uri="{FF2B5EF4-FFF2-40B4-BE49-F238E27FC236}">
-                <a16:creationId xmlns:a16="http://schemas.microsoft.com/office/drawing/2014/main" id="{FAC532EC-EBAD-437E-BCB3-212D5F373DA5}"/>
+                <a16:creationId xmlns:a16="http://schemas.microsoft.com/office/drawing/2014/main" id="{9DA8698E-E968-4486-8B9B-49A9B56FBA90}"/>
               </a:ext>
             </a:extLst>
           </p:cNvPr>
@@ -18499,7 +18499,7 @@
           <p:cNvPr id="4" name="body">
             <a:extLst xmlns:a="http://schemas.openxmlformats.org/drawingml/2006/main">
               <a:ext uri="{FF2B5EF4-FFF2-40B4-BE49-F238E27FC236}">
-                <a16:creationId xmlns:a16="http://schemas.microsoft.com/office/drawing/2014/main" id="{C6737D77-E8A5-4EC4-959E-AF8293557C37}"/>
+                <a16:creationId xmlns:a16="http://schemas.microsoft.com/office/drawing/2014/main" id="{C936CD26-6199-4919-8D88-0CEED45C0DAF}"/>
               </a:ext>
             </a:extLst>
           </p:cNvPr>
@@ -18661,7 +18661,7 @@
           <p:cNvPr id="5" name="body">
             <a:extLst xmlns:a="http://schemas.openxmlformats.org/drawingml/2006/main">
               <a:ext uri="{FF2B5EF4-FFF2-40B4-BE49-F238E27FC236}">
-                <a16:creationId xmlns:a16="http://schemas.microsoft.com/office/drawing/2014/main" id="{5B01CBF8-A698-4209-8149-3113DCB34F3E}"/>
+                <a16:creationId xmlns:a16="http://schemas.microsoft.com/office/drawing/2014/main" id="{49DFB240-BD32-45FE-9B25-431A34E9BCB3}"/>
               </a:ext>
             </a:extLst>
           </p:cNvPr>
@@ -18813,34 +18813,7 @@
                 <a:ea typeface="Be Vietnam Pro"/>
                 <a:cs typeface="Be Vietnam Pro"/>
               </a:rPr>
-              <a:t>Supabase Storage in the demo.</a:t>
-            </a:r>
-          </a:p>
-          <a:p xmlns:a="http://schemas.openxmlformats.org/drawingml/2006/main">
-            <a:pPr>
-              <a:lnSpc>
-                <a:spcPct val="116000"/>
-              </a:lnSpc>
-              <a:buNone/>
-              <a:defRPr sz="2025" b="0">
-                <a:solidFill>
-                  <a:srgbClr val="665F68"/>
-                </a:solidFill>
-                <a:latin typeface="Be Vietnam Pro"/>
-                <a:ea typeface="Be Vietnam Pro"/>
-                <a:cs typeface="Be Vietnam Pro"/>
-              </a:defRPr>
-            </a:pPr>
-            <a:r>
-              <a:rPr sz="2025" b="0">
-                <a:solidFill>
-                  <a:srgbClr val="665F68"/>
-                </a:solidFill>
-                <a:latin typeface="Be Vietnam Pro"/>
-                <a:ea typeface="Be Vietnam Pro"/>
-                <a:cs typeface="Be Vietnam Pro"/>
-              </a:rPr>
-              <a:t>IPFS/Pinata support in code.</a:t>
+              <a:t>Kept in private storage.</a:t>
             </a:r>
           </a:p>
         </p:txBody>
@@ -18850,7 +18823,7 @@
           <p:cNvPr id="6" name="body">
             <a:extLst xmlns:a="http://schemas.openxmlformats.org/drawingml/2006/main">
               <a:ext uri="{FF2B5EF4-FFF2-40B4-BE49-F238E27FC236}">
-                <a16:creationId xmlns:a16="http://schemas.microsoft.com/office/drawing/2014/main" id="{F09FBD5A-FF2E-488D-A6B1-8B639E05AC95}"/>
+                <a16:creationId xmlns:a16="http://schemas.microsoft.com/office/drawing/2014/main" id="{2651BD79-8D44-44CA-A909-1EDB6541EC6F}"/>
               </a:ext>
             </a:extLst>
           </p:cNvPr>
@@ -19012,7 +18985,7 @@
           <p:cNvPr id="7" name="body">
             <a:extLst xmlns:a="http://schemas.openxmlformats.org/drawingml/2006/main">
               <a:ext uri="{FF2B5EF4-FFF2-40B4-BE49-F238E27FC236}">
-                <a16:creationId xmlns:a16="http://schemas.microsoft.com/office/drawing/2014/main" id="{5C936461-38DB-4C42-B012-5293984B2EA1}"/>
+                <a16:creationId xmlns:a16="http://schemas.microsoft.com/office/drawing/2014/main" id="{D4C549BE-2818-43D8-BF6F-22FD0969E244}"/>
               </a:ext>
             </a:extLst>
           </p:cNvPr>
@@ -19164,7 +19137,7 @@
                 <a:ea typeface="Be Vietnam Pro"/>
                 <a:cs typeface="Be Vietnam Pro"/>
               </a:rPr>
-              <a:t>NFT metadata on Solana devnet links the record to the file.</a:t>
+              <a:t>Solana devnet NFT records the file’s SHA-256 fingerprint.</a:t>
             </a:r>
           </a:p>
         </p:txBody>
@@ -19174,7 +19147,7 @@
           <p:cNvPr id="8" name="">
             <a:extLst xmlns:a="http://schemas.openxmlformats.org/drawingml/2006/main">
               <a:ext uri="{FF2B5EF4-FFF2-40B4-BE49-F238E27FC236}">
-                <a16:creationId xmlns:a16="http://schemas.microsoft.com/office/drawing/2014/main" id="{52B22DE7-F70F-4575-B71E-A23947492FE2}"/>
+                <a16:creationId xmlns:a16="http://schemas.microsoft.com/office/drawing/2014/main" id="{7F57B8CD-32EE-4466-BA8B-EA333622455F}"/>
               </a:ext>
             </a:extLst>
           </p:cNvPr>
@@ -19184,7 +19157,7 @@
           <p:nvPr/>
         </p:nvPicPr>
         <p:blipFill>
-          <a:blip xmlns:r="http://schemas.openxmlformats.org/officeDocument/2006/relationships" xmlns:a="http://schemas.openxmlformats.org/drawingml/2006/main" r:embed="R0a32ae08891e4c93"/>
+          <a:blip xmlns:r="http://schemas.openxmlformats.org/officeDocument/2006/relationships" xmlns:a="http://schemas.openxmlformats.org/drawingml/2006/main" r:embed="Rf5fbe18e3f07497a"/>
           <a:stretch xmlns:a="http://schemas.openxmlformats.org/drawingml/2006/main"/>
         </p:blipFill>
         <p:spPr>
@@ -19202,7 +19175,7 @@
           <p:cNvPr id="9" name="source-note">
             <a:extLst xmlns:a="http://schemas.openxmlformats.org/drawingml/2006/main">
               <a:ext uri="{FF2B5EF4-FFF2-40B4-BE49-F238E27FC236}">
-                <a16:creationId xmlns:a16="http://schemas.microsoft.com/office/drawing/2014/main" id="{CEA4C0BD-7DA6-4F3B-8C36-11B7C7DA5FBD}"/>
+                <a16:creationId xmlns:a16="http://schemas.microsoft.com/office/drawing/2014/main" id="{B3F5562A-1A9C-4CF3-A581-DE93793FFC27}"/>
               </a:ext>
             </a:extLst>
           </p:cNvPr>
@@ -19362,7 +19335,7 @@
     </p:spTree>
     <p:extLst>
       <p:ext uri="{BB962C8B-B14F-4D97-AF65-F5344CB8AC3E}">
-        <p14:creationId xmlns:p14="http://schemas.microsoft.com/office/powerpoint/2010/main" val="1190115989"/>
+        <p14:creationId xmlns:p14="http://schemas.microsoft.com/office/powerpoint/2010/main" val="1970954478"/>
       </p:ext>
     </p:extLst>
   </p:cSld>
@@ -19393,7 +19366,7 @@
           <p:cNvPr id="16" name="">
             <a:extLst xmlns:a="http://schemas.openxmlformats.org/drawingml/2006/main">
               <a:ext uri="{FF2B5EF4-FFF2-40B4-BE49-F238E27FC236}">
-                <a16:creationId xmlns:a16="http://schemas.microsoft.com/office/drawing/2014/main" id="{C6C31FC9-9139-4093-BAE1-90B353A33C40}"/>
+                <a16:creationId xmlns:a16="http://schemas.microsoft.com/office/drawing/2014/main" id="{BCB5647E-494B-404F-B5D7-43837D624F81}"/>
               </a:ext>
             </a:extLst>
           </p:cNvPr>
@@ -19403,10 +19376,10 @@
           <p:nvPr/>
         </p:nvPicPr>
         <p:blipFill>
-          <a:blip xmlns:r="http://schemas.openxmlformats.org/officeDocument/2006/relationships" xmlns:a="http://schemas.openxmlformats.org/drawingml/2006/main" r:embed="R516ea89f15e54a99">
+          <a:blip xmlns:r="http://schemas.openxmlformats.org/officeDocument/2006/relationships" xmlns:a="http://schemas.openxmlformats.org/drawingml/2006/main" r:embed="Rf82810746ba24e23">
             <a:extLst>
               <a:ext uri="{96DAC541-7B7A-43D3-8B79-37D633B846F1}">
-                <asvg:svgBlip xmlns:asvg="http://schemas.microsoft.com/office/drawing/2016/SVG/main" r:embed="R92a33ab6e6a04af4"/>
+                <asvg:svgBlip xmlns:asvg="http://schemas.microsoft.com/office/drawing/2016/SVG/main" r:embed="R24bd943e94644966"/>
               </a:ext>
             </a:extLst>
           </a:blip>
@@ -19427,7 +19400,7 @@
           <p:cNvPr id="2" name="title">
             <a:extLst xmlns:a="http://schemas.openxmlformats.org/drawingml/2006/main">
               <a:ext uri="{FF2B5EF4-FFF2-40B4-BE49-F238E27FC236}">
-                <a16:creationId xmlns:a16="http://schemas.microsoft.com/office/drawing/2014/main" id="{D9792B7E-A193-4B12-9170-F58C2DF4E4CE}"/>
+                <a16:creationId xmlns:a16="http://schemas.microsoft.com/office/drawing/2014/main" id="{215FBE64-4453-4793-BB43-7151B289D374}"/>
               </a:ext>
             </a:extLst>
           </p:cNvPr>
@@ -19589,7 +19562,7 @@
           <p:cNvPr id="3" name="page">
             <a:extLst xmlns:a="http://schemas.openxmlformats.org/drawingml/2006/main">
               <a:ext uri="{FF2B5EF4-FFF2-40B4-BE49-F238E27FC236}">
-                <a16:creationId xmlns:a16="http://schemas.microsoft.com/office/drawing/2014/main" id="{6EAC37AD-552D-4F51-A779-159E13326F12}"/>
+                <a16:creationId xmlns:a16="http://schemas.microsoft.com/office/drawing/2014/main" id="{F1B82342-496E-4F2A-BD13-EE8E959C7491}"/>
               </a:ext>
             </a:extLst>
           </p:cNvPr>
@@ -19745,7 +19718,7 @@
           <p:cNvPr id="4" name="body">
             <a:extLst xmlns:a="http://schemas.openxmlformats.org/drawingml/2006/main">
               <a:ext uri="{FF2B5EF4-FFF2-40B4-BE49-F238E27FC236}">
-                <a16:creationId xmlns:a16="http://schemas.microsoft.com/office/drawing/2014/main" id="{84211834-454C-4009-8FB5-B2A7DB144E97}"/>
+                <a16:creationId xmlns:a16="http://schemas.microsoft.com/office/drawing/2014/main" id="{96F5D541-FF90-4C87-945A-77CCFBECE7DC}"/>
               </a:ext>
             </a:extLst>
           </p:cNvPr>
@@ -19907,7 +19880,7 @@
           <p:cNvPr id="5" name="body">
             <a:extLst xmlns:a="http://schemas.openxmlformats.org/drawingml/2006/main">
               <a:ext uri="{FF2B5EF4-FFF2-40B4-BE49-F238E27FC236}">
-                <a16:creationId xmlns:a16="http://schemas.microsoft.com/office/drawing/2014/main" id="{1D9F02FB-1A97-4BA2-9E0E-D3A9226F81F9}"/>
+                <a16:creationId xmlns:a16="http://schemas.microsoft.com/office/drawing/2014/main" id="{F666D947-26F7-44AE-A151-D5D519321834}"/>
               </a:ext>
             </a:extLst>
           </p:cNvPr>
@@ -20069,7 +20042,7 @@
           <p:cNvPr id="6" name="body">
             <a:extLst xmlns:a="http://schemas.openxmlformats.org/drawingml/2006/main">
               <a:ext uri="{FF2B5EF4-FFF2-40B4-BE49-F238E27FC236}">
-                <a16:creationId xmlns:a16="http://schemas.microsoft.com/office/drawing/2014/main" id="{B16E2593-5747-454A-BB83-904AF3FA24CA}"/>
+                <a16:creationId xmlns:a16="http://schemas.microsoft.com/office/drawing/2014/main" id="{CA31E208-F65E-4354-889A-A52581D96D29}"/>
               </a:ext>
             </a:extLst>
           </p:cNvPr>
@@ -20231,7 +20204,7 @@
           <p:cNvPr id="7" name="body">
             <a:extLst xmlns:a="http://schemas.openxmlformats.org/drawingml/2006/main">
               <a:ext uri="{FF2B5EF4-FFF2-40B4-BE49-F238E27FC236}">
-                <a16:creationId xmlns:a16="http://schemas.microsoft.com/office/drawing/2014/main" id="{5CF7CE6D-9EEF-4114-8161-DFB51791BFF3}"/>
+                <a16:creationId xmlns:a16="http://schemas.microsoft.com/office/drawing/2014/main" id="{A5A07D54-7821-4B3F-8944-BAB4B551B474}"/>
               </a:ext>
             </a:extLst>
           </p:cNvPr>
@@ -20393,7 +20366,7 @@
           <p:cNvPr id="8" name="body">
             <a:extLst xmlns:a="http://schemas.openxmlformats.org/drawingml/2006/main">
               <a:ext uri="{FF2B5EF4-FFF2-40B4-BE49-F238E27FC236}">
-                <a16:creationId xmlns:a16="http://schemas.microsoft.com/office/drawing/2014/main" id="{163C839C-9E7C-4344-8841-EC4E96DE50D7}"/>
+                <a16:creationId xmlns:a16="http://schemas.microsoft.com/office/drawing/2014/main" id="{30DBA739-04FF-41D7-B610-CDD37039EF63}"/>
               </a:ext>
             </a:extLst>
           </p:cNvPr>
@@ -20555,7 +20528,7 @@
           <p:cNvPr id="9" name="body">
             <a:extLst xmlns:a="http://schemas.openxmlformats.org/drawingml/2006/main">
               <a:ext uri="{FF2B5EF4-FFF2-40B4-BE49-F238E27FC236}">
-                <a16:creationId xmlns:a16="http://schemas.microsoft.com/office/drawing/2014/main" id="{2B9EBB36-00AC-4171-978A-00873D5A4E69}"/>
+                <a16:creationId xmlns:a16="http://schemas.microsoft.com/office/drawing/2014/main" id="{83DD3B5D-3571-40D2-9018-B26FE993CB6E}"/>
               </a:ext>
             </a:extLst>
           </p:cNvPr>
@@ -20717,7 +20690,7 @@
           <p:cNvPr id="10" name="body">
             <a:extLst xmlns:a="http://schemas.openxmlformats.org/drawingml/2006/main">
               <a:ext uri="{FF2B5EF4-FFF2-40B4-BE49-F238E27FC236}">
-                <a16:creationId xmlns:a16="http://schemas.microsoft.com/office/drawing/2014/main" id="{4158E0F5-E697-4EA3-85D4-853A0A886199}"/>
+                <a16:creationId xmlns:a16="http://schemas.microsoft.com/office/drawing/2014/main" id="{CFBD1C2D-6D50-4D37-B31C-F6FE4CC2B3A0}"/>
               </a:ext>
             </a:extLst>
           </p:cNvPr>
@@ -20879,7 +20852,7 @@
           <p:cNvPr id="11" name="body">
             <a:extLst xmlns:a="http://schemas.openxmlformats.org/drawingml/2006/main">
               <a:ext uri="{FF2B5EF4-FFF2-40B4-BE49-F238E27FC236}">
-                <a16:creationId xmlns:a16="http://schemas.microsoft.com/office/drawing/2014/main" id="{5529F1FB-9F10-4DBB-8791-D26C64A6A735}"/>
+                <a16:creationId xmlns:a16="http://schemas.microsoft.com/office/drawing/2014/main" id="{EE084B08-3091-446D-BF9D-3924E79AA209}"/>
               </a:ext>
             </a:extLst>
           </p:cNvPr>
@@ -21041,7 +21014,7 @@
           <p:cNvPr id="12" name="body">
             <a:extLst xmlns:a="http://schemas.openxmlformats.org/drawingml/2006/main">
               <a:ext uri="{FF2B5EF4-FFF2-40B4-BE49-F238E27FC236}">
-                <a16:creationId xmlns:a16="http://schemas.microsoft.com/office/drawing/2014/main" id="{0B0BF8B0-2B05-41A6-A130-66BD40972170}"/>
+                <a16:creationId xmlns:a16="http://schemas.microsoft.com/office/drawing/2014/main" id="{B9828D1D-097A-48FA-9502-D656409CC0BE}"/>
               </a:ext>
             </a:extLst>
           </p:cNvPr>
@@ -21193,7 +21166,7 @@
                 <a:ea typeface="Be Vietnam Pro"/>
                 <a:cs typeface="Be Vietnam Pro"/>
               </a:rPr>
-              <a:t>Supabase Storage in the demo. IPFS/Pinata support in code.</a:t>
+              <a:t>Private document storage. SHA-256 fingerprint on-chain.</a:t>
             </a:r>
           </a:p>
         </p:txBody>
@@ -21203,7 +21176,7 @@
           <p:cNvPr id="13" name="body">
             <a:extLst xmlns:a="http://schemas.openxmlformats.org/drawingml/2006/main">
               <a:ext uri="{FF2B5EF4-FFF2-40B4-BE49-F238E27FC236}">
-                <a16:creationId xmlns:a16="http://schemas.microsoft.com/office/drawing/2014/main" id="{D8EC62A6-7B95-40BA-B22B-FCC2D8D0BBE7}"/>
+                <a16:creationId xmlns:a16="http://schemas.microsoft.com/office/drawing/2014/main" id="{3192C041-B42E-4A2F-A78B-E9245CC2A854}"/>
               </a:ext>
             </a:extLst>
           </p:cNvPr>
@@ -21365,7 +21338,7 @@
           <p:cNvPr id="14" name="body">
             <a:extLst xmlns:a="http://schemas.openxmlformats.org/drawingml/2006/main">
               <a:ext uri="{FF2B5EF4-FFF2-40B4-BE49-F238E27FC236}">
-                <a16:creationId xmlns:a16="http://schemas.microsoft.com/office/drawing/2014/main" id="{9E7641A0-7BC9-4375-937D-E373983F402D}"/>
+                <a16:creationId xmlns:a16="http://schemas.microsoft.com/office/drawing/2014/main" id="{36749EAF-03F7-4029-9A14-BE84DD258F9E}"/>
               </a:ext>
             </a:extLst>
           </p:cNvPr>
@@ -21527,7 +21500,7 @@
           <p:cNvPr id="15" name="body">
             <a:extLst xmlns:a="http://schemas.openxmlformats.org/drawingml/2006/main">
               <a:ext uri="{FF2B5EF4-FFF2-40B4-BE49-F238E27FC236}">
-                <a16:creationId xmlns:a16="http://schemas.microsoft.com/office/drawing/2014/main" id="{497C7371-3126-40C8-9B52-BB3E84CA2FC0}"/>
+                <a16:creationId xmlns:a16="http://schemas.microsoft.com/office/drawing/2014/main" id="{5B9A10EB-CD6D-4B9F-8DB8-569068A7A66A}"/>
               </a:ext>
             </a:extLst>
           </p:cNvPr>
@@ -21687,7 +21660,7 @@
     </p:spTree>
     <p:extLst>
       <p:ext uri="{BB962C8B-B14F-4D97-AF65-F5344CB8AC3E}">
-        <p14:creationId xmlns:p14="http://schemas.microsoft.com/office/powerpoint/2010/main" val="1512353081"/>
+        <p14:creationId xmlns:p14="http://schemas.microsoft.com/office/powerpoint/2010/main" val="1998084189"/>
       </p:ext>
     </p:extLst>
   </p:cSld>
@@ -21718,7 +21691,7 @@
           <p:cNvPr id="11" name="">
             <a:extLst xmlns:a="http://schemas.openxmlformats.org/drawingml/2006/main">
               <a:ext uri="{FF2B5EF4-FFF2-40B4-BE49-F238E27FC236}">
-                <a16:creationId xmlns:a16="http://schemas.microsoft.com/office/drawing/2014/main" id="{2338E385-1837-4024-8E1F-192DA0A33F0C}"/>
+                <a16:creationId xmlns:a16="http://schemas.microsoft.com/office/drawing/2014/main" id="{24C6894E-15CE-4021-A54B-E88DB5187F7F}"/>
               </a:ext>
             </a:extLst>
           </p:cNvPr>
@@ -21728,10 +21701,10 @@
           <p:nvPr/>
         </p:nvPicPr>
         <p:blipFill>
-          <a:blip xmlns:r="http://schemas.openxmlformats.org/officeDocument/2006/relationships" xmlns:a="http://schemas.openxmlformats.org/drawingml/2006/main" r:embed="R0922117a9d8e4c14">
+          <a:blip xmlns:r="http://schemas.openxmlformats.org/officeDocument/2006/relationships" xmlns:a="http://schemas.openxmlformats.org/drawingml/2006/main" r:embed="Rbdd72a7d10454159">
             <a:extLst>
               <a:ext uri="{96DAC541-7B7A-43D3-8B79-37D633B846F1}">
-                <asvg:svgBlip xmlns:asvg="http://schemas.microsoft.com/office/drawing/2016/SVG/main" r:embed="Rc4e4e2fa35334437"/>
+                <asvg:svgBlip xmlns:asvg="http://schemas.microsoft.com/office/drawing/2016/SVG/main" r:embed="Rede22dc27b7842ad"/>
               </a:ext>
             </a:extLst>
           </a:blip>
@@ -21752,7 +21725,7 @@
           <p:cNvPr id="2" name="title">
             <a:extLst xmlns:a="http://schemas.openxmlformats.org/drawingml/2006/main">
               <a:ext uri="{FF2B5EF4-FFF2-40B4-BE49-F238E27FC236}">
-                <a16:creationId xmlns:a16="http://schemas.microsoft.com/office/drawing/2014/main" id="{15F770F3-6136-4FAD-8DF8-BA61ADEAB2D9}"/>
+                <a16:creationId xmlns:a16="http://schemas.microsoft.com/office/drawing/2014/main" id="{814C5DBB-47A4-4B12-896A-3E01531860BD}"/>
               </a:ext>
             </a:extLst>
           </p:cNvPr>
@@ -21914,7 +21887,7 @@
           <p:cNvPr id="3" name="page">
             <a:extLst xmlns:a="http://schemas.openxmlformats.org/drawingml/2006/main">
               <a:ext uri="{FF2B5EF4-FFF2-40B4-BE49-F238E27FC236}">
-                <a16:creationId xmlns:a16="http://schemas.microsoft.com/office/drawing/2014/main" id="{4E0E9D3A-72EE-49A3-B8D4-538434A9E28C}"/>
+                <a16:creationId xmlns:a16="http://schemas.microsoft.com/office/drawing/2014/main" id="{37989087-40A6-4F95-AA1B-9C16CC7AF9B3}"/>
               </a:ext>
             </a:extLst>
           </p:cNvPr>
@@ -22070,7 +22043,7 @@
           <p:cNvPr id="4" name="body">
             <a:extLst xmlns:a="http://schemas.openxmlformats.org/drawingml/2006/main">
               <a:ext uri="{FF2B5EF4-FFF2-40B4-BE49-F238E27FC236}">
-                <a16:creationId xmlns:a16="http://schemas.microsoft.com/office/drawing/2014/main" id="{8433E757-0FB2-4467-BF57-C50CB24C550E}"/>
+                <a16:creationId xmlns:a16="http://schemas.microsoft.com/office/drawing/2014/main" id="{0EC6E785-EFA9-4760-A095-00D279BBBA49}"/>
               </a:ext>
             </a:extLst>
           </p:cNvPr>
@@ -22232,7 +22205,7 @@
           <p:cNvPr id="5" name="body">
             <a:extLst xmlns:a="http://schemas.openxmlformats.org/drawingml/2006/main">
               <a:ext uri="{FF2B5EF4-FFF2-40B4-BE49-F238E27FC236}">
-                <a16:creationId xmlns:a16="http://schemas.microsoft.com/office/drawing/2014/main" id="{8CAFF3CE-FE70-4705-A2B7-180597E64EAE}"/>
+                <a16:creationId xmlns:a16="http://schemas.microsoft.com/office/drawing/2014/main" id="{51F58C0B-6DC7-4448-9B7F-C3EF942BFCE3}"/>
               </a:ext>
             </a:extLst>
           </p:cNvPr>
@@ -22394,7 +22367,7 @@
           <p:cNvPr id="6" name="body">
             <a:extLst xmlns:a="http://schemas.openxmlformats.org/drawingml/2006/main">
               <a:ext uri="{FF2B5EF4-FFF2-40B4-BE49-F238E27FC236}">
-                <a16:creationId xmlns:a16="http://schemas.microsoft.com/office/drawing/2014/main" id="{293F6767-6B81-4B8C-AB01-081D702D1FDF}"/>
+                <a16:creationId xmlns:a16="http://schemas.microsoft.com/office/drawing/2014/main" id="{A8D51D7F-D607-49D5-88A6-A26A7010D816}"/>
               </a:ext>
             </a:extLst>
           </p:cNvPr>
@@ -22610,7 +22583,7 @@
           <p:cNvPr id="7" name="body">
             <a:extLst xmlns:a="http://schemas.openxmlformats.org/drawingml/2006/main">
               <a:ext uri="{FF2B5EF4-FFF2-40B4-BE49-F238E27FC236}">
-                <a16:creationId xmlns:a16="http://schemas.microsoft.com/office/drawing/2014/main" id="{F9EAED9E-CB2F-45B2-B702-3557DFFBF6DE}"/>
+                <a16:creationId xmlns:a16="http://schemas.microsoft.com/office/drawing/2014/main" id="{ABC3FE11-9392-41BE-A4FC-73AC52B94476}"/>
               </a:ext>
             </a:extLst>
           </p:cNvPr>
@@ -22772,7 +22745,7 @@
           <p:cNvPr id="8" name="body">
             <a:extLst xmlns:a="http://schemas.openxmlformats.org/drawingml/2006/main">
               <a:ext uri="{FF2B5EF4-FFF2-40B4-BE49-F238E27FC236}">
-                <a16:creationId xmlns:a16="http://schemas.microsoft.com/office/drawing/2014/main" id="{B972096B-E30E-4895-9E27-23432F2F70BC}"/>
+                <a16:creationId xmlns:a16="http://schemas.microsoft.com/office/drawing/2014/main" id="{36698F4F-50BF-41B4-91F7-B30983672142}"/>
               </a:ext>
             </a:extLst>
           </p:cNvPr>
@@ -22934,7 +22907,7 @@
           <p:cNvPr id="9" name="body">
             <a:extLst xmlns:a="http://schemas.openxmlformats.org/drawingml/2006/main">
               <a:ext uri="{FF2B5EF4-FFF2-40B4-BE49-F238E27FC236}">
-                <a16:creationId xmlns:a16="http://schemas.microsoft.com/office/drawing/2014/main" id="{ED9514D0-46D0-4AE6-8720-943AB3416050}"/>
+                <a16:creationId xmlns:a16="http://schemas.microsoft.com/office/drawing/2014/main" id="{2069A962-B65A-4DFC-AD10-34742590E54B}"/>
               </a:ext>
             </a:extLst>
           </p:cNvPr>
@@ -23150,7 +23123,7 @@
           <p:cNvPr id="10" name="source-note">
             <a:extLst xmlns:a="http://schemas.openxmlformats.org/drawingml/2006/main">
               <a:ext uri="{FF2B5EF4-FFF2-40B4-BE49-F238E27FC236}">
-                <a16:creationId xmlns:a16="http://schemas.microsoft.com/office/drawing/2014/main" id="{D1F42FB2-C6A7-4243-8365-882FBDECF7DF}"/>
+                <a16:creationId xmlns:a16="http://schemas.microsoft.com/office/drawing/2014/main" id="{5B895D0A-065F-48B2-940F-41E5C4EEDC66}"/>
               </a:ext>
             </a:extLst>
           </p:cNvPr>
@@ -23310,7 +23283,7 @@
     </p:spTree>
     <p:extLst>
       <p:ext uri="{BB962C8B-B14F-4D97-AF65-F5344CB8AC3E}">
-        <p14:creationId xmlns:p14="http://schemas.microsoft.com/office/powerpoint/2010/main" val="787760996"/>
+        <p14:creationId xmlns:p14="http://schemas.microsoft.com/office/powerpoint/2010/main" val="45166593"/>
       </p:ext>
     </p:extLst>
   </p:cSld>

</xml_diff>